<commit_message>
Revise BI symbol variations: fewer dots, keep v2 tree silhouette (4 options)
Co-Authored-By: Claude Sonnet 5.5 <noreply@anthropic.com>
Claude-Session: https://claude.ai/code/session_01XSVwnKProgLsAGnFXzc9nT
</commit_message>
<xml_diff>
--- a/bi/zambia-variations-v3/plant-zambia-bi-variations-v3.pptx
+++ b/bi/zambia-variations-v3/plant-zambia-bi-variations-v3.pptx
@@ -13,10 +13,9 @@
     <p:sldId id="261" r:id="rId7"/>
     <p:sldId id="262" r:id="rId8"/>
     <p:sldId id="263" r:id="rId9"/>
-    <p:sldId id="264" r:id="rId10"/>
   </p:sldIdLst>
   <p:notesMasterIdLst>
-    <p:notesMasterId r:id="rId11"/>
+    <p:notesMasterId r:id="rId10"/>
   </p:notesMasterIdLst>
   <p:sldSz cx="9144000" cy="5143500"/>
   <p:notesSz cx="5143500" cy="9144000"/>
@@ -1150,94 +1149,6 @@
             <a:fld id="{F7021451-1387-4CA6-816F-3879F97B5CBC}" type="slidenum">
               <a:rPr lang="en-US"/>
               <a:t>8</a:t>
-            </a:fld>
-            <a:endParaRPr lang="en-US"/>
-          </a:p>
-        </p:txBody>
-      </p:sp>
-    </p:spTree>
-    <p:extLst>
-      <p:ext uri="{BB962C8B-B14F-4D97-AF65-F5344CB8AC3E}">
-        <p14:creationId xmlns:p14="http://schemas.microsoft.com/office/powerpoint/2010/main" val="1024086991"/>
-      </p:ext>
-    </p:extLst>
-  </p:cSld>
-  <p:clrMapOvr>
-    <a:masterClrMapping/>
-  </p:clrMapOvr>
-</p:notes>
-</file>
-
-<file path=ppt/notesSlides/notesSlide9.xml><?xml version="1.0" encoding="utf-8"?>
-<p:notes xmlns:a="http://schemas.openxmlformats.org/drawingml/2006/main" xmlns:r="http://schemas.openxmlformats.org/officeDocument/2006/relationships" xmlns:p="http://schemas.openxmlformats.org/presentationml/2006/main">
-  <p:cSld>
-    <p:spTree>
-      <p:nvGrpSpPr>
-        <p:cNvPr id="1" name=""/>
-        <p:cNvGrpSpPr/>
-        <p:nvPr/>
-      </p:nvGrpSpPr>
-      <p:grpSpPr>
-        <a:xfrm>
-          <a:off x="0" y="0"/>
-          <a:ext cx="0" cy="0"/>
-          <a:chOff x="0" y="0"/>
-          <a:chExt cx="0" cy="0"/>
-        </a:xfrm>
-      </p:grpSpPr>
-      <p:sp>
-        <p:nvSpPr>
-          <p:cNvPr id="2" name="Slide Image Placeholder 1"/>
-          <p:cNvSpPr>
-            <a:spLocks noGrp="1" noRot="1" noChangeAspect="1"/>
-          </p:cNvSpPr>
-          <p:nvPr>
-            <p:ph type="sldImg"/>
-          </p:nvPr>
-        </p:nvSpPr>
-        <p:spPr/>
-      </p:sp>
-      <p:sp>
-        <p:nvSpPr>
-          <p:cNvPr id="3" name="Notes Placeholder 2"/>
-          <p:cNvSpPr>
-            <a:spLocks noGrp="1"/>
-          </p:cNvSpPr>
-          <p:nvPr>
-            <p:ph type="body" idx="1"/>
-          </p:nvPr>
-        </p:nvSpPr>
-        <p:spPr/>
-        <p:txBody>
-          <a:bodyPr/>
-          <a:lstStyle/>
-          <a:p>
-            <a:r>
-              <a:rPr lang="en-US" dirty="0"/>
-              <a:t/>
-            </a:r>
-            <a:endParaRPr lang="en-US" dirty="0"/>
-          </a:p>
-        </p:txBody>
-      </p:sp>
-      <p:sp>
-        <p:nvSpPr>
-          <p:cNvPr id="4" name="Slide Number Placeholder 3"/>
-          <p:cNvSpPr>
-            <a:spLocks noGrp="1"/>
-          </p:cNvSpPr>
-          <p:nvPr>
-            <p:ph type="sldNum" sz="quarter" idx="10"/>
-          </p:nvPr>
-        </p:nvSpPr>
-        <p:spPr/>
-        <p:txBody>
-          <a:bodyPr/>
-          <a:lstStyle/>
-          <a:p>
-            <a:fld id="{F7021451-1387-4CA6-816F-3879F97B5CBC}" type="slidenum">
-              <a:rPr lang="en-US"/>
-              <a:t>9</a:t>
             </a:fld>
             <a:endParaRPr lang="en-US"/>
           </a:p>
@@ -1589,7 +1500,7 @@
       </p:grpSpPr>
       <p:pic>
         <p:nvPicPr>
-          <p:cNvPr id="2" name="cover symbol" descr="/tmp/claude-0/-home-user-otterlee/54e04198-701a-58c9-b487-eea2ac6d4846/scratchpad/out/A_monowhite.png">    </p:cNvPr>
+          <p:cNvPr id="2" name="cover symbol" descr="/tmp/claude-0/-home-user-otterlee/54e04198-701a-58c9-b487-eea2ac6d4846/scratchpad/out2/2_monowhite.png">    </p:cNvPr>
           <p:cNvPicPr>
             <a:picLocks noChangeAspect="1"/>
           </p:cNvPicPr>
@@ -1722,7 +1633,7 @@
                 <a:ea typeface="Pretendard" pitchFamily="34" charset="-122"/>
                 <a:cs typeface="Pretendard" pitchFamily="34" charset="-120"/>
               </a:rPr>
-              <a:t>(사)산과자연의친구 · 2026. 10 · v3 (피드백 반영 5안)</a:t>
+              <a:t>(사)산과자연의친구 · 2026. 10 · v3 (피드백 반영 4안)</a:t>
             </a:r>
             <a:endParaRPr lang="en-US" sz="1100" dirty="0"/>
           </a:p>
@@ -1801,7 +1712,7 @@
       </p:sp>
       <p:pic>
         <p:nvPicPr>
-          <p:cNvPr id="3" name="v2 symbol" descr="/tmp/claude-0/-home-user-otterlee/54e04198-701a-58c9-b487-eea2ac6d4846/scratchpad/out/../in/x/ppt/media/image9.png">    </p:cNvPr>
+          <p:cNvPr id="3" name="v2 symbol" descr="/tmp/claude-0/-home-user-otterlee/54e04198-701a-58c9-b487-eea2ac6d4846/scratchpad/in/x/ppt/media/image9.png">    </p:cNvPr>
           <p:cNvPicPr>
             <a:picLocks noChangeAspect="1"/>
           </p:cNvPicPr>
@@ -2276,7 +2187,7 @@
                 <a:ea typeface="Pretendard" pitchFamily="34" charset="-122"/>
                 <a:cs typeface="Pretendard" pitchFamily="34" charset="-120"/>
               </a:rPr>
-              <a:t>5가지 변형을 만들어 나중에 택일</a:t>
+              <a:t>4가지 변형을 만들어 나중에 택일</a:t>
             </a:r>
             <a:endParaRPr lang="en-US" sz="1300" dirty="0"/>
           </a:p>
@@ -2386,7 +2297,7 @@
                 <a:ea typeface="Pretendard" pitchFamily="34" charset="-122"/>
                 <a:cs typeface="Pretendard" pitchFamily="34" charset="-120"/>
               </a:rPr>
-              <a:t>모든 안은 점 크기가 제각각이고 배치가 불규칙합니다. 가로형 로고의 글자는 v2와 같습니다.</a:t>
+              <a:t>가로형 로고의 글자는 v2와 같습니다. 심볼만 바꿨습니다.</a:t>
             </a:r>
             <a:endParaRPr lang="en-US" sz="1200" dirty="0"/>
           </a:p>
@@ -2394,7 +2305,7 @@
       </p:sp>
       <p:pic>
         <p:nvPicPr>
-          <p:cNvPr id="4" name="overview A" descr="/tmp/claude-0/-home-user-otterlee/54e04198-701a-58c9-b487-eea2ac6d4846/scratchpad/out/A_green.png">    </p:cNvPr>
+          <p:cNvPr id="4" name="overview 1" descr="/tmp/claude-0/-home-user-otterlee/54e04198-701a-58c9-b487-eea2ac6d4846/scratchpad/out2/1_green.png">    </p:cNvPr>
           <p:cNvPicPr>
             <a:picLocks noChangeAspect="1"/>
           </p:cNvPicPr>
@@ -2409,7 +2320,7 @@
         <p:spPr>
           <a:xfrm>
             <a:off x="457200" y="1371600"/>
-            <a:ext cx="1508760" cy="1508760"/>
+            <a:ext cx="1828800" cy="1828800"/>
           </a:xfrm>
           <a:prstGeom prst="rect">
             <a:avLst/>
@@ -2424,8 +2335,8 @@
         </p:nvSpPr>
         <p:spPr>
           <a:xfrm>
-            <a:off x="457200" y="3017520"/>
-            <a:ext cx="1508760" cy="457200"/>
+            <a:off x="457200" y="3337560"/>
+            <a:ext cx="1828800" cy="365760"/>
           </a:xfrm>
           <a:prstGeom prst="rect">
             <a:avLst/>
@@ -2449,7 +2360,7 @@
                 <a:ea typeface="Pretendard" pitchFamily="34" charset="-122"/>
                 <a:cs typeface="Pretendard" pitchFamily="34" charset="-120"/>
               </a:rPr>
-              <a:t>A  캐노피</a:t>
+              <a:t>1안  살짝 풀기</a:t>
             </a:r>
             <a:endParaRPr lang="en-US" sz="1200" dirty="0"/>
           </a:p>
@@ -2457,7 +2368,7 @@
       </p:sp>
       <p:pic>
         <p:nvPicPr>
-          <p:cNvPr id="6" name="overview B" descr="/tmp/claude-0/-home-user-otterlee/54e04198-701a-58c9-b487-eea2ac6d4846/scratchpad/out/B_green.png">    </p:cNvPr>
+          <p:cNvPr id="6" name="overview 2" descr="/tmp/claude-0/-home-user-otterlee/54e04198-701a-58c9-b487-eea2ac6d4846/scratchpad/out2/2_green.png">    </p:cNvPr>
           <p:cNvPicPr>
             <a:picLocks noChangeAspect="1"/>
           </p:cNvPicPr>
@@ -2471,8 +2382,8 @@
         </p:blipFill>
         <p:spPr>
           <a:xfrm>
-            <a:off x="2103120" y="1371600"/>
-            <a:ext cx="1508760" cy="1508760"/>
+            <a:off x="2560320" y="1371600"/>
+            <a:ext cx="1828800" cy="1828800"/>
           </a:xfrm>
           <a:prstGeom prst="rect">
             <a:avLst/>
@@ -2487,8 +2398,8 @@
         </p:nvSpPr>
         <p:spPr>
           <a:xfrm>
-            <a:off x="2103120" y="3017520"/>
-            <a:ext cx="1508760" cy="457200"/>
+            <a:off x="2560320" y="3337560"/>
+            <a:ext cx="1828800" cy="365760"/>
           </a:xfrm>
           <a:prstGeom prst="rect">
             <a:avLst/>
@@ -2512,7 +2423,7 @@
                 <a:ea typeface="Pretendard" pitchFamily="34" charset="-122"/>
                 <a:cs typeface="Pretendard" pitchFamily="34" charset="-120"/>
               </a:rPr>
-              <a:t>B  바람에 흩날리는 숲</a:t>
+              <a:t>2안  크기 다양</a:t>
             </a:r>
             <a:endParaRPr lang="en-US" sz="1200" dirty="0"/>
           </a:p>
@@ -2520,7 +2431,7 @@
       </p:sp>
       <p:pic>
         <p:nvPicPr>
-          <p:cNvPr id="8" name="overview C" descr="/tmp/claude-0/-home-user-otterlee/54e04198-701a-58c9-b487-eea2ac6d4846/scratchpad/out/C_green.png">    </p:cNvPr>
+          <p:cNvPr id="8" name="overview 3" descr="/tmp/claude-0/-home-user-otterlee/54e04198-701a-58c9-b487-eea2ac6d4846/scratchpad/out2/3_green.png">    </p:cNvPr>
           <p:cNvPicPr>
             <a:picLocks noChangeAspect="1"/>
           </p:cNvPicPr>
@@ -2534,8 +2445,8 @@
         </p:blipFill>
         <p:spPr>
           <a:xfrm>
-            <a:off x="3749040" y="1371600"/>
-            <a:ext cx="1508760" cy="1508760"/>
+            <a:off x="4663440" y="1371600"/>
+            <a:ext cx="1828800" cy="1828800"/>
           </a:xfrm>
           <a:prstGeom prst="rect">
             <a:avLst/>
@@ -2550,8 +2461,8 @@
         </p:nvSpPr>
         <p:spPr>
           <a:xfrm>
-            <a:off x="3749040" y="3017520"/>
-            <a:ext cx="1508760" cy="457200"/>
+            <a:off x="4663440" y="3337560"/>
+            <a:ext cx="1828800" cy="365760"/>
           </a:xfrm>
           <a:prstGeom prst="rect">
             <a:avLst/>
@@ -2575,7 +2486,7 @@
                 <a:ea typeface="Pretendard" pitchFamily="34" charset="-122"/>
                 <a:cs typeface="Pretendard" pitchFamily="34" charset="-120"/>
               </a:rPr>
-              <a:t>C  나무와 숲</a:t>
+              <a:t>3안  흩날림</a:t>
             </a:r>
             <a:endParaRPr lang="en-US" sz="1200" dirty="0"/>
           </a:p>
@@ -2583,7 +2494,7 @@
       </p:sp>
       <p:pic>
         <p:nvPicPr>
-          <p:cNvPr id="10" name="overview D" descr="/tmp/claude-0/-home-user-otterlee/54e04198-701a-58c9-b487-eea2ac6d4846/scratchpad/out/D_green.png">    </p:cNvPr>
+          <p:cNvPr id="10" name="overview 4" descr="/tmp/claude-0/-home-user-otterlee/54e04198-701a-58c9-b487-eea2ac6d4846/scratchpad/out2/4_green.png">    </p:cNvPr>
           <p:cNvPicPr>
             <a:picLocks noChangeAspect="1"/>
           </p:cNvPicPr>
@@ -2597,8 +2508,8 @@
         </p:blipFill>
         <p:spPr>
           <a:xfrm>
-            <a:off x="5394960" y="1371600"/>
-            <a:ext cx="1508760" cy="1508760"/>
+            <a:off x="6766560" y="1371600"/>
+            <a:ext cx="1828800" cy="1828800"/>
           </a:xfrm>
           <a:prstGeom prst="rect">
             <a:avLst/>
@@ -2613,8 +2524,8 @@
         </p:nvSpPr>
         <p:spPr>
           <a:xfrm>
-            <a:off x="5394960" y="3017520"/>
-            <a:ext cx="1508760" cy="457200"/>
+            <a:off x="6766560" y="3337560"/>
+            <a:ext cx="1828800" cy="365760"/>
           </a:xfrm>
           <a:prstGeom prst="rect">
             <a:avLst/>
@@ -2638,84 +2549,21 @@
                 <a:ea typeface="Pretendard" pitchFamily="34" charset="-122"/>
                 <a:cs typeface="Pretendard" pitchFamily="34" charset="-120"/>
               </a:rPr>
-              <a:t>D  자라는 나무</a:t>
+              <a:t>4안  나무와 숲</a:t>
             </a:r>
             <a:endParaRPr lang="en-US" sz="1200" dirty="0"/>
           </a:p>
         </p:txBody>
       </p:sp>
-      <p:pic>
-        <p:nvPicPr>
-          <p:cNvPr id="12" name="overview E" descr="/tmp/claude-0/-home-user-otterlee/54e04198-701a-58c9-b487-eea2ac6d4846/scratchpad/out/E_green.png">    </p:cNvPr>
-          <p:cNvPicPr>
-            <a:picLocks noChangeAspect="1"/>
-          </p:cNvPicPr>
-          <p:nvPr/>
-        </p:nvPicPr>
-        <p:blipFill>
-          <a:blip r:embed="rId5"/>
-          <a:stretch>
-            <a:fillRect/>
-          </a:stretch>
-        </p:blipFill>
-        <p:spPr>
-          <a:xfrm>
-            <a:off x="7040880" y="1371600"/>
-            <a:ext cx="1508760" cy="1508760"/>
-          </a:xfrm>
-          <a:prstGeom prst="rect">
-            <a:avLst/>
-          </a:prstGeom>
-        </p:spPr>
-      </p:pic>
-      <p:sp>
-        <p:nvSpPr>
-          <p:cNvPr id="13" name="Text 6"/>
+      <p:sp>
+        <p:nvSpPr>
+          <p:cNvPr id="12" name="Text 6"/>
           <p:cNvSpPr txBox="1"/>
           <p:nvPr/>
         </p:nvSpPr>
         <p:spPr>
           <a:xfrm>
-            <a:off x="7040880" y="3017520"/>
-            <a:ext cx="1508760" cy="457200"/>
-          </a:xfrm>
-          <a:prstGeom prst="rect">
-            <a:avLst/>
-          </a:prstGeom>
-          <a:noFill/>
-          <a:ln/>
-        </p:spPr>
-        <p:txBody>
-          <a:bodyPr wrap="square" lIns="0" tIns="0" rIns="0" bIns="0" rtlCol="0" anchor="ctr"/>
-          <a:lstStyle/>
-          <a:p>
-            <a:pPr indent="0" marL="0">
-              <a:buNone/>
-            </a:pPr>
-            <a:r>
-              <a:rPr lang="en-US" sz="1200" b="1" dirty="0">
-                <a:solidFill>
-                  <a:srgbClr val="16211C"/>
-                </a:solidFill>
-                <a:latin typeface="Pretendard" pitchFamily="34" charset="0"/>
-                <a:ea typeface="Pretendard" pitchFamily="34" charset="-122"/>
-                <a:cs typeface="Pretendard" pitchFamily="34" charset="-120"/>
-              </a:rPr>
-              <a:t>E  아카시아</a:t>
-            </a:r>
-            <a:endParaRPr lang="en-US" sz="1200" dirty="0"/>
-          </a:p>
-        </p:txBody>
-      </p:sp>
-      <p:sp>
-        <p:nvSpPr>
-          <p:cNvPr id="14" name="Text 7"/>
-          <p:cNvSpPr txBox="1"/>
-          <p:nvPr/>
-        </p:nvSpPr>
-        <p:spPr>
-          <a:xfrm>
-            <a:off x="457200" y="4023360"/>
+            <a:off x="457200" y="4114800"/>
             <a:ext cx="8229600" cy="274320"/>
           </a:xfrm>
           <a:prstGeom prst="rect">
@@ -2740,7 +2588,7 @@
                 <a:ea typeface="Pretendard" pitchFamily="34" charset="-122"/>
                 <a:cs typeface="Pretendard" pitchFamily="34" charset="-120"/>
               </a:rPr>
-              <a:t>크기 다양 · 불규칙 배치 · 가장자리는 잔점</a:t>
+              <a:t>v2(왼쪽 원본)보다 점의 크기와 위치가 자유롭지만, 나무 모양은 알아볼 수 있게 유지했습니다.</a:t>
             </a:r>
             <a:endParaRPr lang="en-US" sz="1200" dirty="0"/>
           </a:p>
@@ -2811,7 +2659,7 @@
                 <a:ea typeface="Pretendard" pitchFamily="34" charset="-122"/>
                 <a:cs typeface="Pretendard" pitchFamily="34" charset="-120"/>
               </a:rPr>
-              <a:t>안 A — 캐노피</a:t>
+              <a:t>1안 — 살짝 풀기</a:t>
             </a:r>
             <a:endParaRPr lang="en-US" sz="2000" dirty="0"/>
           </a:p>
@@ -2850,7 +2698,7 @@
                 <a:ea typeface="Pretendard" pitchFamily="34" charset="-122"/>
                 <a:cs typeface="Pretendard" pitchFamily="34" charset="-120"/>
               </a:rPr>
-              <a:t>둥근 수관. 중심은 큰 점, 가장자리는 잔점으로 흩어집니다.</a:t>
+              <a:t>v2의 나무 모양은 그대로, 점의 위치와 크기만 조금씩 흩트렸습니다.</a:t>
             </a:r>
             <a:endParaRPr lang="en-US" sz="1200" dirty="0"/>
           </a:p>
@@ -2858,7 +2706,7 @@
       </p:sp>
       <p:pic>
         <p:nvPicPr>
-          <p:cNvPr id="4" name="A green" descr="/tmp/claude-0/-home-user-otterlee/54e04198-701a-58c9-b487-eea2ac6d4846/scratchpad/out/A_green.png">    </p:cNvPr>
+          <p:cNvPr id="4" name="1 green" descr="/tmp/claude-0/-home-user-otterlee/54e04198-701a-58c9-b487-eea2ac6d4846/scratchpad/out2/1_green.png">    </p:cNvPr>
           <p:cNvPicPr>
             <a:picLocks noChangeAspect="1"/>
           </p:cNvPicPr>
@@ -2882,7 +2730,7 @@
       </p:pic>
       <p:pic>
         <p:nvPicPr>
-          <p:cNvPr id="5" name="A white" descr="/tmp/claude-0/-home-user-otterlee/54e04198-701a-58c9-b487-eea2ac6d4846/scratchpad/out/A_white.png">    </p:cNvPr>
+          <p:cNvPr id="5" name="1 white" descr="/tmp/claude-0/-home-user-otterlee/54e04198-701a-58c9-b487-eea2ac6d4846/scratchpad/out2/1_white.png">    </p:cNvPr>
           <p:cNvPicPr>
             <a:picLocks noChangeAspect="1"/>
           </p:cNvPicPr>
@@ -2906,7 +2754,7 @@
       </p:pic>
       <p:pic>
         <p:nvPicPr>
-          <p:cNvPr id="6" name="A lockup" descr="/tmp/claude-0/-home-user-otterlee/54e04198-701a-58c9-b487-eea2ac6d4846/scratchpad/out/A_lockup.png">    </p:cNvPr>
+          <p:cNvPr id="6" name="1 lockup" descr="/tmp/claude-0/-home-user-otterlee/54e04198-701a-58c9-b487-eea2ac6d4846/scratchpad/out2/1_lockup.png">    </p:cNvPr>
           <p:cNvPicPr>
             <a:picLocks noChangeAspect="1"/>
           </p:cNvPicPr>
@@ -2930,7 +2778,7 @@
       </p:pic>
       <p:pic>
         <p:nvPicPr>
-          <p:cNvPr id="7" name="A size0" descr="/tmp/claude-0/-home-user-otterlee/54e04198-701a-58c9-b487-eea2ac6d4846/scratchpad/out/A_white.png">    </p:cNvPr>
+          <p:cNvPr id="7" name="1 size0" descr="/tmp/claude-0/-home-user-otterlee/54e04198-701a-58c9-b487-eea2ac6d4846/scratchpad/out2/1_white.png">    </p:cNvPr>
           <p:cNvPicPr>
             <a:picLocks noChangeAspect="1"/>
           </p:cNvPicPr>
@@ -2954,7 +2802,7 @@
       </p:pic>
       <p:pic>
         <p:nvPicPr>
-          <p:cNvPr id="8" name="A size1" descr="/tmp/claude-0/-home-user-otterlee/54e04198-701a-58c9-b487-eea2ac6d4846/scratchpad/out/A_white.png">    </p:cNvPr>
+          <p:cNvPr id="8" name="1 size1" descr="/tmp/claude-0/-home-user-otterlee/54e04198-701a-58c9-b487-eea2ac6d4846/scratchpad/out2/1_white.png">    </p:cNvPr>
           <p:cNvPicPr>
             <a:picLocks noChangeAspect="1"/>
           </p:cNvPicPr>
@@ -2978,7 +2826,7 @@
       </p:pic>
       <p:pic>
         <p:nvPicPr>
-          <p:cNvPr id="9" name="A size2" descr="/tmp/claude-0/-home-user-otterlee/54e04198-701a-58c9-b487-eea2ac6d4846/scratchpad/out/A_white.png">    </p:cNvPr>
+          <p:cNvPr id="9" name="1 size2" descr="/tmp/claude-0/-home-user-otterlee/54e04198-701a-58c9-b487-eea2ac6d4846/scratchpad/out2/1_white.png">    </p:cNvPr>
           <p:cNvPicPr>
             <a:picLocks noChangeAspect="1"/>
           </p:cNvPicPr>
@@ -3099,7 +2947,7 @@
                 <a:ea typeface="Pretendard" pitchFamily="34" charset="-122"/>
                 <a:cs typeface="Pretendard" pitchFamily="34" charset="-120"/>
               </a:rPr>
-              <a:t>가장 기본에 가까운 안. 기존 심볼의 인상을 가장 많이 이어갑니다.</a:t>
+              <a:t>가장 안전한 안. 점 25개로 기존 심볼의 인상을 그대로 이어갑니다.</a:t>
             </a:r>
             <a:endParaRPr lang="en-US" sz="1300" dirty="0"/>
           </a:p>
@@ -3170,7 +3018,7 @@
                 <a:ea typeface="Pretendard" pitchFamily="34" charset="-122"/>
                 <a:cs typeface="Pretendard" pitchFamily="34" charset="-120"/>
               </a:rPr>
-              <a:t>안 B — 바람에 흩날리는 숲</a:t>
+              <a:t>2안 — 크기 다양</a:t>
             </a:r>
             <a:endParaRPr lang="en-US" sz="2000" dirty="0"/>
           </a:p>
@@ -3209,7 +3057,7 @@
                 <a:ea typeface="Pretendard" pitchFamily="34" charset="-122"/>
                 <a:cs typeface="Pretendard" pitchFamily="34" charset="-120"/>
               </a:rPr>
-              <a:t>수관 오른쪽이 열리며 점이 바람에 날리듯 흩어집니다.</a:t>
+              <a:t>같은 마름모 실루엣 안에서 큰 점과 작은 점을 섞었습니다.</a:t>
             </a:r>
             <a:endParaRPr lang="en-US" sz="1200" dirty="0"/>
           </a:p>
@@ -3217,7 +3065,7 @@
       </p:sp>
       <p:pic>
         <p:nvPicPr>
-          <p:cNvPr id="4" name="B green" descr="/tmp/claude-0/-home-user-otterlee/54e04198-701a-58c9-b487-eea2ac6d4846/scratchpad/out/B_green.png">    </p:cNvPr>
+          <p:cNvPr id="4" name="2 green" descr="/tmp/claude-0/-home-user-otterlee/54e04198-701a-58c9-b487-eea2ac6d4846/scratchpad/out2/2_green.png">    </p:cNvPr>
           <p:cNvPicPr>
             <a:picLocks noChangeAspect="1"/>
           </p:cNvPicPr>
@@ -3241,7 +3089,7 @@
       </p:pic>
       <p:pic>
         <p:nvPicPr>
-          <p:cNvPr id="5" name="B white" descr="/tmp/claude-0/-home-user-otterlee/54e04198-701a-58c9-b487-eea2ac6d4846/scratchpad/out/B_white.png">    </p:cNvPr>
+          <p:cNvPr id="5" name="2 white" descr="/tmp/claude-0/-home-user-otterlee/54e04198-701a-58c9-b487-eea2ac6d4846/scratchpad/out2/2_white.png">    </p:cNvPr>
           <p:cNvPicPr>
             <a:picLocks noChangeAspect="1"/>
           </p:cNvPicPr>
@@ -3265,7 +3113,7 @@
       </p:pic>
       <p:pic>
         <p:nvPicPr>
-          <p:cNvPr id="6" name="B lockup" descr="/tmp/claude-0/-home-user-otterlee/54e04198-701a-58c9-b487-eea2ac6d4846/scratchpad/out/B_lockup.png">    </p:cNvPr>
+          <p:cNvPr id="6" name="2 lockup" descr="/tmp/claude-0/-home-user-otterlee/54e04198-701a-58c9-b487-eea2ac6d4846/scratchpad/out2/2_lockup.png">    </p:cNvPr>
           <p:cNvPicPr>
             <a:picLocks noChangeAspect="1"/>
           </p:cNvPicPr>
@@ -3289,7 +3137,7 @@
       </p:pic>
       <p:pic>
         <p:nvPicPr>
-          <p:cNvPr id="7" name="B size0" descr="/tmp/claude-0/-home-user-otterlee/54e04198-701a-58c9-b487-eea2ac6d4846/scratchpad/out/B_white.png">    </p:cNvPr>
+          <p:cNvPr id="7" name="2 size0" descr="/tmp/claude-0/-home-user-otterlee/54e04198-701a-58c9-b487-eea2ac6d4846/scratchpad/out2/2_white.png">    </p:cNvPr>
           <p:cNvPicPr>
             <a:picLocks noChangeAspect="1"/>
           </p:cNvPicPr>
@@ -3313,7 +3161,7 @@
       </p:pic>
       <p:pic>
         <p:nvPicPr>
-          <p:cNvPr id="8" name="B size1" descr="/tmp/claude-0/-home-user-otterlee/54e04198-701a-58c9-b487-eea2ac6d4846/scratchpad/out/B_white.png">    </p:cNvPr>
+          <p:cNvPr id="8" name="2 size1" descr="/tmp/claude-0/-home-user-otterlee/54e04198-701a-58c9-b487-eea2ac6d4846/scratchpad/out2/2_white.png">    </p:cNvPr>
           <p:cNvPicPr>
             <a:picLocks noChangeAspect="1"/>
           </p:cNvPicPr>
@@ -3337,7 +3185,7 @@
       </p:pic>
       <p:pic>
         <p:nvPicPr>
-          <p:cNvPr id="9" name="B size2" descr="/tmp/claude-0/-home-user-otterlee/54e04198-701a-58c9-b487-eea2ac6d4846/scratchpad/out/B_white.png">    </p:cNvPr>
+          <p:cNvPr id="9" name="2 size2" descr="/tmp/claude-0/-home-user-otterlee/54e04198-701a-58c9-b487-eea2ac6d4846/scratchpad/out2/2_white.png">    </p:cNvPr>
           <p:cNvPicPr>
             <a:picLocks noChangeAspect="1"/>
           </p:cNvPicPr>
@@ -3458,7 +3306,7 @@
                 <a:ea typeface="Pretendard" pitchFamily="34" charset="-122"/>
                 <a:cs typeface="Pretendard" pitchFamily="34" charset="-120"/>
               </a:rPr>
-              <a:t>움직임과 확산의 느낌. 점이 퍼져가는 캠페인의 성격과 맞습니다.</a:t>
+              <a:t>도식적인 느낌이 줄고 자연스럽습니다. 점 45개 안팎입니다.</a:t>
             </a:r>
             <a:endParaRPr lang="en-US" sz="1300" dirty="0"/>
           </a:p>
@@ -3529,7 +3377,7 @@
                 <a:ea typeface="Pretendard" pitchFamily="34" charset="-122"/>
                 <a:cs typeface="Pretendard" pitchFamily="34" charset="-120"/>
               </a:rPr>
-              <a:t>안 C — 나무와 숲</a:t>
+              <a:t>3안 — 흩날림</a:t>
             </a:r>
             <a:endParaRPr lang="en-US" sz="2000" dirty="0"/>
           </a:p>
@@ -3568,7 +3416,7 @@
                 <a:ea typeface="Pretendard" pitchFamily="34" charset="-122"/>
                 <a:cs typeface="Pretendard" pitchFamily="34" charset="-120"/>
               </a:rPr>
-              <a:t>큰 나무 한 그루와 이웃한 나무들이 어우러진 작은 숲.</a:t>
+              <a:t>2안에 가장자리의 점 몇 개가 바람에 날려 떨어져 나가는 모습을 더했습니다.</a:t>
             </a:r>
             <a:endParaRPr lang="en-US" sz="1200" dirty="0"/>
           </a:p>
@@ -3576,7 +3424,7 @@
       </p:sp>
       <p:pic>
         <p:nvPicPr>
-          <p:cNvPr id="4" name="C green" descr="/tmp/claude-0/-home-user-otterlee/54e04198-701a-58c9-b487-eea2ac6d4846/scratchpad/out/C_green.png">    </p:cNvPr>
+          <p:cNvPr id="4" name="3 green" descr="/tmp/claude-0/-home-user-otterlee/54e04198-701a-58c9-b487-eea2ac6d4846/scratchpad/out2/3_green.png">    </p:cNvPr>
           <p:cNvPicPr>
             <a:picLocks noChangeAspect="1"/>
           </p:cNvPicPr>
@@ -3600,7 +3448,7 @@
       </p:pic>
       <p:pic>
         <p:nvPicPr>
-          <p:cNvPr id="5" name="C white" descr="/tmp/claude-0/-home-user-otterlee/54e04198-701a-58c9-b487-eea2ac6d4846/scratchpad/out/C_white.png">    </p:cNvPr>
+          <p:cNvPr id="5" name="3 white" descr="/tmp/claude-0/-home-user-otterlee/54e04198-701a-58c9-b487-eea2ac6d4846/scratchpad/out2/3_white.png">    </p:cNvPr>
           <p:cNvPicPr>
             <a:picLocks noChangeAspect="1"/>
           </p:cNvPicPr>
@@ -3624,7 +3472,7 @@
       </p:pic>
       <p:pic>
         <p:nvPicPr>
-          <p:cNvPr id="6" name="C lockup" descr="/tmp/claude-0/-home-user-otterlee/54e04198-701a-58c9-b487-eea2ac6d4846/scratchpad/out/C_lockup.png">    </p:cNvPr>
+          <p:cNvPr id="6" name="3 lockup" descr="/tmp/claude-0/-home-user-otterlee/54e04198-701a-58c9-b487-eea2ac6d4846/scratchpad/out2/3_lockup.png">    </p:cNvPr>
           <p:cNvPicPr>
             <a:picLocks noChangeAspect="1"/>
           </p:cNvPicPr>
@@ -3648,7 +3496,7 @@
       </p:pic>
       <p:pic>
         <p:nvPicPr>
-          <p:cNvPr id="7" name="C size0" descr="/tmp/claude-0/-home-user-otterlee/54e04198-701a-58c9-b487-eea2ac6d4846/scratchpad/out/C_white.png">    </p:cNvPr>
+          <p:cNvPr id="7" name="3 size0" descr="/tmp/claude-0/-home-user-otterlee/54e04198-701a-58c9-b487-eea2ac6d4846/scratchpad/out2/3_white.png">    </p:cNvPr>
           <p:cNvPicPr>
             <a:picLocks noChangeAspect="1"/>
           </p:cNvPicPr>
@@ -3672,7 +3520,7 @@
       </p:pic>
       <p:pic>
         <p:nvPicPr>
-          <p:cNvPr id="8" name="C size1" descr="/tmp/claude-0/-home-user-otterlee/54e04198-701a-58c9-b487-eea2ac6d4846/scratchpad/out/C_white.png">    </p:cNvPr>
+          <p:cNvPr id="8" name="3 size1" descr="/tmp/claude-0/-home-user-otterlee/54e04198-701a-58c9-b487-eea2ac6d4846/scratchpad/out2/3_white.png">    </p:cNvPr>
           <p:cNvPicPr>
             <a:picLocks noChangeAspect="1"/>
           </p:cNvPicPr>
@@ -3696,7 +3544,7 @@
       </p:pic>
       <p:pic>
         <p:nvPicPr>
-          <p:cNvPr id="9" name="C size2" descr="/tmp/claude-0/-home-user-otterlee/54e04198-701a-58c9-b487-eea2ac6d4846/scratchpad/out/C_white.png">    </p:cNvPr>
+          <p:cNvPr id="9" name="3 size2" descr="/tmp/claude-0/-home-user-otterlee/54e04198-701a-58c9-b487-eea2ac6d4846/scratchpad/out2/3_white.png">    </p:cNvPr>
           <p:cNvPicPr>
             <a:picLocks noChangeAspect="1"/>
           </p:cNvPicPr>
@@ -3817,7 +3665,7 @@
                 <a:ea typeface="Pretendard" pitchFamily="34" charset="-122"/>
                 <a:cs typeface="Pretendard" pitchFamily="34" charset="-120"/>
               </a:rPr>
-              <a:t>“나무에서 숲으로”라는 서사를 한 심볼에 담습니다. 가장 복잡합니다.</a:t>
+              <a:t>움직임과 확산의 느낌. 점이 퍼져가는 캠페인의 성격과 맞습니다.</a:t>
             </a:r>
             <a:endParaRPr lang="en-US" sz="1300" dirty="0"/>
           </a:p>
@@ -3888,7 +3736,7 @@
                 <a:ea typeface="Pretendard" pitchFamily="34" charset="-122"/>
                 <a:cs typeface="Pretendard" pitchFamily="34" charset="-120"/>
               </a:rPr>
-              <a:t>안 D — 자라는 나무</a:t>
+              <a:t>4안 — 나무와 숲</a:t>
             </a:r>
             <a:endParaRPr lang="en-US" sz="2000" dirty="0"/>
           </a:p>
@@ -3927,7 +3775,7 @@
                 <a:ea typeface="Pretendard" pitchFamily="34" charset="-122"/>
                 <a:cs typeface="Pretendard" pitchFamily="34" charset="-120"/>
               </a:rPr>
-              <a:t>아래는 큰 점, 위로 갈수록 작은 점. 아래에서 위로 자라는 흐름.</a:t>
+              <a:t>같은 모양의 나무 세 그루. 큰 나무 하나와 작은 나무 둘이 모여 숲이 됩니다.</a:t>
             </a:r>
             <a:endParaRPr lang="en-US" sz="1200" dirty="0"/>
           </a:p>
@@ -3935,7 +3783,7 @@
       </p:sp>
       <p:pic>
         <p:nvPicPr>
-          <p:cNvPr id="4" name="D green" descr="/tmp/claude-0/-home-user-otterlee/54e04198-701a-58c9-b487-eea2ac6d4846/scratchpad/out/D_green.png">    </p:cNvPr>
+          <p:cNvPr id="4" name="4 green" descr="/tmp/claude-0/-home-user-otterlee/54e04198-701a-58c9-b487-eea2ac6d4846/scratchpad/out2/4_green.png">    </p:cNvPr>
           <p:cNvPicPr>
             <a:picLocks noChangeAspect="1"/>
           </p:cNvPicPr>
@@ -3959,7 +3807,7 @@
       </p:pic>
       <p:pic>
         <p:nvPicPr>
-          <p:cNvPr id="5" name="D white" descr="/tmp/claude-0/-home-user-otterlee/54e04198-701a-58c9-b487-eea2ac6d4846/scratchpad/out/D_white.png">    </p:cNvPr>
+          <p:cNvPr id="5" name="4 white" descr="/tmp/claude-0/-home-user-otterlee/54e04198-701a-58c9-b487-eea2ac6d4846/scratchpad/out2/4_white.png">    </p:cNvPr>
           <p:cNvPicPr>
             <a:picLocks noChangeAspect="1"/>
           </p:cNvPicPr>
@@ -3983,7 +3831,7 @@
       </p:pic>
       <p:pic>
         <p:nvPicPr>
-          <p:cNvPr id="6" name="D lockup" descr="/tmp/claude-0/-home-user-otterlee/54e04198-701a-58c9-b487-eea2ac6d4846/scratchpad/out/D_lockup.png">    </p:cNvPr>
+          <p:cNvPr id="6" name="4 lockup" descr="/tmp/claude-0/-home-user-otterlee/54e04198-701a-58c9-b487-eea2ac6d4846/scratchpad/out2/4_lockup.png">    </p:cNvPr>
           <p:cNvPicPr>
             <a:picLocks noChangeAspect="1"/>
           </p:cNvPicPr>
@@ -4007,7 +3855,7 @@
       </p:pic>
       <p:pic>
         <p:nvPicPr>
-          <p:cNvPr id="7" name="D size0" descr="/tmp/claude-0/-home-user-otterlee/54e04198-701a-58c9-b487-eea2ac6d4846/scratchpad/out/D_white.png">    </p:cNvPr>
+          <p:cNvPr id="7" name="4 size0" descr="/tmp/claude-0/-home-user-otterlee/54e04198-701a-58c9-b487-eea2ac6d4846/scratchpad/out2/4_white.png">    </p:cNvPr>
           <p:cNvPicPr>
             <a:picLocks noChangeAspect="1"/>
           </p:cNvPicPr>
@@ -4031,7 +3879,7 @@
       </p:pic>
       <p:pic>
         <p:nvPicPr>
-          <p:cNvPr id="8" name="D size1" descr="/tmp/claude-0/-home-user-otterlee/54e04198-701a-58c9-b487-eea2ac6d4846/scratchpad/out/D_white.png">    </p:cNvPr>
+          <p:cNvPr id="8" name="4 size1" descr="/tmp/claude-0/-home-user-otterlee/54e04198-701a-58c9-b487-eea2ac6d4846/scratchpad/out2/4_white.png">    </p:cNvPr>
           <p:cNvPicPr>
             <a:picLocks noChangeAspect="1"/>
           </p:cNvPicPr>
@@ -4055,7 +3903,7 @@
       </p:pic>
       <p:pic>
         <p:nvPicPr>
-          <p:cNvPr id="9" name="D size2" descr="/tmp/claude-0/-home-user-otterlee/54e04198-701a-58c9-b487-eea2ac6d4846/scratchpad/out/D_white.png">    </p:cNvPr>
+          <p:cNvPr id="9" name="4 size2" descr="/tmp/claude-0/-home-user-otterlee/54e04198-701a-58c9-b487-eea2ac6d4846/scratchpad/out2/4_white.png">    </p:cNvPr>
           <p:cNvPicPr>
             <a:picLocks noChangeAspect="1"/>
           </p:cNvPicPr>
@@ -4176,7 +4024,7 @@
                 <a:ea typeface="Pretendard" pitchFamily="34" charset="-122"/>
                 <a:cs typeface="Pretendard" pitchFamily="34" charset="-120"/>
               </a:rPr>
-              <a:t>성장의 방향성이 보입니다. 수관이 풍선처럼 읽힐 수 있어 확인이 필요합니다.</a:t>
+              <a:t>나무 한 그루에서 숲으로 가는 이야기를 담습니다. 작게 줄이면 점이 뭉칠 수 있어 확인이 필요합니다.</a:t>
             </a:r>
             <a:endParaRPr lang="en-US" sz="1300" dirty="0"/>
           </a:p>
@@ -4193,365 +4041,6 @@
 <file path=ppt/slides/slide8.xml><?xml version="1.0" encoding="utf-8"?>
 <p:sld xmlns:a="http://schemas.openxmlformats.org/drawingml/2006/main" xmlns:r="http://schemas.openxmlformats.org/officeDocument/2006/relationships" xmlns:p="http://schemas.openxmlformats.org/presentationml/2006/main">
   <p:cSld name="Slide 8">
-    <p:bg>
-      <p:bgPr>
-        <a:solidFill>
-          <a:srgbClr val="FFFFFF"/>
-        </a:solidFill>
-      </p:bgPr>
-    </p:bg>
-    <p:spTree>
-      <p:nvGrpSpPr>
-        <p:cNvPr id="1" name=""/>
-        <p:cNvGrpSpPr/>
-        <p:nvPr/>
-      </p:nvGrpSpPr>
-      <p:grpSpPr>
-        <a:xfrm>
-          <a:off x="0" y="0"/>
-          <a:ext cx="0" cy="0"/>
-          <a:chOff x="0" y="0"/>
-          <a:chExt cx="0" cy="0"/>
-        </a:xfrm>
-      </p:grpSpPr>
-      <p:sp>
-        <p:nvSpPr>
-          <p:cNvPr id="2" name="Text 0"/>
-          <p:cNvSpPr txBox="1"/>
-          <p:nvPr/>
-        </p:nvSpPr>
-        <p:spPr>
-          <a:xfrm>
-            <a:off x="457200" y="292608"/>
-            <a:ext cx="8229600" cy="457200"/>
-          </a:xfrm>
-          <a:prstGeom prst="rect">
-            <a:avLst/>
-          </a:prstGeom>
-          <a:noFill/>
-          <a:ln/>
-        </p:spPr>
-        <p:txBody>
-          <a:bodyPr wrap="square" lIns="0" tIns="0" rIns="0" bIns="0" rtlCol="0" anchor="ctr"/>
-          <a:lstStyle/>
-          <a:p>
-            <a:pPr indent="0" marL="0">
-              <a:buNone/>
-            </a:pPr>
-            <a:r>
-              <a:rPr lang="en-US" sz="2000" b="1" dirty="0">
-                <a:solidFill>
-                  <a:srgbClr val="16211C"/>
-                </a:solidFill>
-                <a:latin typeface="Pretendard" pitchFamily="34" charset="0"/>
-                <a:ea typeface="Pretendard" pitchFamily="34" charset="-122"/>
-                <a:cs typeface="Pretendard" pitchFamily="34" charset="-120"/>
-              </a:rPr>
-              <a:t>안 E — 아카시아</a:t>
-            </a:r>
-            <a:endParaRPr lang="en-US" sz="2000" dirty="0"/>
-          </a:p>
-        </p:txBody>
-      </p:sp>
-      <p:sp>
-        <p:nvSpPr>
-          <p:cNvPr id="3" name="Text 1"/>
-          <p:cNvSpPr txBox="1"/>
-          <p:nvPr/>
-        </p:nvSpPr>
-        <p:spPr>
-          <a:xfrm>
-            <a:off x="457200" y="731520"/>
-            <a:ext cx="8229600" cy="274320"/>
-          </a:xfrm>
-          <a:prstGeom prst="rect">
-            <a:avLst/>
-          </a:prstGeom>
-          <a:noFill/>
-          <a:ln/>
-        </p:spPr>
-        <p:txBody>
-          <a:bodyPr wrap="square" lIns="0" tIns="0" rIns="0" bIns="0" rtlCol="0" anchor="ctr"/>
-          <a:lstStyle/>
-          <a:p>
-            <a:pPr indent="0" marL="0">
-              <a:buNone/>
-            </a:pPr>
-            <a:r>
-              <a:rPr lang="en-US" sz="1200" dirty="0">
-                <a:solidFill>
-                  <a:srgbClr val="6B7A72"/>
-                </a:solidFill>
-                <a:latin typeface="Pretendard" pitchFamily="34" charset="0"/>
-                <a:ea typeface="Pretendard" pitchFamily="34" charset="-122"/>
-                <a:cs typeface="Pretendard" pitchFamily="34" charset="-120"/>
-              </a:rPr>
-              <a:t>잠비아 사바나의 납작한 우산형 수관.</a:t>
-            </a:r>
-            <a:endParaRPr lang="en-US" sz="1200" dirty="0"/>
-          </a:p>
-        </p:txBody>
-      </p:sp>
-      <p:pic>
-        <p:nvPicPr>
-          <p:cNvPr id="4" name="E green" descr="/tmp/claude-0/-home-user-otterlee/54e04198-701a-58c9-b487-eea2ac6d4846/scratchpad/out/E_green.png">    </p:cNvPr>
-          <p:cNvPicPr>
-            <a:picLocks noChangeAspect="1"/>
-          </p:cNvPicPr>
-          <p:nvPr/>
-        </p:nvPicPr>
-        <p:blipFill>
-          <a:blip r:embed="rId1"/>
-          <a:stretch>
-            <a:fillRect/>
-          </a:stretch>
-        </p:blipFill>
-        <p:spPr>
-          <a:xfrm>
-            <a:off x="457200" y="1188720"/>
-            <a:ext cx="2926080" cy="2926080"/>
-          </a:xfrm>
-          <a:prstGeom prst="rect">
-            <a:avLst/>
-          </a:prstGeom>
-        </p:spPr>
-      </p:pic>
-      <p:pic>
-        <p:nvPicPr>
-          <p:cNvPr id="5" name="E white" descr="/tmp/claude-0/-home-user-otterlee/54e04198-701a-58c9-b487-eea2ac6d4846/scratchpad/out/E_white.png">    </p:cNvPr>
-          <p:cNvPicPr>
-            <a:picLocks noChangeAspect="1"/>
-          </p:cNvPicPr>
-          <p:nvPr/>
-        </p:nvPicPr>
-        <p:blipFill>
-          <a:blip r:embed="rId2"/>
-          <a:stretch>
-            <a:fillRect/>
-          </a:stretch>
-        </p:blipFill>
-        <p:spPr>
-          <a:xfrm>
-            <a:off x="3566160" y="1188720"/>
-            <a:ext cx="1463040" cy="1463040"/>
-          </a:xfrm>
-          <a:prstGeom prst="rect">
-            <a:avLst/>
-          </a:prstGeom>
-        </p:spPr>
-      </p:pic>
-      <p:pic>
-        <p:nvPicPr>
-          <p:cNvPr id="6" name="E lockup" descr="/tmp/claude-0/-home-user-otterlee/54e04198-701a-58c9-b487-eea2ac6d4846/scratchpad/out/E_lockup.png">    </p:cNvPr>
-          <p:cNvPicPr>
-            <a:picLocks noChangeAspect="1"/>
-          </p:cNvPicPr>
-          <p:nvPr/>
-        </p:nvPicPr>
-        <p:blipFill>
-          <a:blip r:embed="rId3"/>
-          <a:stretch>
-            <a:fillRect/>
-          </a:stretch>
-        </p:blipFill>
-        <p:spPr>
-          <a:xfrm>
-            <a:off x="5212080" y="1188720"/>
-            <a:ext cx="3474720" cy="1411834"/>
-          </a:xfrm>
-          <a:prstGeom prst="rect">
-            <a:avLst/>
-          </a:prstGeom>
-        </p:spPr>
-      </p:pic>
-      <p:pic>
-        <p:nvPicPr>
-          <p:cNvPr id="7" name="E size0" descr="/tmp/claude-0/-home-user-otterlee/54e04198-701a-58c9-b487-eea2ac6d4846/scratchpad/out/E_white.png">    </p:cNvPr>
-          <p:cNvPicPr>
-            <a:picLocks noChangeAspect="1"/>
-          </p:cNvPicPr>
-          <p:nvPr/>
-        </p:nvPicPr>
-        <p:blipFill>
-          <a:blip r:embed="rId4"/>
-          <a:stretch>
-            <a:fillRect/>
-          </a:stretch>
-        </p:blipFill>
-        <p:spPr>
-          <a:xfrm>
-            <a:off x="3566160" y="3063240"/>
-            <a:ext cx="274320" cy="274320"/>
-          </a:xfrm>
-          <a:prstGeom prst="rect">
-            <a:avLst/>
-          </a:prstGeom>
-        </p:spPr>
-      </p:pic>
-      <p:pic>
-        <p:nvPicPr>
-          <p:cNvPr id="8" name="E size1" descr="/tmp/claude-0/-home-user-otterlee/54e04198-701a-58c9-b487-eea2ac6d4846/scratchpad/out/E_white.png">    </p:cNvPr>
-          <p:cNvPicPr>
-            <a:picLocks noChangeAspect="1"/>
-          </p:cNvPicPr>
-          <p:nvPr/>
-        </p:nvPicPr>
-        <p:blipFill>
-          <a:blip r:embed="rId5"/>
-          <a:stretch>
-            <a:fillRect/>
-          </a:stretch>
-        </p:blipFill>
-        <p:spPr>
-          <a:xfrm>
-            <a:off x="3977640" y="2994660"/>
-            <a:ext cx="411480" cy="411480"/>
-          </a:xfrm>
-          <a:prstGeom prst="rect">
-            <a:avLst/>
-          </a:prstGeom>
-        </p:spPr>
-      </p:pic>
-      <p:pic>
-        <p:nvPicPr>
-          <p:cNvPr id="9" name="E size2" descr="/tmp/claude-0/-home-user-otterlee/54e04198-701a-58c9-b487-eea2ac6d4846/scratchpad/out/E_white.png">    </p:cNvPr>
-          <p:cNvPicPr>
-            <a:picLocks noChangeAspect="1"/>
-          </p:cNvPicPr>
-          <p:nvPr/>
-        </p:nvPicPr>
-        <p:blipFill>
-          <a:blip r:embed="rId6"/>
-          <a:stretch>
-            <a:fillRect/>
-          </a:stretch>
-        </p:blipFill>
-        <p:spPr>
-          <a:xfrm>
-            <a:off x="4480560" y="2880360"/>
-            <a:ext cx="640080" cy="640080"/>
-          </a:xfrm>
-          <a:prstGeom prst="rect">
-            <a:avLst/>
-          </a:prstGeom>
-        </p:spPr>
-      </p:pic>
-      <p:sp>
-        <p:nvSpPr>
-          <p:cNvPr id="10" name="Text 2"/>
-          <p:cNvSpPr txBox="1"/>
-          <p:nvPr/>
-        </p:nvSpPr>
-        <p:spPr>
-          <a:xfrm>
-            <a:off x="3566160" y="3840480"/>
-            <a:ext cx="1645920" cy="228600"/>
-          </a:xfrm>
-          <a:prstGeom prst="rect">
-            <a:avLst/>
-          </a:prstGeom>
-          <a:noFill/>
-          <a:ln/>
-        </p:spPr>
-        <p:txBody>
-          <a:bodyPr wrap="square" lIns="0" tIns="0" rIns="0" bIns="0" rtlCol="0" anchor="ctr"/>
-          <a:lstStyle/>
-          <a:p>
-            <a:pPr indent="0" marL="0">
-              <a:buNone/>
-            </a:pPr>
-            <a:r>
-              <a:rPr lang="en-US" sz="1000" dirty="0">
-                <a:solidFill>
-                  <a:srgbClr val="6B7A72"/>
-                </a:solidFill>
-                <a:latin typeface="Pretendard" pitchFamily="34" charset="0"/>
-                <a:ea typeface="Pretendard" pitchFamily="34" charset="-122"/>
-                <a:cs typeface="Pretendard" pitchFamily="34" charset="-120"/>
-              </a:rPr>
-              <a:t>축소 확인</a:t>
-            </a:r>
-            <a:endParaRPr lang="en-US" sz="1000" dirty="0"/>
-          </a:p>
-        </p:txBody>
-      </p:sp>
-      <p:sp>
-        <p:nvSpPr>
-          <p:cNvPr id="11" name="note card"/>
-          <p:cNvSpPr/>
-          <p:nvPr/>
-        </p:nvSpPr>
-        <p:spPr>
-          <a:xfrm>
-            <a:off x="5212080" y="2880360"/>
-            <a:ext cx="3474720" cy="1234440"/>
-          </a:xfrm>
-          <a:prstGeom prst="roundRect">
-            <a:avLst>
-              <a:gd name="adj" fmla="val 5926"/>
-            </a:avLst>
-          </a:prstGeom>
-          <a:solidFill>
-            <a:srgbClr val="EAF7EE"/>
-          </a:solidFill>
-          <a:ln w="12700">
-            <a:solidFill>
-              <a:srgbClr val="EAF7EE"/>
-            </a:solidFill>
-            <a:prstDash val="solid"/>
-          </a:ln>
-        </p:spPr>
-      </p:sp>
-      <p:sp>
-        <p:nvSpPr>
-          <p:cNvPr id="12" name="Text 4"/>
-          <p:cNvSpPr txBox="1"/>
-          <p:nvPr/>
-        </p:nvSpPr>
-        <p:spPr>
-          <a:xfrm>
-            <a:off x="5394960" y="2880360"/>
-            <a:ext cx="3108960" cy="1234440"/>
-          </a:xfrm>
-          <a:prstGeom prst="rect">
-            <a:avLst/>
-          </a:prstGeom>
-          <a:noFill/>
-          <a:ln/>
-        </p:spPr>
-        <p:txBody>
-          <a:bodyPr wrap="square" lIns="0" tIns="0" rIns="0" bIns="0" rtlCol="0" anchor="ctr"/>
-          <a:lstStyle/>
-          <a:p>
-            <a:pPr indent="0" marL="0">
-              <a:buNone/>
-            </a:pPr>
-            <a:r>
-              <a:rPr lang="en-US" sz="1300" dirty="0">
-                <a:solidFill>
-                  <a:srgbClr val="16211C"/>
-                </a:solidFill>
-                <a:latin typeface="Pretendard" pitchFamily="34" charset="0"/>
-                <a:ea typeface="Pretendard" pitchFamily="34" charset="-122"/>
-                <a:cs typeface="Pretendard" pitchFamily="34" charset="-120"/>
-              </a:rPr>
-              <a:t>잠비아다운 고유한 실루엣. 다른 안보다 가로로 넓습니다.</a:t>
-            </a:r>
-            <a:endParaRPr lang="en-US" sz="1300" dirty="0"/>
-          </a:p>
-        </p:txBody>
-      </p:sp>
-    </p:spTree>
-  </p:cSld>
-  <p:clrMapOvr>
-    <a:masterClrMapping/>
-  </p:clrMapOvr>
-</p:sld>
-</file>
-
-<file path=ppt/slides/slide9.xml><?xml version="1.0" encoding="utf-8"?>
-<p:sld xmlns:a="http://schemas.openxmlformats.org/drawingml/2006/main" xmlns:r="http://schemas.openxmlformats.org/officeDocument/2006/relationships" xmlns:p="http://schemas.openxmlformats.org/presentationml/2006/main">
-  <p:cSld name="Slide 9">
     <p:bg>
       <p:bgPr>
         <a:solidFill>

</xml_diff>

<commit_message>
BI symbol variations: 5 gentle variants based on approved option 1
Co-Authored-By: Claude Sonnet 5.5 <noreply@anthropic.com>
Claude-Session: https://claude.ai/code/session_01XSVwnKProgLsAGnFXzc9nT
</commit_message>
<xml_diff>
--- a/bi/zambia-variations-v3/plant-zambia-bi-variations-v3.pptx
+++ b/bi/zambia-variations-v3/plant-zambia-bi-variations-v3.pptx
@@ -13,9 +13,10 @@
     <p:sldId id="261" r:id="rId7"/>
     <p:sldId id="262" r:id="rId8"/>
     <p:sldId id="263" r:id="rId9"/>
+    <p:sldId id="264" r:id="rId10"/>
   </p:sldIdLst>
   <p:notesMasterIdLst>
-    <p:notesMasterId r:id="rId10"/>
+    <p:notesMasterId r:id="rId11"/>
   </p:notesMasterIdLst>
   <p:sldSz cx="9144000" cy="5143500"/>
   <p:notesSz cx="5143500" cy="9144000"/>
@@ -1149,6 +1150,94 @@
             <a:fld id="{F7021451-1387-4CA6-816F-3879F97B5CBC}" type="slidenum">
               <a:rPr lang="en-US"/>
               <a:t>8</a:t>
+            </a:fld>
+            <a:endParaRPr lang="en-US"/>
+          </a:p>
+        </p:txBody>
+      </p:sp>
+    </p:spTree>
+    <p:extLst>
+      <p:ext uri="{BB962C8B-B14F-4D97-AF65-F5344CB8AC3E}">
+        <p14:creationId xmlns:p14="http://schemas.microsoft.com/office/powerpoint/2010/main" val="1024086991"/>
+      </p:ext>
+    </p:extLst>
+  </p:cSld>
+  <p:clrMapOvr>
+    <a:masterClrMapping/>
+  </p:clrMapOvr>
+</p:notes>
+</file>
+
+<file path=ppt/notesSlides/notesSlide9.xml><?xml version="1.0" encoding="utf-8"?>
+<p:notes xmlns:a="http://schemas.openxmlformats.org/drawingml/2006/main" xmlns:r="http://schemas.openxmlformats.org/officeDocument/2006/relationships" xmlns:p="http://schemas.openxmlformats.org/presentationml/2006/main">
+  <p:cSld>
+    <p:spTree>
+      <p:nvGrpSpPr>
+        <p:cNvPr id="1" name=""/>
+        <p:cNvGrpSpPr/>
+        <p:nvPr/>
+      </p:nvGrpSpPr>
+      <p:grpSpPr>
+        <a:xfrm>
+          <a:off x="0" y="0"/>
+          <a:ext cx="0" cy="0"/>
+          <a:chOff x="0" y="0"/>
+          <a:chExt cx="0" cy="0"/>
+        </a:xfrm>
+      </p:grpSpPr>
+      <p:sp>
+        <p:nvSpPr>
+          <p:cNvPr id="2" name="Slide Image Placeholder 1"/>
+          <p:cNvSpPr>
+            <a:spLocks noGrp="1" noRot="1" noChangeAspect="1"/>
+          </p:cNvSpPr>
+          <p:nvPr>
+            <p:ph type="sldImg"/>
+          </p:nvPr>
+        </p:nvSpPr>
+        <p:spPr/>
+      </p:sp>
+      <p:sp>
+        <p:nvSpPr>
+          <p:cNvPr id="3" name="Notes Placeholder 2"/>
+          <p:cNvSpPr>
+            <a:spLocks noGrp="1"/>
+          </p:cNvSpPr>
+          <p:nvPr>
+            <p:ph type="body" idx="1"/>
+          </p:nvPr>
+        </p:nvSpPr>
+        <p:spPr/>
+        <p:txBody>
+          <a:bodyPr/>
+          <a:lstStyle/>
+          <a:p>
+            <a:r>
+              <a:rPr lang="en-US" dirty="0"/>
+              <a:t/>
+            </a:r>
+            <a:endParaRPr lang="en-US" dirty="0"/>
+          </a:p>
+        </p:txBody>
+      </p:sp>
+      <p:sp>
+        <p:nvSpPr>
+          <p:cNvPr id="4" name="Slide Number Placeholder 3"/>
+          <p:cNvSpPr>
+            <a:spLocks noGrp="1"/>
+          </p:cNvSpPr>
+          <p:nvPr>
+            <p:ph type="sldNum" sz="quarter" idx="10"/>
+          </p:nvPr>
+        </p:nvSpPr>
+        <p:spPr/>
+        <p:txBody>
+          <a:bodyPr/>
+          <a:lstStyle/>
+          <a:p>
+            <a:fld id="{F7021451-1387-4CA6-816F-3879F97B5CBC}" type="slidenum">
+              <a:rPr lang="en-US"/>
+              <a:t>9</a:t>
             </a:fld>
             <a:endParaRPr lang="en-US"/>
           </a:p>
@@ -1500,7 +1589,7 @@
       </p:grpSpPr>
       <p:pic>
         <p:nvPicPr>
-          <p:cNvPr id="2" name="cover symbol" descr="/tmp/claude-0/-home-user-otterlee/54e04198-701a-58c9-b487-eea2ac6d4846/scratchpad/out2/2_monowhite.png">    </p:cNvPr>
+          <p:cNvPr id="2" name="cover symbol" descr="/tmp/claude-0/-home-user-otterlee/54e04198-701a-58c9-b487-eea2ac6d4846/scratchpad/out3/a_monowhite.png">    </p:cNvPr>
           <p:cNvPicPr>
             <a:picLocks noChangeAspect="1"/>
           </p:cNvPicPr>
@@ -1633,7 +1722,7 @@
                 <a:ea typeface="Pretendard" pitchFamily="34" charset="-122"/>
                 <a:cs typeface="Pretendard" pitchFamily="34" charset="-120"/>
               </a:rPr>
-              <a:t>(사)산과자연의친구 · 2026. 10 · v3 (피드백 반영 4안)</a:t>
+              <a:t>(사)산과자연의친구 · 2026. 10 · v3 (피드백 반영 5안)</a:t>
             </a:r>
             <a:endParaRPr lang="en-US" sz="1100" dirty="0"/>
           </a:p>
@@ -2187,7 +2276,7 @@
                 <a:ea typeface="Pretendard" pitchFamily="34" charset="-122"/>
                 <a:cs typeface="Pretendard" pitchFamily="34" charset="-120"/>
               </a:rPr>
-              <a:t>4가지 변형을 만들어 나중에 택일</a:t>
+              <a:t>5가지 변형을 만들어 나중에 택일</a:t>
             </a:r>
             <a:endParaRPr lang="en-US" sz="1300" dirty="0"/>
           </a:p>
@@ -2258,7 +2347,7 @@
                 <a:ea typeface="Pretendard" pitchFamily="34" charset="-122"/>
                 <a:cs typeface="Pretendard" pitchFamily="34" charset="-120"/>
               </a:rPr>
-              <a:t>변형안 한눈에 보기</a:t>
+              <a:t>1안 기준 변형 한눈에 보기</a:t>
             </a:r>
             <a:endParaRPr lang="en-US" sz="2000" dirty="0"/>
           </a:p>
@@ -2305,7 +2394,7 @@
       </p:sp>
       <p:pic>
         <p:nvPicPr>
-          <p:cNvPr id="4" name="overview 1" descr="/tmp/claude-0/-home-user-otterlee/54e04198-701a-58c9-b487-eea2ac6d4846/scratchpad/out2/1_green.png">    </p:cNvPr>
+          <p:cNvPr id="4" name="overview a" descr="/tmp/claude-0/-home-user-otterlee/54e04198-701a-58c9-b487-eea2ac6d4846/scratchpad/out3/a_green.png">    </p:cNvPr>
           <p:cNvPicPr>
             <a:picLocks noChangeAspect="1"/>
           </p:cNvPicPr>
@@ -2320,7 +2409,7 @@
         <p:spPr>
           <a:xfrm>
             <a:off x="457200" y="1371600"/>
-            <a:ext cx="1828800" cy="1828800"/>
+            <a:ext cx="1508760" cy="1508760"/>
           </a:xfrm>
           <a:prstGeom prst="rect">
             <a:avLst/>
@@ -2335,8 +2424,8 @@
         </p:nvSpPr>
         <p:spPr>
           <a:xfrm>
-            <a:off x="457200" y="3337560"/>
-            <a:ext cx="1828800" cy="365760"/>
+            <a:off x="457200" y="3017520"/>
+            <a:ext cx="1508760" cy="548640"/>
           </a:xfrm>
           <a:prstGeom prst="rect">
             <a:avLst/>
@@ -2360,7 +2449,7 @@
                 <a:ea typeface="Pretendard" pitchFamily="34" charset="-122"/>
                 <a:cs typeface="Pretendard" pitchFamily="34" charset="-120"/>
               </a:rPr>
-              <a:t>1안  살짝 풀기</a:t>
+              <a:t>1-1  기준안</a:t>
             </a:r>
             <a:endParaRPr lang="en-US" sz="1200" dirty="0"/>
           </a:p>
@@ -2368,7 +2457,7 @@
       </p:sp>
       <p:pic>
         <p:nvPicPr>
-          <p:cNvPr id="6" name="overview 2" descr="/tmp/claude-0/-home-user-otterlee/54e04198-701a-58c9-b487-eea2ac6d4846/scratchpad/out2/2_green.png">    </p:cNvPr>
+          <p:cNvPr id="6" name="overview b" descr="/tmp/claude-0/-home-user-otterlee/54e04198-701a-58c9-b487-eea2ac6d4846/scratchpad/out3/b_green.png">    </p:cNvPr>
           <p:cNvPicPr>
             <a:picLocks noChangeAspect="1"/>
           </p:cNvPicPr>
@@ -2382,8 +2471,8 @@
         </p:blipFill>
         <p:spPr>
           <a:xfrm>
-            <a:off x="2560320" y="1371600"/>
-            <a:ext cx="1828800" cy="1828800"/>
+            <a:off x="2103120" y="1371600"/>
+            <a:ext cx="1508760" cy="1508760"/>
           </a:xfrm>
           <a:prstGeom prst="rect">
             <a:avLst/>
@@ -2398,8 +2487,8 @@
         </p:nvSpPr>
         <p:spPr>
           <a:xfrm>
-            <a:off x="2560320" y="3337560"/>
-            <a:ext cx="1828800" cy="365760"/>
+            <a:off x="2103120" y="3017520"/>
+            <a:ext cx="1508760" cy="548640"/>
           </a:xfrm>
           <a:prstGeom prst="rect">
             <a:avLst/>
@@ -2423,7 +2512,7 @@
                 <a:ea typeface="Pretendard" pitchFamily="34" charset="-122"/>
                 <a:cs typeface="Pretendard" pitchFamily="34" charset="-120"/>
               </a:rPr>
-              <a:t>2안  크기 다양</a:t>
+              <a:t>1-2  크기 차이 크게</a:t>
             </a:r>
             <a:endParaRPr lang="en-US" sz="1200" dirty="0"/>
           </a:p>
@@ -2431,7 +2520,7 @@
       </p:sp>
       <p:pic>
         <p:nvPicPr>
-          <p:cNvPr id="8" name="overview 3" descr="/tmp/claude-0/-home-user-otterlee/54e04198-701a-58c9-b487-eea2ac6d4846/scratchpad/out2/3_green.png">    </p:cNvPr>
+          <p:cNvPr id="8" name="overview c" descr="/tmp/claude-0/-home-user-otterlee/54e04198-701a-58c9-b487-eea2ac6d4846/scratchpad/out3/c_green.png">    </p:cNvPr>
           <p:cNvPicPr>
             <a:picLocks noChangeAspect="1"/>
           </p:cNvPicPr>
@@ -2445,8 +2534,8 @@
         </p:blipFill>
         <p:spPr>
           <a:xfrm>
-            <a:off x="4663440" y="1371600"/>
-            <a:ext cx="1828800" cy="1828800"/>
+            <a:off x="3749040" y="1371600"/>
+            <a:ext cx="1508760" cy="1508760"/>
           </a:xfrm>
           <a:prstGeom prst="rect">
             <a:avLst/>
@@ -2461,8 +2550,8 @@
         </p:nvSpPr>
         <p:spPr>
           <a:xfrm>
-            <a:off x="4663440" y="3337560"/>
-            <a:ext cx="1828800" cy="365760"/>
+            <a:off x="3749040" y="3017520"/>
+            <a:ext cx="1508760" cy="548640"/>
           </a:xfrm>
           <a:prstGeom prst="rect">
             <a:avLst/>
@@ -2486,7 +2575,7 @@
                 <a:ea typeface="Pretendard" pitchFamily="34" charset="-122"/>
                 <a:cs typeface="Pretendard" pitchFamily="34" charset="-120"/>
               </a:rPr>
-              <a:t>3안  흩날림</a:t>
+              <a:t>1-3  위치 더 흩트리기</a:t>
             </a:r>
             <a:endParaRPr lang="en-US" sz="1200" dirty="0"/>
           </a:p>
@@ -2494,7 +2583,7 @@
       </p:sp>
       <p:pic>
         <p:nvPicPr>
-          <p:cNvPr id="10" name="overview 4" descr="/tmp/claude-0/-home-user-otterlee/54e04198-701a-58c9-b487-eea2ac6d4846/scratchpad/out2/4_green.png">    </p:cNvPr>
+          <p:cNvPr id="10" name="overview d" descr="/tmp/claude-0/-home-user-otterlee/54e04198-701a-58c9-b487-eea2ac6d4846/scratchpad/out3/d_green.png">    </p:cNvPr>
           <p:cNvPicPr>
             <a:picLocks noChangeAspect="1"/>
           </p:cNvPicPr>
@@ -2508,8 +2597,8 @@
         </p:blipFill>
         <p:spPr>
           <a:xfrm>
-            <a:off x="6766560" y="1371600"/>
-            <a:ext cx="1828800" cy="1828800"/>
+            <a:off x="5394960" y="1371600"/>
+            <a:ext cx="1508760" cy="1508760"/>
           </a:xfrm>
           <a:prstGeom prst="rect">
             <a:avLst/>
@@ -2524,8 +2613,8 @@
         </p:nvSpPr>
         <p:spPr>
           <a:xfrm>
-            <a:off x="6766560" y="3337560"/>
-            <a:ext cx="1828800" cy="365760"/>
+            <a:off x="5394960" y="3017520"/>
+            <a:ext cx="1508760" cy="548640"/>
           </a:xfrm>
           <a:prstGeom prst="rect">
             <a:avLst/>
@@ -2549,15 +2638,78 @@
                 <a:ea typeface="Pretendard" pitchFamily="34" charset="-122"/>
                 <a:cs typeface="Pretendard" pitchFamily="34" charset="-120"/>
               </a:rPr>
-              <a:t>4안  나무와 숲</a:t>
+              <a:t>1-4  줄기를 자유롭게</a:t>
             </a:r>
             <a:endParaRPr lang="en-US" sz="1200" dirty="0"/>
           </a:p>
         </p:txBody>
       </p:sp>
-      <p:sp>
-        <p:nvSpPr>
-          <p:cNvPr id="12" name="Text 6"/>
+      <p:pic>
+        <p:nvPicPr>
+          <p:cNvPr id="12" name="overview e" descr="/tmp/claude-0/-home-user-otterlee/54e04198-701a-58c9-b487-eea2ac6d4846/scratchpad/out3/e_green.png">    </p:cNvPr>
+          <p:cNvPicPr>
+            <a:picLocks noChangeAspect="1"/>
+          </p:cNvPicPr>
+          <p:nvPr/>
+        </p:nvPicPr>
+        <p:blipFill>
+          <a:blip r:embed="rId5"/>
+          <a:stretch>
+            <a:fillRect/>
+          </a:stretch>
+        </p:blipFill>
+        <p:spPr>
+          <a:xfrm>
+            <a:off x="7040880" y="1371600"/>
+            <a:ext cx="1508760" cy="1508760"/>
+          </a:xfrm>
+          <a:prstGeom prst="rect">
+            <a:avLst/>
+          </a:prstGeom>
+        </p:spPr>
+      </p:pic>
+      <p:sp>
+        <p:nvSpPr>
+          <p:cNvPr id="13" name="Text 6"/>
+          <p:cNvSpPr txBox="1"/>
+          <p:nvPr/>
+        </p:nvSpPr>
+        <p:spPr>
+          <a:xfrm>
+            <a:off x="7040880" y="3017520"/>
+            <a:ext cx="1508760" cy="548640"/>
+          </a:xfrm>
+          <a:prstGeom prst="rect">
+            <a:avLst/>
+          </a:prstGeom>
+          <a:noFill/>
+          <a:ln/>
+        </p:spPr>
+        <p:txBody>
+          <a:bodyPr wrap="square" lIns="0" tIns="0" rIns="0" bIns="0" rtlCol="0" anchor="ctr"/>
+          <a:lstStyle/>
+          <a:p>
+            <a:pPr indent="0" marL="0">
+              <a:buNone/>
+            </a:pPr>
+            <a:r>
+              <a:rPr lang="en-US" sz="1200" b="1" dirty="0">
+                <a:solidFill>
+                  <a:srgbClr val="16211C"/>
+                </a:solidFill>
+                <a:latin typeface="Pretendard" pitchFamily="34" charset="0"/>
+                <a:ea typeface="Pretendard" pitchFamily="34" charset="-122"/>
+                <a:cs typeface="Pretendard" pitchFamily="34" charset="-120"/>
+              </a:rPr>
+              <a:t>1-5  가장자리 비우기</a:t>
+            </a:r>
+            <a:endParaRPr lang="en-US" sz="1200" dirty="0"/>
+          </a:p>
+        </p:txBody>
+      </p:sp>
+      <p:sp>
+        <p:nvSpPr>
+          <p:cNvPr id="14" name="Text 7"/>
           <p:cNvSpPr txBox="1"/>
           <p:nvPr/>
         </p:nvSpPr>
@@ -2588,7 +2740,7 @@
                 <a:ea typeface="Pretendard" pitchFamily="34" charset="-122"/>
                 <a:cs typeface="Pretendard" pitchFamily="34" charset="-120"/>
               </a:rPr>
-              <a:t>v2(왼쪽 원본)보다 점의 크기와 위치가 자유롭지만, 나무 모양은 알아볼 수 있게 유지했습니다.</a:t>
+              <a:t>모두 점 25개 안팎이고 나무 모양을 유지했습니다. 달라지는 것은 점의 크기와 위치뿐입니다.</a:t>
             </a:r>
             <a:endParaRPr lang="en-US" sz="1200" dirty="0"/>
           </a:p>
@@ -2659,7 +2811,7 @@
                 <a:ea typeface="Pretendard" pitchFamily="34" charset="-122"/>
                 <a:cs typeface="Pretendard" pitchFamily="34" charset="-120"/>
               </a:rPr>
-              <a:t>1안 — 살짝 풀기</a:t>
+              <a:t>1-1  기준안</a:t>
             </a:r>
             <a:endParaRPr lang="en-US" sz="2000" dirty="0"/>
           </a:p>
@@ -2698,7 +2850,7 @@
                 <a:ea typeface="Pretendard" pitchFamily="34" charset="-122"/>
                 <a:cs typeface="Pretendard" pitchFamily="34" charset="-120"/>
               </a:rPr>
-              <a:t>v2의 나무 모양은 그대로, 점의 위치와 크기만 조금씩 흩트렸습니다.</a:t>
+              <a:t>앞서 좋다고 하신 1안 그대로입니다. v2의 나무 모양에 점 위치와 크기만 조금 풀었습니다.</a:t>
             </a:r>
             <a:endParaRPr lang="en-US" sz="1200" dirty="0"/>
           </a:p>
@@ -2706,7 +2858,7 @@
       </p:sp>
       <p:pic>
         <p:nvPicPr>
-          <p:cNvPr id="4" name="1 green" descr="/tmp/claude-0/-home-user-otterlee/54e04198-701a-58c9-b487-eea2ac6d4846/scratchpad/out2/1_green.png">    </p:cNvPr>
+          <p:cNvPr id="4" name="a green" descr="/tmp/claude-0/-home-user-otterlee/54e04198-701a-58c9-b487-eea2ac6d4846/scratchpad/out3/a_green.png">    </p:cNvPr>
           <p:cNvPicPr>
             <a:picLocks noChangeAspect="1"/>
           </p:cNvPicPr>
@@ -2730,7 +2882,7 @@
       </p:pic>
       <p:pic>
         <p:nvPicPr>
-          <p:cNvPr id="5" name="1 white" descr="/tmp/claude-0/-home-user-otterlee/54e04198-701a-58c9-b487-eea2ac6d4846/scratchpad/out2/1_white.png">    </p:cNvPr>
+          <p:cNvPr id="5" name="a white" descr="/tmp/claude-0/-home-user-otterlee/54e04198-701a-58c9-b487-eea2ac6d4846/scratchpad/out3/a_white.png">    </p:cNvPr>
           <p:cNvPicPr>
             <a:picLocks noChangeAspect="1"/>
           </p:cNvPicPr>
@@ -2754,7 +2906,7 @@
       </p:pic>
       <p:pic>
         <p:nvPicPr>
-          <p:cNvPr id="6" name="1 lockup" descr="/tmp/claude-0/-home-user-otterlee/54e04198-701a-58c9-b487-eea2ac6d4846/scratchpad/out2/1_lockup.png">    </p:cNvPr>
+          <p:cNvPr id="6" name="a lockup" descr="/tmp/claude-0/-home-user-otterlee/54e04198-701a-58c9-b487-eea2ac6d4846/scratchpad/out3/a_lockup.png">    </p:cNvPr>
           <p:cNvPicPr>
             <a:picLocks noChangeAspect="1"/>
           </p:cNvPicPr>
@@ -2778,7 +2930,7 @@
       </p:pic>
       <p:pic>
         <p:nvPicPr>
-          <p:cNvPr id="7" name="1 size0" descr="/tmp/claude-0/-home-user-otterlee/54e04198-701a-58c9-b487-eea2ac6d4846/scratchpad/out2/1_white.png">    </p:cNvPr>
+          <p:cNvPr id="7" name="a size0" descr="/tmp/claude-0/-home-user-otterlee/54e04198-701a-58c9-b487-eea2ac6d4846/scratchpad/out3/a_white.png">    </p:cNvPr>
           <p:cNvPicPr>
             <a:picLocks noChangeAspect="1"/>
           </p:cNvPicPr>
@@ -2802,7 +2954,7 @@
       </p:pic>
       <p:pic>
         <p:nvPicPr>
-          <p:cNvPr id="8" name="1 size1" descr="/tmp/claude-0/-home-user-otterlee/54e04198-701a-58c9-b487-eea2ac6d4846/scratchpad/out2/1_white.png">    </p:cNvPr>
+          <p:cNvPr id="8" name="a size1" descr="/tmp/claude-0/-home-user-otterlee/54e04198-701a-58c9-b487-eea2ac6d4846/scratchpad/out3/a_white.png">    </p:cNvPr>
           <p:cNvPicPr>
             <a:picLocks noChangeAspect="1"/>
           </p:cNvPicPr>
@@ -2826,7 +2978,7 @@
       </p:pic>
       <p:pic>
         <p:nvPicPr>
-          <p:cNvPr id="9" name="1 size2" descr="/tmp/claude-0/-home-user-otterlee/54e04198-701a-58c9-b487-eea2ac6d4846/scratchpad/out2/1_white.png">    </p:cNvPr>
+          <p:cNvPr id="9" name="a size2" descr="/tmp/claude-0/-home-user-otterlee/54e04198-701a-58c9-b487-eea2ac6d4846/scratchpad/out3/a_white.png">    </p:cNvPr>
           <p:cNvPicPr>
             <a:picLocks noChangeAspect="1"/>
           </p:cNvPicPr>
@@ -2947,7 +3099,7 @@
                 <a:ea typeface="Pretendard" pitchFamily="34" charset="-122"/>
                 <a:cs typeface="Pretendard" pitchFamily="34" charset="-120"/>
               </a:rPr>
-              <a:t>가장 안전한 안. 점 25개로 기존 심볼의 인상을 그대로 이어갑니다.</a:t>
+              <a:t>기준이 되는 안. 아래 변주와 비교해 보세요.</a:t>
             </a:r>
             <a:endParaRPr lang="en-US" sz="1300" dirty="0"/>
           </a:p>
@@ -3018,7 +3170,7 @@
                 <a:ea typeface="Pretendard" pitchFamily="34" charset="-122"/>
                 <a:cs typeface="Pretendard" pitchFamily="34" charset="-120"/>
               </a:rPr>
-              <a:t>2안 — 크기 다양</a:t>
+              <a:t>1-2  크기 차이 크게</a:t>
             </a:r>
             <a:endParaRPr lang="en-US" sz="2000" dirty="0"/>
           </a:p>
@@ -3057,7 +3209,7 @@
                 <a:ea typeface="Pretendard" pitchFamily="34" charset="-122"/>
                 <a:cs typeface="Pretendard" pitchFamily="34" charset="-120"/>
               </a:rPr>
-              <a:t>같은 마름모 실루엣 안에서 큰 점과 작은 점을 섞었습니다.</a:t>
+              <a:t>1안보다 큰 점과 작은 점의 차이를 키웠습니다.</a:t>
             </a:r>
             <a:endParaRPr lang="en-US" sz="1200" dirty="0"/>
           </a:p>
@@ -3065,7 +3217,7 @@
       </p:sp>
       <p:pic>
         <p:nvPicPr>
-          <p:cNvPr id="4" name="2 green" descr="/tmp/claude-0/-home-user-otterlee/54e04198-701a-58c9-b487-eea2ac6d4846/scratchpad/out2/2_green.png">    </p:cNvPr>
+          <p:cNvPr id="4" name="b green" descr="/tmp/claude-0/-home-user-otterlee/54e04198-701a-58c9-b487-eea2ac6d4846/scratchpad/out3/b_green.png">    </p:cNvPr>
           <p:cNvPicPr>
             <a:picLocks noChangeAspect="1"/>
           </p:cNvPicPr>
@@ -3089,7 +3241,7 @@
       </p:pic>
       <p:pic>
         <p:nvPicPr>
-          <p:cNvPr id="5" name="2 white" descr="/tmp/claude-0/-home-user-otterlee/54e04198-701a-58c9-b487-eea2ac6d4846/scratchpad/out2/2_white.png">    </p:cNvPr>
+          <p:cNvPr id="5" name="b white" descr="/tmp/claude-0/-home-user-otterlee/54e04198-701a-58c9-b487-eea2ac6d4846/scratchpad/out3/b_white.png">    </p:cNvPr>
           <p:cNvPicPr>
             <a:picLocks noChangeAspect="1"/>
           </p:cNvPicPr>
@@ -3113,7 +3265,7 @@
       </p:pic>
       <p:pic>
         <p:nvPicPr>
-          <p:cNvPr id="6" name="2 lockup" descr="/tmp/claude-0/-home-user-otterlee/54e04198-701a-58c9-b487-eea2ac6d4846/scratchpad/out2/2_lockup.png">    </p:cNvPr>
+          <p:cNvPr id="6" name="b lockup" descr="/tmp/claude-0/-home-user-otterlee/54e04198-701a-58c9-b487-eea2ac6d4846/scratchpad/out3/b_lockup.png">    </p:cNvPr>
           <p:cNvPicPr>
             <a:picLocks noChangeAspect="1"/>
           </p:cNvPicPr>
@@ -3137,7 +3289,7 @@
       </p:pic>
       <p:pic>
         <p:nvPicPr>
-          <p:cNvPr id="7" name="2 size0" descr="/tmp/claude-0/-home-user-otterlee/54e04198-701a-58c9-b487-eea2ac6d4846/scratchpad/out2/2_white.png">    </p:cNvPr>
+          <p:cNvPr id="7" name="b size0" descr="/tmp/claude-0/-home-user-otterlee/54e04198-701a-58c9-b487-eea2ac6d4846/scratchpad/out3/b_white.png">    </p:cNvPr>
           <p:cNvPicPr>
             <a:picLocks noChangeAspect="1"/>
           </p:cNvPicPr>
@@ -3161,7 +3313,7 @@
       </p:pic>
       <p:pic>
         <p:nvPicPr>
-          <p:cNvPr id="8" name="2 size1" descr="/tmp/claude-0/-home-user-otterlee/54e04198-701a-58c9-b487-eea2ac6d4846/scratchpad/out2/2_white.png">    </p:cNvPr>
+          <p:cNvPr id="8" name="b size1" descr="/tmp/claude-0/-home-user-otterlee/54e04198-701a-58c9-b487-eea2ac6d4846/scratchpad/out3/b_white.png">    </p:cNvPr>
           <p:cNvPicPr>
             <a:picLocks noChangeAspect="1"/>
           </p:cNvPicPr>
@@ -3185,7 +3337,7 @@
       </p:pic>
       <p:pic>
         <p:nvPicPr>
-          <p:cNvPr id="9" name="2 size2" descr="/tmp/claude-0/-home-user-otterlee/54e04198-701a-58c9-b487-eea2ac6d4846/scratchpad/out2/2_white.png">    </p:cNvPr>
+          <p:cNvPr id="9" name="b size2" descr="/tmp/claude-0/-home-user-otterlee/54e04198-701a-58c9-b487-eea2ac6d4846/scratchpad/out3/b_white.png">    </p:cNvPr>
           <p:cNvPicPr>
             <a:picLocks noChangeAspect="1"/>
           </p:cNvPicPr>
@@ -3306,7 +3458,7 @@
                 <a:ea typeface="Pretendard" pitchFamily="34" charset="-122"/>
                 <a:cs typeface="Pretendard" pitchFamily="34" charset="-120"/>
               </a:rPr>
-              <a:t>도식적인 느낌이 줄고 자연스럽습니다. 점 45개 안팎입니다.</a:t>
+              <a:t>리듬감이 생기고 덜 도식적입니다. 가장 작은 점은 축소 시 뭉칠 수 있습니다.</a:t>
             </a:r>
             <a:endParaRPr lang="en-US" sz="1300" dirty="0"/>
           </a:p>
@@ -3377,7 +3529,7 @@
                 <a:ea typeface="Pretendard" pitchFamily="34" charset="-122"/>
                 <a:cs typeface="Pretendard" pitchFamily="34" charset="-120"/>
               </a:rPr>
-              <a:t>3안 — 흩날림</a:t>
+              <a:t>1-3  위치 더 흩트리기</a:t>
             </a:r>
             <a:endParaRPr lang="en-US" sz="2000" dirty="0"/>
           </a:p>
@@ -3416,7 +3568,7 @@
                 <a:ea typeface="Pretendard" pitchFamily="34" charset="-122"/>
                 <a:cs typeface="Pretendard" pitchFamily="34" charset="-120"/>
               </a:rPr>
-              <a:t>2안에 가장자리의 점 몇 개가 바람에 날려 떨어져 나가는 모습을 더했습니다.</a:t>
+              <a:t>점 크기는 비슷하게 두고 배치를 더 자유롭게 흩트렸습니다.</a:t>
             </a:r>
             <a:endParaRPr lang="en-US" sz="1200" dirty="0"/>
           </a:p>
@@ -3424,7 +3576,7 @@
       </p:sp>
       <p:pic>
         <p:nvPicPr>
-          <p:cNvPr id="4" name="3 green" descr="/tmp/claude-0/-home-user-otterlee/54e04198-701a-58c9-b487-eea2ac6d4846/scratchpad/out2/3_green.png">    </p:cNvPr>
+          <p:cNvPr id="4" name="c green" descr="/tmp/claude-0/-home-user-otterlee/54e04198-701a-58c9-b487-eea2ac6d4846/scratchpad/out3/c_green.png">    </p:cNvPr>
           <p:cNvPicPr>
             <a:picLocks noChangeAspect="1"/>
           </p:cNvPicPr>
@@ -3448,7 +3600,7 @@
       </p:pic>
       <p:pic>
         <p:nvPicPr>
-          <p:cNvPr id="5" name="3 white" descr="/tmp/claude-0/-home-user-otterlee/54e04198-701a-58c9-b487-eea2ac6d4846/scratchpad/out2/3_white.png">    </p:cNvPr>
+          <p:cNvPr id="5" name="c white" descr="/tmp/claude-0/-home-user-otterlee/54e04198-701a-58c9-b487-eea2ac6d4846/scratchpad/out3/c_white.png">    </p:cNvPr>
           <p:cNvPicPr>
             <a:picLocks noChangeAspect="1"/>
           </p:cNvPicPr>
@@ -3472,7 +3624,7 @@
       </p:pic>
       <p:pic>
         <p:nvPicPr>
-          <p:cNvPr id="6" name="3 lockup" descr="/tmp/claude-0/-home-user-otterlee/54e04198-701a-58c9-b487-eea2ac6d4846/scratchpad/out2/3_lockup.png">    </p:cNvPr>
+          <p:cNvPr id="6" name="c lockup" descr="/tmp/claude-0/-home-user-otterlee/54e04198-701a-58c9-b487-eea2ac6d4846/scratchpad/out3/c_lockup.png">    </p:cNvPr>
           <p:cNvPicPr>
             <a:picLocks noChangeAspect="1"/>
           </p:cNvPicPr>
@@ -3496,7 +3648,7 @@
       </p:pic>
       <p:pic>
         <p:nvPicPr>
-          <p:cNvPr id="7" name="3 size0" descr="/tmp/claude-0/-home-user-otterlee/54e04198-701a-58c9-b487-eea2ac6d4846/scratchpad/out2/3_white.png">    </p:cNvPr>
+          <p:cNvPr id="7" name="c size0" descr="/tmp/claude-0/-home-user-otterlee/54e04198-701a-58c9-b487-eea2ac6d4846/scratchpad/out3/c_white.png">    </p:cNvPr>
           <p:cNvPicPr>
             <a:picLocks noChangeAspect="1"/>
           </p:cNvPicPr>
@@ -3520,7 +3672,7 @@
       </p:pic>
       <p:pic>
         <p:nvPicPr>
-          <p:cNvPr id="8" name="3 size1" descr="/tmp/claude-0/-home-user-otterlee/54e04198-701a-58c9-b487-eea2ac6d4846/scratchpad/out2/3_white.png">    </p:cNvPr>
+          <p:cNvPr id="8" name="c size1" descr="/tmp/claude-0/-home-user-otterlee/54e04198-701a-58c9-b487-eea2ac6d4846/scratchpad/out3/c_white.png">    </p:cNvPr>
           <p:cNvPicPr>
             <a:picLocks noChangeAspect="1"/>
           </p:cNvPicPr>
@@ -3544,7 +3696,7 @@
       </p:pic>
       <p:pic>
         <p:nvPicPr>
-          <p:cNvPr id="9" name="3 size2" descr="/tmp/claude-0/-home-user-otterlee/54e04198-701a-58c9-b487-eea2ac6d4846/scratchpad/out2/3_white.png">    </p:cNvPr>
+          <p:cNvPr id="9" name="c size2" descr="/tmp/claude-0/-home-user-otterlee/54e04198-701a-58c9-b487-eea2ac6d4846/scratchpad/out3/c_white.png">    </p:cNvPr>
           <p:cNvPicPr>
             <a:picLocks noChangeAspect="1"/>
           </p:cNvPicPr>
@@ -3665,7 +3817,7 @@
                 <a:ea typeface="Pretendard" pitchFamily="34" charset="-122"/>
                 <a:cs typeface="Pretendard" pitchFamily="34" charset="-120"/>
               </a:rPr>
-              <a:t>움직임과 확산의 느낌. 점이 퍼져가는 캠페인의 성격과 맞습니다.</a:t>
+              <a:t>나무 모양은 유지하면서 격자 느낌이 가장 많이 사라집니다.</a:t>
             </a:r>
             <a:endParaRPr lang="en-US" sz="1300" dirty="0"/>
           </a:p>
@@ -3736,7 +3888,7 @@
                 <a:ea typeface="Pretendard" pitchFamily="34" charset="-122"/>
                 <a:cs typeface="Pretendard" pitchFamily="34" charset="-120"/>
               </a:rPr>
-              <a:t>4안 — 나무와 숲</a:t>
+              <a:t>1-4  줄기를 자유롭게</a:t>
             </a:r>
             <a:endParaRPr lang="en-US" sz="2000" dirty="0"/>
           </a:p>
@@ -3775,7 +3927,7 @@
                 <a:ea typeface="Pretendard" pitchFamily="34" charset="-122"/>
                 <a:cs typeface="Pretendard" pitchFamily="34" charset="-120"/>
               </a:rPr>
-              <a:t>같은 모양의 나무 세 그루. 큰 나무 하나와 작은 나무 둘이 모여 숲이 됩니다.</a:t>
+              <a:t>수관은 1안 수준으로 두고, 줄기 점을 아래로 갈수록 작게 하며 살짝 기울였습니다.</a:t>
             </a:r>
             <a:endParaRPr lang="en-US" sz="1200" dirty="0"/>
           </a:p>
@@ -3783,7 +3935,7 @@
       </p:sp>
       <p:pic>
         <p:nvPicPr>
-          <p:cNvPr id="4" name="4 green" descr="/tmp/claude-0/-home-user-otterlee/54e04198-701a-58c9-b487-eea2ac6d4846/scratchpad/out2/4_green.png">    </p:cNvPr>
+          <p:cNvPr id="4" name="d green" descr="/tmp/claude-0/-home-user-otterlee/54e04198-701a-58c9-b487-eea2ac6d4846/scratchpad/out3/d_green.png">    </p:cNvPr>
           <p:cNvPicPr>
             <a:picLocks noChangeAspect="1"/>
           </p:cNvPicPr>
@@ -3807,7 +3959,7 @@
       </p:pic>
       <p:pic>
         <p:nvPicPr>
-          <p:cNvPr id="5" name="4 white" descr="/tmp/claude-0/-home-user-otterlee/54e04198-701a-58c9-b487-eea2ac6d4846/scratchpad/out2/4_white.png">    </p:cNvPr>
+          <p:cNvPr id="5" name="d white" descr="/tmp/claude-0/-home-user-otterlee/54e04198-701a-58c9-b487-eea2ac6d4846/scratchpad/out3/d_white.png">    </p:cNvPr>
           <p:cNvPicPr>
             <a:picLocks noChangeAspect="1"/>
           </p:cNvPicPr>
@@ -3831,7 +3983,7 @@
       </p:pic>
       <p:pic>
         <p:nvPicPr>
-          <p:cNvPr id="6" name="4 lockup" descr="/tmp/claude-0/-home-user-otterlee/54e04198-701a-58c9-b487-eea2ac6d4846/scratchpad/out2/4_lockup.png">    </p:cNvPr>
+          <p:cNvPr id="6" name="d lockup" descr="/tmp/claude-0/-home-user-otterlee/54e04198-701a-58c9-b487-eea2ac6d4846/scratchpad/out3/d_lockup.png">    </p:cNvPr>
           <p:cNvPicPr>
             <a:picLocks noChangeAspect="1"/>
           </p:cNvPicPr>
@@ -3855,7 +4007,7 @@
       </p:pic>
       <p:pic>
         <p:nvPicPr>
-          <p:cNvPr id="7" name="4 size0" descr="/tmp/claude-0/-home-user-otterlee/54e04198-701a-58c9-b487-eea2ac6d4846/scratchpad/out2/4_white.png">    </p:cNvPr>
+          <p:cNvPr id="7" name="d size0" descr="/tmp/claude-0/-home-user-otterlee/54e04198-701a-58c9-b487-eea2ac6d4846/scratchpad/out3/d_white.png">    </p:cNvPr>
           <p:cNvPicPr>
             <a:picLocks noChangeAspect="1"/>
           </p:cNvPicPr>
@@ -3879,7 +4031,7 @@
       </p:pic>
       <p:pic>
         <p:nvPicPr>
-          <p:cNvPr id="8" name="4 size1" descr="/tmp/claude-0/-home-user-otterlee/54e04198-701a-58c9-b487-eea2ac6d4846/scratchpad/out2/4_white.png">    </p:cNvPr>
+          <p:cNvPr id="8" name="d size1" descr="/tmp/claude-0/-home-user-otterlee/54e04198-701a-58c9-b487-eea2ac6d4846/scratchpad/out3/d_white.png">    </p:cNvPr>
           <p:cNvPicPr>
             <a:picLocks noChangeAspect="1"/>
           </p:cNvPicPr>
@@ -3903,7 +4055,7 @@
       </p:pic>
       <p:pic>
         <p:nvPicPr>
-          <p:cNvPr id="9" name="4 size2" descr="/tmp/claude-0/-home-user-otterlee/54e04198-701a-58c9-b487-eea2ac6d4846/scratchpad/out2/4_white.png">    </p:cNvPr>
+          <p:cNvPr id="9" name="d size2" descr="/tmp/claude-0/-home-user-otterlee/54e04198-701a-58c9-b487-eea2ac6d4846/scratchpad/out3/d_white.png">    </p:cNvPr>
           <p:cNvPicPr>
             <a:picLocks noChangeAspect="1"/>
           </p:cNvPicPr>
@@ -4024,7 +4176,7 @@
                 <a:ea typeface="Pretendard" pitchFamily="34" charset="-122"/>
                 <a:cs typeface="Pretendard" pitchFamily="34" charset="-120"/>
               </a:rPr>
-              <a:t>나무 한 그루에서 숲으로 가는 이야기를 담습니다. 작게 줄이면 점이 뭉칠 수 있어 확인이 필요합니다.</a:t>
+              <a:t>자라나는 줄기의 느낌. 수관은 거의 그대로입니다.</a:t>
             </a:r>
             <a:endParaRPr lang="en-US" sz="1300" dirty="0"/>
           </a:p>
@@ -4041,6 +4193,365 @@
 <file path=ppt/slides/slide8.xml><?xml version="1.0" encoding="utf-8"?>
 <p:sld xmlns:a="http://schemas.openxmlformats.org/drawingml/2006/main" xmlns:r="http://schemas.openxmlformats.org/officeDocument/2006/relationships" xmlns:p="http://schemas.openxmlformats.org/presentationml/2006/main">
   <p:cSld name="Slide 8">
+    <p:bg>
+      <p:bgPr>
+        <a:solidFill>
+          <a:srgbClr val="FFFFFF"/>
+        </a:solidFill>
+      </p:bgPr>
+    </p:bg>
+    <p:spTree>
+      <p:nvGrpSpPr>
+        <p:cNvPr id="1" name=""/>
+        <p:cNvGrpSpPr/>
+        <p:nvPr/>
+      </p:nvGrpSpPr>
+      <p:grpSpPr>
+        <a:xfrm>
+          <a:off x="0" y="0"/>
+          <a:ext cx="0" cy="0"/>
+          <a:chOff x="0" y="0"/>
+          <a:chExt cx="0" cy="0"/>
+        </a:xfrm>
+      </p:grpSpPr>
+      <p:sp>
+        <p:nvSpPr>
+          <p:cNvPr id="2" name="Text 0"/>
+          <p:cNvSpPr txBox="1"/>
+          <p:nvPr/>
+        </p:nvSpPr>
+        <p:spPr>
+          <a:xfrm>
+            <a:off x="457200" y="292608"/>
+            <a:ext cx="8229600" cy="457200"/>
+          </a:xfrm>
+          <a:prstGeom prst="rect">
+            <a:avLst/>
+          </a:prstGeom>
+          <a:noFill/>
+          <a:ln/>
+        </p:spPr>
+        <p:txBody>
+          <a:bodyPr wrap="square" lIns="0" tIns="0" rIns="0" bIns="0" rtlCol="0" anchor="ctr"/>
+          <a:lstStyle/>
+          <a:p>
+            <a:pPr indent="0" marL="0">
+              <a:buNone/>
+            </a:pPr>
+            <a:r>
+              <a:rPr lang="en-US" sz="2000" b="1" dirty="0">
+                <a:solidFill>
+                  <a:srgbClr val="16211C"/>
+                </a:solidFill>
+                <a:latin typeface="Pretendard" pitchFamily="34" charset="0"/>
+                <a:ea typeface="Pretendard" pitchFamily="34" charset="-122"/>
+                <a:cs typeface="Pretendard" pitchFamily="34" charset="-120"/>
+              </a:rPr>
+              <a:t>1-5  가장자리 비우기</a:t>
+            </a:r>
+            <a:endParaRPr lang="en-US" sz="2000" dirty="0"/>
+          </a:p>
+        </p:txBody>
+      </p:sp>
+      <p:sp>
+        <p:nvSpPr>
+          <p:cNvPr id="3" name="Text 1"/>
+          <p:cNvSpPr txBox="1"/>
+          <p:nvPr/>
+        </p:nvSpPr>
+        <p:spPr>
+          <a:xfrm>
+            <a:off x="457200" y="731520"/>
+            <a:ext cx="8229600" cy="274320"/>
+          </a:xfrm>
+          <a:prstGeom prst="rect">
+            <a:avLst/>
+          </a:prstGeom>
+          <a:noFill/>
+          <a:ln/>
+        </p:spPr>
+        <p:txBody>
+          <a:bodyPr wrap="square" lIns="0" tIns="0" rIns="0" bIns="0" rtlCol="0" anchor="ctr"/>
+          <a:lstStyle/>
+          <a:p>
+            <a:pPr indent="0" marL="0">
+              <a:buNone/>
+            </a:pPr>
+            <a:r>
+              <a:rPr lang="en-US" sz="1200" dirty="0">
+                <a:solidFill>
+                  <a:srgbClr val="6B7A72"/>
+                </a:solidFill>
+                <a:latin typeface="Pretendard" pitchFamily="34" charset="0"/>
+                <a:ea typeface="Pretendard" pitchFamily="34" charset="-122"/>
+                <a:cs typeface="Pretendard" pitchFamily="34" charset="-120"/>
+              </a:rPr>
+              <a:t>수관 가장자리 점 몇 개를 빼고, 밖에 작은 점 둘을 떨어뜨렸습니다.</a:t>
+            </a:r>
+            <a:endParaRPr lang="en-US" sz="1200" dirty="0"/>
+          </a:p>
+        </p:txBody>
+      </p:sp>
+      <p:pic>
+        <p:nvPicPr>
+          <p:cNvPr id="4" name="e green" descr="/tmp/claude-0/-home-user-otterlee/54e04198-701a-58c9-b487-eea2ac6d4846/scratchpad/out3/e_green.png">    </p:cNvPr>
+          <p:cNvPicPr>
+            <a:picLocks noChangeAspect="1"/>
+          </p:cNvPicPr>
+          <p:nvPr/>
+        </p:nvPicPr>
+        <p:blipFill>
+          <a:blip r:embed="rId1"/>
+          <a:stretch>
+            <a:fillRect/>
+          </a:stretch>
+        </p:blipFill>
+        <p:spPr>
+          <a:xfrm>
+            <a:off x="457200" y="1188720"/>
+            <a:ext cx="2926080" cy="2926080"/>
+          </a:xfrm>
+          <a:prstGeom prst="rect">
+            <a:avLst/>
+          </a:prstGeom>
+        </p:spPr>
+      </p:pic>
+      <p:pic>
+        <p:nvPicPr>
+          <p:cNvPr id="5" name="e white" descr="/tmp/claude-0/-home-user-otterlee/54e04198-701a-58c9-b487-eea2ac6d4846/scratchpad/out3/e_white.png">    </p:cNvPr>
+          <p:cNvPicPr>
+            <a:picLocks noChangeAspect="1"/>
+          </p:cNvPicPr>
+          <p:nvPr/>
+        </p:nvPicPr>
+        <p:blipFill>
+          <a:blip r:embed="rId2"/>
+          <a:stretch>
+            <a:fillRect/>
+          </a:stretch>
+        </p:blipFill>
+        <p:spPr>
+          <a:xfrm>
+            <a:off x="3566160" y="1188720"/>
+            <a:ext cx="1463040" cy="1463040"/>
+          </a:xfrm>
+          <a:prstGeom prst="rect">
+            <a:avLst/>
+          </a:prstGeom>
+        </p:spPr>
+      </p:pic>
+      <p:pic>
+        <p:nvPicPr>
+          <p:cNvPr id="6" name="e lockup" descr="/tmp/claude-0/-home-user-otterlee/54e04198-701a-58c9-b487-eea2ac6d4846/scratchpad/out3/e_lockup.png">    </p:cNvPr>
+          <p:cNvPicPr>
+            <a:picLocks noChangeAspect="1"/>
+          </p:cNvPicPr>
+          <p:nvPr/>
+        </p:nvPicPr>
+        <p:blipFill>
+          <a:blip r:embed="rId3"/>
+          <a:stretch>
+            <a:fillRect/>
+          </a:stretch>
+        </p:blipFill>
+        <p:spPr>
+          <a:xfrm>
+            <a:off x="5212080" y="1188720"/>
+            <a:ext cx="3474720" cy="1411834"/>
+          </a:xfrm>
+          <a:prstGeom prst="rect">
+            <a:avLst/>
+          </a:prstGeom>
+        </p:spPr>
+      </p:pic>
+      <p:pic>
+        <p:nvPicPr>
+          <p:cNvPr id="7" name="e size0" descr="/tmp/claude-0/-home-user-otterlee/54e04198-701a-58c9-b487-eea2ac6d4846/scratchpad/out3/e_white.png">    </p:cNvPr>
+          <p:cNvPicPr>
+            <a:picLocks noChangeAspect="1"/>
+          </p:cNvPicPr>
+          <p:nvPr/>
+        </p:nvPicPr>
+        <p:blipFill>
+          <a:blip r:embed="rId4"/>
+          <a:stretch>
+            <a:fillRect/>
+          </a:stretch>
+        </p:blipFill>
+        <p:spPr>
+          <a:xfrm>
+            <a:off x="3566160" y="3063240"/>
+            <a:ext cx="274320" cy="274320"/>
+          </a:xfrm>
+          <a:prstGeom prst="rect">
+            <a:avLst/>
+          </a:prstGeom>
+        </p:spPr>
+      </p:pic>
+      <p:pic>
+        <p:nvPicPr>
+          <p:cNvPr id="8" name="e size1" descr="/tmp/claude-0/-home-user-otterlee/54e04198-701a-58c9-b487-eea2ac6d4846/scratchpad/out3/e_white.png">    </p:cNvPr>
+          <p:cNvPicPr>
+            <a:picLocks noChangeAspect="1"/>
+          </p:cNvPicPr>
+          <p:nvPr/>
+        </p:nvPicPr>
+        <p:blipFill>
+          <a:blip r:embed="rId5"/>
+          <a:stretch>
+            <a:fillRect/>
+          </a:stretch>
+        </p:blipFill>
+        <p:spPr>
+          <a:xfrm>
+            <a:off x="3977640" y="2994660"/>
+            <a:ext cx="411480" cy="411480"/>
+          </a:xfrm>
+          <a:prstGeom prst="rect">
+            <a:avLst/>
+          </a:prstGeom>
+        </p:spPr>
+      </p:pic>
+      <p:pic>
+        <p:nvPicPr>
+          <p:cNvPr id="9" name="e size2" descr="/tmp/claude-0/-home-user-otterlee/54e04198-701a-58c9-b487-eea2ac6d4846/scratchpad/out3/e_white.png">    </p:cNvPr>
+          <p:cNvPicPr>
+            <a:picLocks noChangeAspect="1"/>
+          </p:cNvPicPr>
+          <p:nvPr/>
+        </p:nvPicPr>
+        <p:blipFill>
+          <a:blip r:embed="rId6"/>
+          <a:stretch>
+            <a:fillRect/>
+          </a:stretch>
+        </p:blipFill>
+        <p:spPr>
+          <a:xfrm>
+            <a:off x="4480560" y="2880360"/>
+            <a:ext cx="640080" cy="640080"/>
+          </a:xfrm>
+          <a:prstGeom prst="rect">
+            <a:avLst/>
+          </a:prstGeom>
+        </p:spPr>
+      </p:pic>
+      <p:sp>
+        <p:nvSpPr>
+          <p:cNvPr id="10" name="Text 2"/>
+          <p:cNvSpPr txBox="1"/>
+          <p:nvPr/>
+        </p:nvSpPr>
+        <p:spPr>
+          <a:xfrm>
+            <a:off x="3566160" y="3840480"/>
+            <a:ext cx="1645920" cy="228600"/>
+          </a:xfrm>
+          <a:prstGeom prst="rect">
+            <a:avLst/>
+          </a:prstGeom>
+          <a:noFill/>
+          <a:ln/>
+        </p:spPr>
+        <p:txBody>
+          <a:bodyPr wrap="square" lIns="0" tIns="0" rIns="0" bIns="0" rtlCol="0" anchor="ctr"/>
+          <a:lstStyle/>
+          <a:p>
+            <a:pPr indent="0" marL="0">
+              <a:buNone/>
+            </a:pPr>
+            <a:r>
+              <a:rPr lang="en-US" sz="1000" dirty="0">
+                <a:solidFill>
+                  <a:srgbClr val="6B7A72"/>
+                </a:solidFill>
+                <a:latin typeface="Pretendard" pitchFamily="34" charset="0"/>
+                <a:ea typeface="Pretendard" pitchFamily="34" charset="-122"/>
+                <a:cs typeface="Pretendard" pitchFamily="34" charset="-120"/>
+              </a:rPr>
+              <a:t>축소 확인</a:t>
+            </a:r>
+            <a:endParaRPr lang="en-US" sz="1000" dirty="0"/>
+          </a:p>
+        </p:txBody>
+      </p:sp>
+      <p:sp>
+        <p:nvSpPr>
+          <p:cNvPr id="11" name="note card"/>
+          <p:cNvSpPr/>
+          <p:nvPr/>
+        </p:nvSpPr>
+        <p:spPr>
+          <a:xfrm>
+            <a:off x="5212080" y="2880360"/>
+            <a:ext cx="3474720" cy="1234440"/>
+          </a:xfrm>
+          <a:prstGeom prst="roundRect">
+            <a:avLst>
+              <a:gd name="adj" fmla="val 5926"/>
+            </a:avLst>
+          </a:prstGeom>
+          <a:solidFill>
+            <a:srgbClr val="EAF7EE"/>
+          </a:solidFill>
+          <a:ln w="12700">
+            <a:solidFill>
+              <a:srgbClr val="EAF7EE"/>
+            </a:solidFill>
+            <a:prstDash val="solid"/>
+          </a:ln>
+        </p:spPr>
+      </p:sp>
+      <p:sp>
+        <p:nvSpPr>
+          <p:cNvPr id="12" name="Text 4"/>
+          <p:cNvSpPr txBox="1"/>
+          <p:nvPr/>
+        </p:nvSpPr>
+        <p:spPr>
+          <a:xfrm>
+            <a:off x="5394960" y="2880360"/>
+            <a:ext cx="3108960" cy="1234440"/>
+          </a:xfrm>
+          <a:prstGeom prst="rect">
+            <a:avLst/>
+          </a:prstGeom>
+          <a:noFill/>
+          <a:ln/>
+        </p:spPr>
+        <p:txBody>
+          <a:bodyPr wrap="square" lIns="0" tIns="0" rIns="0" bIns="0" rtlCol="0" anchor="ctr"/>
+          <a:lstStyle/>
+          <a:p>
+            <a:pPr indent="0" marL="0">
+              <a:buNone/>
+            </a:pPr>
+            <a:r>
+              <a:rPr lang="en-US" sz="1300" dirty="0">
+                <a:solidFill>
+                  <a:srgbClr val="16211C"/>
+                </a:solidFill>
+                <a:latin typeface="Pretendard" pitchFamily="34" charset="0"/>
+                <a:ea typeface="Pretendard" pitchFamily="34" charset="-122"/>
+                <a:cs typeface="Pretendard" pitchFamily="34" charset="-120"/>
+              </a:rPr>
+              <a:t>바람에 날리는 느낌을 아주 조금만 더했습니다.</a:t>
+            </a:r>
+            <a:endParaRPr lang="en-US" sz="1300" dirty="0"/>
+          </a:p>
+        </p:txBody>
+      </p:sp>
+    </p:spTree>
+  </p:cSld>
+  <p:clrMapOvr>
+    <a:masterClrMapping/>
+  </p:clrMapOvr>
+</p:sld>
+</file>
+
+<file path=ppt/slides/slide9.xml><?xml version="1.0" encoding="utf-8"?>
+<p:sld xmlns:a="http://schemas.openxmlformats.org/drawingml/2006/main" xmlns:r="http://schemas.openxmlformats.org/officeDocument/2006/relationships" xmlns:p="http://schemas.openxmlformats.org/presentationml/2006/main">
+  <p:cSld name="Slide 9">
     <p:bg>
       <p:bgPr>
         <a:solidFill>

</xml_diff>

<commit_message>
BI symbol variations: keep option 1, add triangle forest, two mountains, fingerprint
Co-Authored-By: Claude Sonnet 5.5 <noreply@anthropic.com>
Claude-Session: https://claude.ai/code/session_01XSVwnKProgLsAGnFXzc9nT
</commit_message>
<xml_diff>
--- a/bi/zambia-variations-v3/plant-zambia-bi-variations-v3.pptx
+++ b/bi/zambia-variations-v3/plant-zambia-bi-variations-v3.pptx
@@ -13,10 +13,9 @@
     <p:sldId id="261" r:id="rId7"/>
     <p:sldId id="262" r:id="rId8"/>
     <p:sldId id="263" r:id="rId9"/>
-    <p:sldId id="264" r:id="rId10"/>
   </p:sldIdLst>
   <p:notesMasterIdLst>
-    <p:notesMasterId r:id="rId11"/>
+    <p:notesMasterId r:id="rId10"/>
   </p:notesMasterIdLst>
   <p:sldSz cx="9144000" cy="5143500"/>
   <p:notesSz cx="5143500" cy="9144000"/>
@@ -1150,94 +1149,6 @@
             <a:fld id="{F7021451-1387-4CA6-816F-3879F97B5CBC}" type="slidenum">
               <a:rPr lang="en-US"/>
               <a:t>8</a:t>
-            </a:fld>
-            <a:endParaRPr lang="en-US"/>
-          </a:p>
-        </p:txBody>
-      </p:sp>
-    </p:spTree>
-    <p:extLst>
-      <p:ext uri="{BB962C8B-B14F-4D97-AF65-F5344CB8AC3E}">
-        <p14:creationId xmlns:p14="http://schemas.microsoft.com/office/powerpoint/2010/main" val="1024086991"/>
-      </p:ext>
-    </p:extLst>
-  </p:cSld>
-  <p:clrMapOvr>
-    <a:masterClrMapping/>
-  </p:clrMapOvr>
-</p:notes>
-</file>
-
-<file path=ppt/notesSlides/notesSlide9.xml><?xml version="1.0" encoding="utf-8"?>
-<p:notes xmlns:a="http://schemas.openxmlformats.org/drawingml/2006/main" xmlns:r="http://schemas.openxmlformats.org/officeDocument/2006/relationships" xmlns:p="http://schemas.openxmlformats.org/presentationml/2006/main">
-  <p:cSld>
-    <p:spTree>
-      <p:nvGrpSpPr>
-        <p:cNvPr id="1" name=""/>
-        <p:cNvGrpSpPr/>
-        <p:nvPr/>
-      </p:nvGrpSpPr>
-      <p:grpSpPr>
-        <a:xfrm>
-          <a:off x="0" y="0"/>
-          <a:ext cx="0" cy="0"/>
-          <a:chOff x="0" y="0"/>
-          <a:chExt cx="0" cy="0"/>
-        </a:xfrm>
-      </p:grpSpPr>
-      <p:sp>
-        <p:nvSpPr>
-          <p:cNvPr id="2" name="Slide Image Placeholder 1"/>
-          <p:cNvSpPr>
-            <a:spLocks noGrp="1" noRot="1" noChangeAspect="1"/>
-          </p:cNvSpPr>
-          <p:nvPr>
-            <p:ph type="sldImg"/>
-          </p:nvPr>
-        </p:nvSpPr>
-        <p:spPr/>
-      </p:sp>
-      <p:sp>
-        <p:nvSpPr>
-          <p:cNvPr id="3" name="Notes Placeholder 2"/>
-          <p:cNvSpPr>
-            <a:spLocks noGrp="1"/>
-          </p:cNvSpPr>
-          <p:nvPr>
-            <p:ph type="body" idx="1"/>
-          </p:nvPr>
-        </p:nvSpPr>
-        <p:spPr/>
-        <p:txBody>
-          <a:bodyPr/>
-          <a:lstStyle/>
-          <a:p>
-            <a:r>
-              <a:rPr lang="en-US" dirty="0"/>
-              <a:t/>
-            </a:r>
-            <a:endParaRPr lang="en-US" dirty="0"/>
-          </a:p>
-        </p:txBody>
-      </p:sp>
-      <p:sp>
-        <p:nvSpPr>
-          <p:cNvPr id="4" name="Slide Number Placeholder 3"/>
-          <p:cNvSpPr>
-            <a:spLocks noGrp="1"/>
-          </p:cNvSpPr>
-          <p:nvPr>
-            <p:ph type="sldNum" sz="quarter" idx="10"/>
-          </p:nvPr>
-        </p:nvSpPr>
-        <p:spPr/>
-        <p:txBody>
-          <a:bodyPr/>
-          <a:lstStyle/>
-          <a:p>
-            <a:fld id="{F7021451-1387-4CA6-816F-3879F97B5CBC}" type="slidenum">
-              <a:rPr lang="en-US"/>
-              <a:t>9</a:t>
             </a:fld>
             <a:endParaRPr lang="en-US"/>
           </a:p>
@@ -1589,7 +1500,7 @@
       </p:grpSpPr>
       <p:pic>
         <p:nvPicPr>
-          <p:cNvPr id="2" name="cover symbol" descr="/tmp/claude-0/-home-user-otterlee/54e04198-701a-58c9-b487-eea2ac6d4846/scratchpad/out3/a_monowhite.png">    </p:cNvPr>
+          <p:cNvPr id="2" name="cover symbol" descr="/tmp/claude-0/-home-user-otterlee/54e04198-701a-58c9-b487-eea2ac6d4846/scratchpad/out4/1_monowhite.png">    </p:cNvPr>
           <p:cNvPicPr>
             <a:picLocks noChangeAspect="1"/>
           </p:cNvPicPr>
@@ -1722,7 +1633,7 @@
                 <a:ea typeface="Pretendard" pitchFamily="34" charset="-122"/>
                 <a:cs typeface="Pretendard" pitchFamily="34" charset="-120"/>
               </a:rPr>
-              <a:t>(사)산과자연의친구 · 2026. 10 · v3 (피드백 반영 5안)</a:t>
+              <a:t>(사)산과자연의친구 · 2026. 10 · v3 (피드백 반영 4안)</a:t>
             </a:r>
             <a:endParaRPr lang="en-US" sz="1100" dirty="0"/>
           </a:p>
@@ -2276,7 +2187,7 @@
                 <a:ea typeface="Pretendard" pitchFamily="34" charset="-122"/>
                 <a:cs typeface="Pretendard" pitchFamily="34" charset="-120"/>
               </a:rPr>
-              <a:t>5가지 변형을 만들어 나중에 택일</a:t>
+              <a:t>4가지 변형을 만들어 나중에 택일</a:t>
             </a:r>
             <a:endParaRPr lang="en-US" sz="1300" dirty="0"/>
           </a:p>
@@ -2347,7 +2258,7 @@
                 <a:ea typeface="Pretendard" pitchFamily="34" charset="-122"/>
                 <a:cs typeface="Pretendard" pitchFamily="34" charset="-120"/>
               </a:rPr>
-              <a:t>1안 기준 변형 한눈에 보기</a:t>
+              <a:t>변형안 한눈에 보기</a:t>
             </a:r>
             <a:endParaRPr lang="en-US" sz="2000" dirty="0"/>
           </a:p>
@@ -2394,7 +2305,7 @@
       </p:sp>
       <p:pic>
         <p:nvPicPr>
-          <p:cNvPr id="4" name="overview a" descr="/tmp/claude-0/-home-user-otterlee/54e04198-701a-58c9-b487-eea2ac6d4846/scratchpad/out3/a_green.png">    </p:cNvPr>
+          <p:cNvPr id="4" name="overview 1" descr="/tmp/claude-0/-home-user-otterlee/54e04198-701a-58c9-b487-eea2ac6d4846/scratchpad/out4/1_green.png">    </p:cNvPr>
           <p:cNvPicPr>
             <a:picLocks noChangeAspect="1"/>
           </p:cNvPicPr>
@@ -2409,7 +2320,7 @@
         <p:spPr>
           <a:xfrm>
             <a:off x="457200" y="1371600"/>
-            <a:ext cx="1508760" cy="1508760"/>
+            <a:ext cx="1828800" cy="1828800"/>
           </a:xfrm>
           <a:prstGeom prst="rect">
             <a:avLst/>
@@ -2424,8 +2335,8 @@
         </p:nvSpPr>
         <p:spPr>
           <a:xfrm>
-            <a:off x="457200" y="3017520"/>
-            <a:ext cx="1508760" cy="548640"/>
+            <a:off x="457200" y="3337560"/>
+            <a:ext cx="1828800" cy="365760"/>
           </a:xfrm>
           <a:prstGeom prst="rect">
             <a:avLst/>
@@ -2449,7 +2360,7 @@
                 <a:ea typeface="Pretendard" pitchFamily="34" charset="-122"/>
                 <a:cs typeface="Pretendard" pitchFamily="34" charset="-120"/>
               </a:rPr>
-              <a:t>1-1  기준안</a:t>
+              <a:t>1안  나무</a:t>
             </a:r>
             <a:endParaRPr lang="en-US" sz="1200" dirty="0"/>
           </a:p>
@@ -2457,7 +2368,7 @@
       </p:sp>
       <p:pic>
         <p:nvPicPr>
-          <p:cNvPr id="6" name="overview b" descr="/tmp/claude-0/-home-user-otterlee/54e04198-701a-58c9-b487-eea2ac6d4846/scratchpad/out3/b_green.png">    </p:cNvPr>
+          <p:cNvPr id="6" name="overview 2" descr="/tmp/claude-0/-home-user-otterlee/54e04198-701a-58c9-b487-eea2ac6d4846/scratchpad/out4/2_green.png">    </p:cNvPr>
           <p:cNvPicPr>
             <a:picLocks noChangeAspect="1"/>
           </p:cNvPicPr>
@@ -2471,8 +2382,8 @@
         </p:blipFill>
         <p:spPr>
           <a:xfrm>
-            <a:off x="2103120" y="1371600"/>
-            <a:ext cx="1508760" cy="1508760"/>
+            <a:off x="2560320" y="1371600"/>
+            <a:ext cx="1828800" cy="1828800"/>
           </a:xfrm>
           <a:prstGeom prst="rect">
             <a:avLst/>
@@ -2487,8 +2398,8 @@
         </p:nvSpPr>
         <p:spPr>
           <a:xfrm>
-            <a:off x="2103120" y="3017520"/>
-            <a:ext cx="1508760" cy="548640"/>
+            <a:off x="2560320" y="3337560"/>
+            <a:ext cx="1828800" cy="365760"/>
           </a:xfrm>
           <a:prstGeom prst="rect">
             <a:avLst/>
@@ -2512,7 +2423,7 @@
                 <a:ea typeface="Pretendard" pitchFamily="34" charset="-122"/>
                 <a:cs typeface="Pretendard" pitchFamily="34" charset="-120"/>
               </a:rPr>
-              <a:t>1-2  크기 차이 크게</a:t>
+              <a:t>2안  숲(삼각형)</a:t>
             </a:r>
             <a:endParaRPr lang="en-US" sz="1200" dirty="0"/>
           </a:p>
@@ -2520,7 +2431,7 @@
       </p:sp>
       <p:pic>
         <p:nvPicPr>
-          <p:cNvPr id="8" name="overview c" descr="/tmp/claude-0/-home-user-otterlee/54e04198-701a-58c9-b487-eea2ac6d4846/scratchpad/out3/c_green.png">    </p:cNvPr>
+          <p:cNvPr id="8" name="overview 3" descr="/tmp/claude-0/-home-user-otterlee/54e04198-701a-58c9-b487-eea2ac6d4846/scratchpad/out4/3_green.png">    </p:cNvPr>
           <p:cNvPicPr>
             <a:picLocks noChangeAspect="1"/>
           </p:cNvPicPr>
@@ -2534,8 +2445,8 @@
         </p:blipFill>
         <p:spPr>
           <a:xfrm>
-            <a:off x="3749040" y="1371600"/>
-            <a:ext cx="1508760" cy="1508760"/>
+            <a:off x="4663440" y="1371600"/>
+            <a:ext cx="1828800" cy="1828800"/>
           </a:xfrm>
           <a:prstGeom prst="rect">
             <a:avLst/>
@@ -2550,8 +2461,8 @@
         </p:nvSpPr>
         <p:spPr>
           <a:xfrm>
-            <a:off x="3749040" y="3017520"/>
-            <a:ext cx="1508760" cy="548640"/>
+            <a:off x="4663440" y="3337560"/>
+            <a:ext cx="1828800" cy="365760"/>
           </a:xfrm>
           <a:prstGeom prst="rect">
             <a:avLst/>
@@ -2575,7 +2486,7 @@
                 <a:ea typeface="Pretendard" pitchFamily="34" charset="-122"/>
                 <a:cs typeface="Pretendard" pitchFamily="34" charset="-120"/>
               </a:rPr>
-              <a:t>1-3  위치 더 흩트리기</a:t>
+              <a:t>3안  산 두 개</a:t>
             </a:r>
             <a:endParaRPr lang="en-US" sz="1200" dirty="0"/>
           </a:p>
@@ -2583,7 +2494,7 @@
       </p:sp>
       <p:pic>
         <p:nvPicPr>
-          <p:cNvPr id="10" name="overview d" descr="/tmp/claude-0/-home-user-otterlee/54e04198-701a-58c9-b487-eea2ac6d4846/scratchpad/out3/d_green.png">    </p:cNvPr>
+          <p:cNvPr id="10" name="overview 4" descr="/tmp/claude-0/-home-user-otterlee/54e04198-701a-58c9-b487-eea2ac6d4846/scratchpad/out4/4_green.png">    </p:cNvPr>
           <p:cNvPicPr>
             <a:picLocks noChangeAspect="1"/>
           </p:cNvPicPr>
@@ -2597,8 +2508,8 @@
         </p:blipFill>
         <p:spPr>
           <a:xfrm>
-            <a:off x="5394960" y="1371600"/>
-            <a:ext cx="1508760" cy="1508760"/>
+            <a:off x="6766560" y="1371600"/>
+            <a:ext cx="1828800" cy="1828800"/>
           </a:xfrm>
           <a:prstGeom prst="rect">
             <a:avLst/>
@@ -2613,8 +2524,8 @@
         </p:nvSpPr>
         <p:spPr>
           <a:xfrm>
-            <a:off x="5394960" y="3017520"/>
-            <a:ext cx="1508760" cy="548640"/>
+            <a:off x="6766560" y="3337560"/>
+            <a:ext cx="1828800" cy="365760"/>
           </a:xfrm>
           <a:prstGeom prst="rect">
             <a:avLst/>
@@ -2638,78 +2549,15 @@
                 <a:ea typeface="Pretendard" pitchFamily="34" charset="-122"/>
                 <a:cs typeface="Pretendard" pitchFamily="34" charset="-120"/>
               </a:rPr>
-              <a:t>1-4  줄기를 자유롭게</a:t>
+              <a:t>4안  지문</a:t>
             </a:r>
             <a:endParaRPr lang="en-US" sz="1200" dirty="0"/>
           </a:p>
         </p:txBody>
       </p:sp>
-      <p:pic>
-        <p:nvPicPr>
-          <p:cNvPr id="12" name="overview e" descr="/tmp/claude-0/-home-user-otterlee/54e04198-701a-58c9-b487-eea2ac6d4846/scratchpad/out3/e_green.png">    </p:cNvPr>
-          <p:cNvPicPr>
-            <a:picLocks noChangeAspect="1"/>
-          </p:cNvPicPr>
-          <p:nvPr/>
-        </p:nvPicPr>
-        <p:blipFill>
-          <a:blip r:embed="rId5"/>
-          <a:stretch>
-            <a:fillRect/>
-          </a:stretch>
-        </p:blipFill>
-        <p:spPr>
-          <a:xfrm>
-            <a:off x="7040880" y="1371600"/>
-            <a:ext cx="1508760" cy="1508760"/>
-          </a:xfrm>
-          <a:prstGeom prst="rect">
-            <a:avLst/>
-          </a:prstGeom>
-        </p:spPr>
-      </p:pic>
-      <p:sp>
-        <p:nvSpPr>
-          <p:cNvPr id="13" name="Text 6"/>
-          <p:cNvSpPr txBox="1"/>
-          <p:nvPr/>
-        </p:nvSpPr>
-        <p:spPr>
-          <a:xfrm>
-            <a:off x="7040880" y="3017520"/>
-            <a:ext cx="1508760" cy="548640"/>
-          </a:xfrm>
-          <a:prstGeom prst="rect">
-            <a:avLst/>
-          </a:prstGeom>
-          <a:noFill/>
-          <a:ln/>
-        </p:spPr>
-        <p:txBody>
-          <a:bodyPr wrap="square" lIns="0" tIns="0" rIns="0" bIns="0" rtlCol="0" anchor="ctr"/>
-          <a:lstStyle/>
-          <a:p>
-            <a:pPr indent="0" marL="0">
-              <a:buNone/>
-            </a:pPr>
-            <a:r>
-              <a:rPr lang="en-US" sz="1200" b="1" dirty="0">
-                <a:solidFill>
-                  <a:srgbClr val="16211C"/>
-                </a:solidFill>
-                <a:latin typeface="Pretendard" pitchFamily="34" charset="0"/>
-                <a:ea typeface="Pretendard" pitchFamily="34" charset="-122"/>
-                <a:cs typeface="Pretendard" pitchFamily="34" charset="-120"/>
-              </a:rPr>
-              <a:t>1-5  가장자리 비우기</a:t>
-            </a:r>
-            <a:endParaRPr lang="en-US" sz="1200" dirty="0"/>
-          </a:p>
-        </p:txBody>
-      </p:sp>
-      <p:sp>
-        <p:nvSpPr>
-          <p:cNvPr id="14" name="Text 7"/>
+      <p:sp>
+        <p:nvSpPr>
+          <p:cNvPr id="12" name="Text 6"/>
           <p:cNvSpPr txBox="1"/>
           <p:nvPr/>
         </p:nvSpPr>
@@ -2740,7 +2588,7 @@
                 <a:ea typeface="Pretendard" pitchFamily="34" charset="-122"/>
                 <a:cs typeface="Pretendard" pitchFamily="34" charset="-120"/>
               </a:rPr>
-              <a:t>모두 점 25개 안팎이고 나무 모양을 유지했습니다. 달라지는 것은 점의 크기와 위치뿐입니다.</a:t>
+              <a:t>1안은 그대로 두고, 2~4안은 형태를 달리했습니다.</a:t>
             </a:r>
             <a:endParaRPr lang="en-US" sz="1200" dirty="0"/>
           </a:p>
@@ -2811,7 +2659,7 @@
                 <a:ea typeface="Pretendard" pitchFamily="34" charset="-122"/>
                 <a:cs typeface="Pretendard" pitchFamily="34" charset="-120"/>
               </a:rPr>
-              <a:t>1-1  기준안</a:t>
+              <a:t>1안  나무</a:t>
             </a:r>
             <a:endParaRPr lang="en-US" sz="2000" dirty="0"/>
           </a:p>
@@ -2850,7 +2698,7 @@
                 <a:ea typeface="Pretendard" pitchFamily="34" charset="-122"/>
                 <a:cs typeface="Pretendard" pitchFamily="34" charset="-120"/>
               </a:rPr>
-              <a:t>앞서 좋다고 하신 1안 그대로입니다. v2의 나무 모양에 점 위치와 크기만 조금 풀었습니다.</a:t>
+              <a:t>앞서 좋다고 하신 1안 그대로입니다. v2의 나무 모양에 점의 위치와 크기만 조금 풀었습니다.</a:t>
             </a:r>
             <a:endParaRPr lang="en-US" sz="1200" dirty="0"/>
           </a:p>
@@ -2858,7 +2706,7 @@
       </p:sp>
       <p:pic>
         <p:nvPicPr>
-          <p:cNvPr id="4" name="a green" descr="/tmp/claude-0/-home-user-otterlee/54e04198-701a-58c9-b487-eea2ac6d4846/scratchpad/out3/a_green.png">    </p:cNvPr>
+          <p:cNvPr id="4" name="1 green" descr="/tmp/claude-0/-home-user-otterlee/54e04198-701a-58c9-b487-eea2ac6d4846/scratchpad/out4/1_green.png">    </p:cNvPr>
           <p:cNvPicPr>
             <a:picLocks noChangeAspect="1"/>
           </p:cNvPicPr>
@@ -2882,7 +2730,7 @@
       </p:pic>
       <p:pic>
         <p:nvPicPr>
-          <p:cNvPr id="5" name="a white" descr="/tmp/claude-0/-home-user-otterlee/54e04198-701a-58c9-b487-eea2ac6d4846/scratchpad/out3/a_white.png">    </p:cNvPr>
+          <p:cNvPr id="5" name="1 white" descr="/tmp/claude-0/-home-user-otterlee/54e04198-701a-58c9-b487-eea2ac6d4846/scratchpad/out4/1_white.png">    </p:cNvPr>
           <p:cNvPicPr>
             <a:picLocks noChangeAspect="1"/>
           </p:cNvPicPr>
@@ -2906,7 +2754,7 @@
       </p:pic>
       <p:pic>
         <p:nvPicPr>
-          <p:cNvPr id="6" name="a lockup" descr="/tmp/claude-0/-home-user-otterlee/54e04198-701a-58c9-b487-eea2ac6d4846/scratchpad/out3/a_lockup.png">    </p:cNvPr>
+          <p:cNvPr id="6" name="1 lockup" descr="/tmp/claude-0/-home-user-otterlee/54e04198-701a-58c9-b487-eea2ac6d4846/scratchpad/out4/1_lockup.png">    </p:cNvPr>
           <p:cNvPicPr>
             <a:picLocks noChangeAspect="1"/>
           </p:cNvPicPr>
@@ -2930,7 +2778,7 @@
       </p:pic>
       <p:pic>
         <p:nvPicPr>
-          <p:cNvPr id="7" name="a size0" descr="/tmp/claude-0/-home-user-otterlee/54e04198-701a-58c9-b487-eea2ac6d4846/scratchpad/out3/a_white.png">    </p:cNvPr>
+          <p:cNvPr id="7" name="1 size0" descr="/tmp/claude-0/-home-user-otterlee/54e04198-701a-58c9-b487-eea2ac6d4846/scratchpad/out4/1_white.png">    </p:cNvPr>
           <p:cNvPicPr>
             <a:picLocks noChangeAspect="1"/>
           </p:cNvPicPr>
@@ -2954,7 +2802,7 @@
       </p:pic>
       <p:pic>
         <p:nvPicPr>
-          <p:cNvPr id="8" name="a size1" descr="/tmp/claude-0/-home-user-otterlee/54e04198-701a-58c9-b487-eea2ac6d4846/scratchpad/out3/a_white.png">    </p:cNvPr>
+          <p:cNvPr id="8" name="1 size1" descr="/tmp/claude-0/-home-user-otterlee/54e04198-701a-58c9-b487-eea2ac6d4846/scratchpad/out4/1_white.png">    </p:cNvPr>
           <p:cNvPicPr>
             <a:picLocks noChangeAspect="1"/>
           </p:cNvPicPr>
@@ -2978,7 +2826,7 @@
       </p:pic>
       <p:pic>
         <p:nvPicPr>
-          <p:cNvPr id="9" name="a size2" descr="/tmp/claude-0/-home-user-otterlee/54e04198-701a-58c9-b487-eea2ac6d4846/scratchpad/out3/a_white.png">    </p:cNvPr>
+          <p:cNvPr id="9" name="1 size2" descr="/tmp/claude-0/-home-user-otterlee/54e04198-701a-58c9-b487-eea2ac6d4846/scratchpad/out4/1_white.png">    </p:cNvPr>
           <p:cNvPicPr>
             <a:picLocks noChangeAspect="1"/>
           </p:cNvPicPr>
@@ -3099,7 +2947,7 @@
                 <a:ea typeface="Pretendard" pitchFamily="34" charset="-122"/>
                 <a:cs typeface="Pretendard" pitchFamily="34" charset="-120"/>
               </a:rPr>
-              <a:t>기준이 되는 안. 아래 변주와 비교해 보세요.</a:t>
+              <a:t>기준이 되는 안. 나무 한 그루를 점으로 그립니다.</a:t>
             </a:r>
             <a:endParaRPr lang="en-US" sz="1300" dirty="0"/>
           </a:p>
@@ -3170,7 +3018,7 @@
                 <a:ea typeface="Pretendard" pitchFamily="34" charset="-122"/>
                 <a:cs typeface="Pretendard" pitchFamily="34" charset="-120"/>
               </a:rPr>
-              <a:t>1-2  크기 차이 크게</a:t>
+              <a:t>2안  숲(삼각형)</a:t>
             </a:r>
             <a:endParaRPr lang="en-US" sz="2000" dirty="0"/>
           </a:p>
@@ -3209,7 +3057,7 @@
                 <a:ea typeface="Pretendard" pitchFamily="34" charset="-122"/>
                 <a:cs typeface="Pretendard" pitchFamily="34" charset="-120"/>
               </a:rPr>
-              <a:t>1안보다 큰 점과 작은 점의 차이를 키웠습니다.</a:t>
+              <a:t>점이 삼각형으로 모여 숲이자 산의 모양이 됩니다.</a:t>
             </a:r>
             <a:endParaRPr lang="en-US" sz="1200" dirty="0"/>
           </a:p>
@@ -3217,7 +3065,7 @@
       </p:sp>
       <p:pic>
         <p:nvPicPr>
-          <p:cNvPr id="4" name="b green" descr="/tmp/claude-0/-home-user-otterlee/54e04198-701a-58c9-b487-eea2ac6d4846/scratchpad/out3/b_green.png">    </p:cNvPr>
+          <p:cNvPr id="4" name="2 green" descr="/tmp/claude-0/-home-user-otterlee/54e04198-701a-58c9-b487-eea2ac6d4846/scratchpad/out4/2_green.png">    </p:cNvPr>
           <p:cNvPicPr>
             <a:picLocks noChangeAspect="1"/>
           </p:cNvPicPr>
@@ -3241,7 +3089,7 @@
       </p:pic>
       <p:pic>
         <p:nvPicPr>
-          <p:cNvPr id="5" name="b white" descr="/tmp/claude-0/-home-user-otterlee/54e04198-701a-58c9-b487-eea2ac6d4846/scratchpad/out3/b_white.png">    </p:cNvPr>
+          <p:cNvPr id="5" name="2 white" descr="/tmp/claude-0/-home-user-otterlee/54e04198-701a-58c9-b487-eea2ac6d4846/scratchpad/out4/2_white.png">    </p:cNvPr>
           <p:cNvPicPr>
             <a:picLocks noChangeAspect="1"/>
           </p:cNvPicPr>
@@ -3265,7 +3113,7 @@
       </p:pic>
       <p:pic>
         <p:nvPicPr>
-          <p:cNvPr id="6" name="b lockup" descr="/tmp/claude-0/-home-user-otterlee/54e04198-701a-58c9-b487-eea2ac6d4846/scratchpad/out3/b_lockup.png">    </p:cNvPr>
+          <p:cNvPr id="6" name="2 lockup" descr="/tmp/claude-0/-home-user-otterlee/54e04198-701a-58c9-b487-eea2ac6d4846/scratchpad/out4/2_lockup.png">    </p:cNvPr>
           <p:cNvPicPr>
             <a:picLocks noChangeAspect="1"/>
           </p:cNvPicPr>
@@ -3289,7 +3137,7 @@
       </p:pic>
       <p:pic>
         <p:nvPicPr>
-          <p:cNvPr id="7" name="b size0" descr="/tmp/claude-0/-home-user-otterlee/54e04198-701a-58c9-b487-eea2ac6d4846/scratchpad/out3/b_white.png">    </p:cNvPr>
+          <p:cNvPr id="7" name="2 size0" descr="/tmp/claude-0/-home-user-otterlee/54e04198-701a-58c9-b487-eea2ac6d4846/scratchpad/out4/2_white.png">    </p:cNvPr>
           <p:cNvPicPr>
             <a:picLocks noChangeAspect="1"/>
           </p:cNvPicPr>
@@ -3313,7 +3161,7 @@
       </p:pic>
       <p:pic>
         <p:nvPicPr>
-          <p:cNvPr id="8" name="b size1" descr="/tmp/claude-0/-home-user-otterlee/54e04198-701a-58c9-b487-eea2ac6d4846/scratchpad/out3/b_white.png">    </p:cNvPr>
+          <p:cNvPr id="8" name="2 size1" descr="/tmp/claude-0/-home-user-otterlee/54e04198-701a-58c9-b487-eea2ac6d4846/scratchpad/out4/2_white.png">    </p:cNvPr>
           <p:cNvPicPr>
             <a:picLocks noChangeAspect="1"/>
           </p:cNvPicPr>
@@ -3337,7 +3185,7 @@
       </p:pic>
       <p:pic>
         <p:nvPicPr>
-          <p:cNvPr id="9" name="b size2" descr="/tmp/claude-0/-home-user-otterlee/54e04198-701a-58c9-b487-eea2ac6d4846/scratchpad/out3/b_white.png">    </p:cNvPr>
+          <p:cNvPr id="9" name="2 size2" descr="/tmp/claude-0/-home-user-otterlee/54e04198-701a-58c9-b487-eea2ac6d4846/scratchpad/out4/2_white.png">    </p:cNvPr>
           <p:cNvPicPr>
             <a:picLocks noChangeAspect="1"/>
           </p:cNvPicPr>
@@ -3458,7 +3306,7 @@
                 <a:ea typeface="Pretendard" pitchFamily="34" charset="-122"/>
                 <a:cs typeface="Pretendard" pitchFamily="34" charset="-120"/>
               </a:rPr>
-              <a:t>리듬감이 생기고 덜 도식적입니다. 가장 작은 점은 축소 시 뭉칠 수 있습니다.</a:t>
+              <a:t>가장 단순한 형태. 점이 모여 숲을 이룬다는 이야기가 바로 읽힙니다. 삼각형이라 표지판처럼 보이지 않는지 확인이 필요합니다.</a:t>
             </a:r>
             <a:endParaRPr lang="en-US" sz="1300" dirty="0"/>
           </a:p>
@@ -3529,7 +3377,7 @@
                 <a:ea typeface="Pretendard" pitchFamily="34" charset="-122"/>
                 <a:cs typeface="Pretendard" pitchFamily="34" charset="-120"/>
               </a:rPr>
-              <a:t>1-3  위치 더 흩트리기</a:t>
+              <a:t>3안  산 두 개</a:t>
             </a:r>
             <a:endParaRPr lang="en-US" sz="2000" dirty="0"/>
           </a:p>
@@ -3568,7 +3416,7 @@
                 <a:ea typeface="Pretendard" pitchFamily="34" charset="-122"/>
                 <a:cs typeface="Pretendard" pitchFamily="34" charset="-120"/>
               </a:rPr>
-              <a:t>점 크기는 비슷하게 두고 배치를 더 자유롭게 흩트렸습니다.</a:t>
+              <a:t>큰 산과 작은 산, 두 개의 삼각형이 이어집니다.</a:t>
             </a:r>
             <a:endParaRPr lang="en-US" sz="1200" dirty="0"/>
           </a:p>
@@ -3576,7 +3424,7 @@
       </p:sp>
       <p:pic>
         <p:nvPicPr>
-          <p:cNvPr id="4" name="c green" descr="/tmp/claude-0/-home-user-otterlee/54e04198-701a-58c9-b487-eea2ac6d4846/scratchpad/out3/c_green.png">    </p:cNvPr>
+          <p:cNvPr id="4" name="3 green" descr="/tmp/claude-0/-home-user-otterlee/54e04198-701a-58c9-b487-eea2ac6d4846/scratchpad/out4/3_green.png">    </p:cNvPr>
           <p:cNvPicPr>
             <a:picLocks noChangeAspect="1"/>
           </p:cNvPicPr>
@@ -3600,7 +3448,7 @@
       </p:pic>
       <p:pic>
         <p:nvPicPr>
-          <p:cNvPr id="5" name="c white" descr="/tmp/claude-0/-home-user-otterlee/54e04198-701a-58c9-b487-eea2ac6d4846/scratchpad/out3/c_white.png">    </p:cNvPr>
+          <p:cNvPr id="5" name="3 white" descr="/tmp/claude-0/-home-user-otterlee/54e04198-701a-58c9-b487-eea2ac6d4846/scratchpad/out4/3_white.png">    </p:cNvPr>
           <p:cNvPicPr>
             <a:picLocks noChangeAspect="1"/>
           </p:cNvPicPr>
@@ -3624,7 +3472,7 @@
       </p:pic>
       <p:pic>
         <p:nvPicPr>
-          <p:cNvPr id="6" name="c lockup" descr="/tmp/claude-0/-home-user-otterlee/54e04198-701a-58c9-b487-eea2ac6d4846/scratchpad/out3/c_lockup.png">    </p:cNvPr>
+          <p:cNvPr id="6" name="3 lockup" descr="/tmp/claude-0/-home-user-otterlee/54e04198-701a-58c9-b487-eea2ac6d4846/scratchpad/out4/3_lockup.png">    </p:cNvPr>
           <p:cNvPicPr>
             <a:picLocks noChangeAspect="1"/>
           </p:cNvPicPr>
@@ -3648,7 +3496,7 @@
       </p:pic>
       <p:pic>
         <p:nvPicPr>
-          <p:cNvPr id="7" name="c size0" descr="/tmp/claude-0/-home-user-otterlee/54e04198-701a-58c9-b487-eea2ac6d4846/scratchpad/out3/c_white.png">    </p:cNvPr>
+          <p:cNvPr id="7" name="3 size0" descr="/tmp/claude-0/-home-user-otterlee/54e04198-701a-58c9-b487-eea2ac6d4846/scratchpad/out4/3_white.png">    </p:cNvPr>
           <p:cNvPicPr>
             <a:picLocks noChangeAspect="1"/>
           </p:cNvPicPr>
@@ -3672,7 +3520,7 @@
       </p:pic>
       <p:pic>
         <p:nvPicPr>
-          <p:cNvPr id="8" name="c size1" descr="/tmp/claude-0/-home-user-otterlee/54e04198-701a-58c9-b487-eea2ac6d4846/scratchpad/out3/c_white.png">    </p:cNvPr>
+          <p:cNvPr id="8" name="3 size1" descr="/tmp/claude-0/-home-user-otterlee/54e04198-701a-58c9-b487-eea2ac6d4846/scratchpad/out4/3_white.png">    </p:cNvPr>
           <p:cNvPicPr>
             <a:picLocks noChangeAspect="1"/>
           </p:cNvPicPr>
@@ -3696,7 +3544,7 @@
       </p:pic>
       <p:pic>
         <p:nvPicPr>
-          <p:cNvPr id="9" name="c size2" descr="/tmp/claude-0/-home-user-otterlee/54e04198-701a-58c9-b487-eea2ac6d4846/scratchpad/out3/c_white.png">    </p:cNvPr>
+          <p:cNvPr id="9" name="3 size2" descr="/tmp/claude-0/-home-user-otterlee/54e04198-701a-58c9-b487-eea2ac6d4846/scratchpad/out4/3_white.png">    </p:cNvPr>
           <p:cNvPicPr>
             <a:picLocks noChangeAspect="1"/>
           </p:cNvPicPr>
@@ -3817,7 +3665,7 @@
                 <a:ea typeface="Pretendard" pitchFamily="34" charset="-122"/>
                 <a:cs typeface="Pretendard" pitchFamily="34" charset="-120"/>
               </a:rPr>
-              <a:t>나무 모양은 유지하면서 격자 느낌이 가장 많이 사라집니다.</a:t>
+              <a:t>두 개가 이어져 한국과 잠비아, 나와 이웃의 모습으로 이야기할 수 있습니다.</a:t>
             </a:r>
             <a:endParaRPr lang="en-US" sz="1300" dirty="0"/>
           </a:p>
@@ -3888,7 +3736,7 @@
                 <a:ea typeface="Pretendard" pitchFamily="34" charset="-122"/>
                 <a:cs typeface="Pretendard" pitchFamily="34" charset="-120"/>
               </a:rPr>
-              <a:t>1-4  줄기를 자유롭게</a:t>
+              <a:t>4안  지문</a:t>
             </a:r>
             <a:endParaRPr lang="en-US" sz="2000" dirty="0"/>
           </a:p>
@@ -3927,7 +3775,7 @@
                 <a:ea typeface="Pretendard" pitchFamily="34" charset="-122"/>
                 <a:cs typeface="Pretendard" pitchFamily="34" charset="-120"/>
               </a:rPr>
-              <a:t>수관은 1안 수준으로 두고, 줄기 점을 아래로 갈수록 작게 하며 살짝 기울였습니다.</a:t>
+              <a:t>1안의 나무 모양 안에서 점이 지문처럼 휘감겨 돕니다. 바깥 끝이 줄기로 이어집니다.</a:t>
             </a:r>
             <a:endParaRPr lang="en-US" sz="1200" dirty="0"/>
           </a:p>
@@ -3935,7 +3783,7 @@
       </p:sp>
       <p:pic>
         <p:nvPicPr>
-          <p:cNvPr id="4" name="d green" descr="/tmp/claude-0/-home-user-otterlee/54e04198-701a-58c9-b487-eea2ac6d4846/scratchpad/out3/d_green.png">    </p:cNvPr>
+          <p:cNvPr id="4" name="4 green" descr="/tmp/claude-0/-home-user-otterlee/54e04198-701a-58c9-b487-eea2ac6d4846/scratchpad/out4/4_green.png">    </p:cNvPr>
           <p:cNvPicPr>
             <a:picLocks noChangeAspect="1"/>
           </p:cNvPicPr>
@@ -3959,7 +3807,7 @@
       </p:pic>
       <p:pic>
         <p:nvPicPr>
-          <p:cNvPr id="5" name="d white" descr="/tmp/claude-0/-home-user-otterlee/54e04198-701a-58c9-b487-eea2ac6d4846/scratchpad/out3/d_white.png">    </p:cNvPr>
+          <p:cNvPr id="5" name="4 white" descr="/tmp/claude-0/-home-user-otterlee/54e04198-701a-58c9-b487-eea2ac6d4846/scratchpad/out4/4_white.png">    </p:cNvPr>
           <p:cNvPicPr>
             <a:picLocks noChangeAspect="1"/>
           </p:cNvPicPr>
@@ -3983,7 +3831,7 @@
       </p:pic>
       <p:pic>
         <p:nvPicPr>
-          <p:cNvPr id="6" name="d lockup" descr="/tmp/claude-0/-home-user-otterlee/54e04198-701a-58c9-b487-eea2ac6d4846/scratchpad/out3/d_lockup.png">    </p:cNvPr>
+          <p:cNvPr id="6" name="4 lockup" descr="/tmp/claude-0/-home-user-otterlee/54e04198-701a-58c9-b487-eea2ac6d4846/scratchpad/out4/4_lockup.png">    </p:cNvPr>
           <p:cNvPicPr>
             <a:picLocks noChangeAspect="1"/>
           </p:cNvPicPr>
@@ -4007,7 +3855,7 @@
       </p:pic>
       <p:pic>
         <p:nvPicPr>
-          <p:cNvPr id="7" name="d size0" descr="/tmp/claude-0/-home-user-otterlee/54e04198-701a-58c9-b487-eea2ac6d4846/scratchpad/out3/d_white.png">    </p:cNvPr>
+          <p:cNvPr id="7" name="4 size0" descr="/tmp/claude-0/-home-user-otterlee/54e04198-701a-58c9-b487-eea2ac6d4846/scratchpad/out4/4_white.png">    </p:cNvPr>
           <p:cNvPicPr>
             <a:picLocks noChangeAspect="1"/>
           </p:cNvPicPr>
@@ -4031,7 +3879,7 @@
       </p:pic>
       <p:pic>
         <p:nvPicPr>
-          <p:cNvPr id="8" name="d size1" descr="/tmp/claude-0/-home-user-otterlee/54e04198-701a-58c9-b487-eea2ac6d4846/scratchpad/out3/d_white.png">    </p:cNvPr>
+          <p:cNvPr id="8" name="4 size1" descr="/tmp/claude-0/-home-user-otterlee/54e04198-701a-58c9-b487-eea2ac6d4846/scratchpad/out4/4_white.png">    </p:cNvPr>
           <p:cNvPicPr>
             <a:picLocks noChangeAspect="1"/>
           </p:cNvPicPr>
@@ -4055,7 +3903,7 @@
       </p:pic>
       <p:pic>
         <p:nvPicPr>
-          <p:cNvPr id="9" name="d size2" descr="/tmp/claude-0/-home-user-otterlee/54e04198-701a-58c9-b487-eea2ac6d4846/scratchpad/out3/d_white.png">    </p:cNvPr>
+          <p:cNvPr id="9" name="4 size2" descr="/tmp/claude-0/-home-user-otterlee/54e04198-701a-58c9-b487-eea2ac6d4846/scratchpad/out4/4_white.png">    </p:cNvPr>
           <p:cNvPicPr>
             <a:picLocks noChangeAspect="1"/>
           </p:cNvPicPr>
@@ -4176,7 +4024,7 @@
                 <a:ea typeface="Pretendard" pitchFamily="34" charset="-122"/>
                 <a:cs typeface="Pretendard" pitchFamily="34" charset="-120"/>
               </a:rPr>
-              <a:t>자라나는 줄기의 느낌. 수관은 거의 그대로입니다.</a:t>
+              <a:t>점 하나가 사람 한 명, 지문은 그 사람의 흔적입니다. 점이 64개로 가장 많아 작게 쓸 때 확인이 필요합니다.</a:t>
             </a:r>
             <a:endParaRPr lang="en-US" sz="1300" dirty="0"/>
           </a:p>
@@ -4193,365 +4041,6 @@
 <file path=ppt/slides/slide8.xml><?xml version="1.0" encoding="utf-8"?>
 <p:sld xmlns:a="http://schemas.openxmlformats.org/drawingml/2006/main" xmlns:r="http://schemas.openxmlformats.org/officeDocument/2006/relationships" xmlns:p="http://schemas.openxmlformats.org/presentationml/2006/main">
   <p:cSld name="Slide 8">
-    <p:bg>
-      <p:bgPr>
-        <a:solidFill>
-          <a:srgbClr val="FFFFFF"/>
-        </a:solidFill>
-      </p:bgPr>
-    </p:bg>
-    <p:spTree>
-      <p:nvGrpSpPr>
-        <p:cNvPr id="1" name=""/>
-        <p:cNvGrpSpPr/>
-        <p:nvPr/>
-      </p:nvGrpSpPr>
-      <p:grpSpPr>
-        <a:xfrm>
-          <a:off x="0" y="0"/>
-          <a:ext cx="0" cy="0"/>
-          <a:chOff x="0" y="0"/>
-          <a:chExt cx="0" cy="0"/>
-        </a:xfrm>
-      </p:grpSpPr>
-      <p:sp>
-        <p:nvSpPr>
-          <p:cNvPr id="2" name="Text 0"/>
-          <p:cNvSpPr txBox="1"/>
-          <p:nvPr/>
-        </p:nvSpPr>
-        <p:spPr>
-          <a:xfrm>
-            <a:off x="457200" y="292608"/>
-            <a:ext cx="8229600" cy="457200"/>
-          </a:xfrm>
-          <a:prstGeom prst="rect">
-            <a:avLst/>
-          </a:prstGeom>
-          <a:noFill/>
-          <a:ln/>
-        </p:spPr>
-        <p:txBody>
-          <a:bodyPr wrap="square" lIns="0" tIns="0" rIns="0" bIns="0" rtlCol="0" anchor="ctr"/>
-          <a:lstStyle/>
-          <a:p>
-            <a:pPr indent="0" marL="0">
-              <a:buNone/>
-            </a:pPr>
-            <a:r>
-              <a:rPr lang="en-US" sz="2000" b="1" dirty="0">
-                <a:solidFill>
-                  <a:srgbClr val="16211C"/>
-                </a:solidFill>
-                <a:latin typeface="Pretendard" pitchFamily="34" charset="0"/>
-                <a:ea typeface="Pretendard" pitchFamily="34" charset="-122"/>
-                <a:cs typeface="Pretendard" pitchFamily="34" charset="-120"/>
-              </a:rPr>
-              <a:t>1-5  가장자리 비우기</a:t>
-            </a:r>
-            <a:endParaRPr lang="en-US" sz="2000" dirty="0"/>
-          </a:p>
-        </p:txBody>
-      </p:sp>
-      <p:sp>
-        <p:nvSpPr>
-          <p:cNvPr id="3" name="Text 1"/>
-          <p:cNvSpPr txBox="1"/>
-          <p:nvPr/>
-        </p:nvSpPr>
-        <p:spPr>
-          <a:xfrm>
-            <a:off x="457200" y="731520"/>
-            <a:ext cx="8229600" cy="274320"/>
-          </a:xfrm>
-          <a:prstGeom prst="rect">
-            <a:avLst/>
-          </a:prstGeom>
-          <a:noFill/>
-          <a:ln/>
-        </p:spPr>
-        <p:txBody>
-          <a:bodyPr wrap="square" lIns="0" tIns="0" rIns="0" bIns="0" rtlCol="0" anchor="ctr"/>
-          <a:lstStyle/>
-          <a:p>
-            <a:pPr indent="0" marL="0">
-              <a:buNone/>
-            </a:pPr>
-            <a:r>
-              <a:rPr lang="en-US" sz="1200" dirty="0">
-                <a:solidFill>
-                  <a:srgbClr val="6B7A72"/>
-                </a:solidFill>
-                <a:latin typeface="Pretendard" pitchFamily="34" charset="0"/>
-                <a:ea typeface="Pretendard" pitchFamily="34" charset="-122"/>
-                <a:cs typeface="Pretendard" pitchFamily="34" charset="-120"/>
-              </a:rPr>
-              <a:t>수관 가장자리 점 몇 개를 빼고, 밖에 작은 점 둘을 떨어뜨렸습니다.</a:t>
-            </a:r>
-            <a:endParaRPr lang="en-US" sz="1200" dirty="0"/>
-          </a:p>
-        </p:txBody>
-      </p:sp>
-      <p:pic>
-        <p:nvPicPr>
-          <p:cNvPr id="4" name="e green" descr="/tmp/claude-0/-home-user-otterlee/54e04198-701a-58c9-b487-eea2ac6d4846/scratchpad/out3/e_green.png">    </p:cNvPr>
-          <p:cNvPicPr>
-            <a:picLocks noChangeAspect="1"/>
-          </p:cNvPicPr>
-          <p:nvPr/>
-        </p:nvPicPr>
-        <p:blipFill>
-          <a:blip r:embed="rId1"/>
-          <a:stretch>
-            <a:fillRect/>
-          </a:stretch>
-        </p:blipFill>
-        <p:spPr>
-          <a:xfrm>
-            <a:off x="457200" y="1188720"/>
-            <a:ext cx="2926080" cy="2926080"/>
-          </a:xfrm>
-          <a:prstGeom prst="rect">
-            <a:avLst/>
-          </a:prstGeom>
-        </p:spPr>
-      </p:pic>
-      <p:pic>
-        <p:nvPicPr>
-          <p:cNvPr id="5" name="e white" descr="/tmp/claude-0/-home-user-otterlee/54e04198-701a-58c9-b487-eea2ac6d4846/scratchpad/out3/e_white.png">    </p:cNvPr>
-          <p:cNvPicPr>
-            <a:picLocks noChangeAspect="1"/>
-          </p:cNvPicPr>
-          <p:nvPr/>
-        </p:nvPicPr>
-        <p:blipFill>
-          <a:blip r:embed="rId2"/>
-          <a:stretch>
-            <a:fillRect/>
-          </a:stretch>
-        </p:blipFill>
-        <p:spPr>
-          <a:xfrm>
-            <a:off x="3566160" y="1188720"/>
-            <a:ext cx="1463040" cy="1463040"/>
-          </a:xfrm>
-          <a:prstGeom prst="rect">
-            <a:avLst/>
-          </a:prstGeom>
-        </p:spPr>
-      </p:pic>
-      <p:pic>
-        <p:nvPicPr>
-          <p:cNvPr id="6" name="e lockup" descr="/tmp/claude-0/-home-user-otterlee/54e04198-701a-58c9-b487-eea2ac6d4846/scratchpad/out3/e_lockup.png">    </p:cNvPr>
-          <p:cNvPicPr>
-            <a:picLocks noChangeAspect="1"/>
-          </p:cNvPicPr>
-          <p:nvPr/>
-        </p:nvPicPr>
-        <p:blipFill>
-          <a:blip r:embed="rId3"/>
-          <a:stretch>
-            <a:fillRect/>
-          </a:stretch>
-        </p:blipFill>
-        <p:spPr>
-          <a:xfrm>
-            <a:off x="5212080" y="1188720"/>
-            <a:ext cx="3474720" cy="1411834"/>
-          </a:xfrm>
-          <a:prstGeom prst="rect">
-            <a:avLst/>
-          </a:prstGeom>
-        </p:spPr>
-      </p:pic>
-      <p:pic>
-        <p:nvPicPr>
-          <p:cNvPr id="7" name="e size0" descr="/tmp/claude-0/-home-user-otterlee/54e04198-701a-58c9-b487-eea2ac6d4846/scratchpad/out3/e_white.png">    </p:cNvPr>
-          <p:cNvPicPr>
-            <a:picLocks noChangeAspect="1"/>
-          </p:cNvPicPr>
-          <p:nvPr/>
-        </p:nvPicPr>
-        <p:blipFill>
-          <a:blip r:embed="rId4"/>
-          <a:stretch>
-            <a:fillRect/>
-          </a:stretch>
-        </p:blipFill>
-        <p:spPr>
-          <a:xfrm>
-            <a:off x="3566160" y="3063240"/>
-            <a:ext cx="274320" cy="274320"/>
-          </a:xfrm>
-          <a:prstGeom prst="rect">
-            <a:avLst/>
-          </a:prstGeom>
-        </p:spPr>
-      </p:pic>
-      <p:pic>
-        <p:nvPicPr>
-          <p:cNvPr id="8" name="e size1" descr="/tmp/claude-0/-home-user-otterlee/54e04198-701a-58c9-b487-eea2ac6d4846/scratchpad/out3/e_white.png">    </p:cNvPr>
-          <p:cNvPicPr>
-            <a:picLocks noChangeAspect="1"/>
-          </p:cNvPicPr>
-          <p:nvPr/>
-        </p:nvPicPr>
-        <p:blipFill>
-          <a:blip r:embed="rId5"/>
-          <a:stretch>
-            <a:fillRect/>
-          </a:stretch>
-        </p:blipFill>
-        <p:spPr>
-          <a:xfrm>
-            <a:off x="3977640" y="2994660"/>
-            <a:ext cx="411480" cy="411480"/>
-          </a:xfrm>
-          <a:prstGeom prst="rect">
-            <a:avLst/>
-          </a:prstGeom>
-        </p:spPr>
-      </p:pic>
-      <p:pic>
-        <p:nvPicPr>
-          <p:cNvPr id="9" name="e size2" descr="/tmp/claude-0/-home-user-otterlee/54e04198-701a-58c9-b487-eea2ac6d4846/scratchpad/out3/e_white.png">    </p:cNvPr>
-          <p:cNvPicPr>
-            <a:picLocks noChangeAspect="1"/>
-          </p:cNvPicPr>
-          <p:nvPr/>
-        </p:nvPicPr>
-        <p:blipFill>
-          <a:blip r:embed="rId6"/>
-          <a:stretch>
-            <a:fillRect/>
-          </a:stretch>
-        </p:blipFill>
-        <p:spPr>
-          <a:xfrm>
-            <a:off x="4480560" y="2880360"/>
-            <a:ext cx="640080" cy="640080"/>
-          </a:xfrm>
-          <a:prstGeom prst="rect">
-            <a:avLst/>
-          </a:prstGeom>
-        </p:spPr>
-      </p:pic>
-      <p:sp>
-        <p:nvSpPr>
-          <p:cNvPr id="10" name="Text 2"/>
-          <p:cNvSpPr txBox="1"/>
-          <p:nvPr/>
-        </p:nvSpPr>
-        <p:spPr>
-          <a:xfrm>
-            <a:off x="3566160" y="3840480"/>
-            <a:ext cx="1645920" cy="228600"/>
-          </a:xfrm>
-          <a:prstGeom prst="rect">
-            <a:avLst/>
-          </a:prstGeom>
-          <a:noFill/>
-          <a:ln/>
-        </p:spPr>
-        <p:txBody>
-          <a:bodyPr wrap="square" lIns="0" tIns="0" rIns="0" bIns="0" rtlCol="0" anchor="ctr"/>
-          <a:lstStyle/>
-          <a:p>
-            <a:pPr indent="0" marL="0">
-              <a:buNone/>
-            </a:pPr>
-            <a:r>
-              <a:rPr lang="en-US" sz="1000" dirty="0">
-                <a:solidFill>
-                  <a:srgbClr val="6B7A72"/>
-                </a:solidFill>
-                <a:latin typeface="Pretendard" pitchFamily="34" charset="0"/>
-                <a:ea typeface="Pretendard" pitchFamily="34" charset="-122"/>
-                <a:cs typeface="Pretendard" pitchFamily="34" charset="-120"/>
-              </a:rPr>
-              <a:t>축소 확인</a:t>
-            </a:r>
-            <a:endParaRPr lang="en-US" sz="1000" dirty="0"/>
-          </a:p>
-        </p:txBody>
-      </p:sp>
-      <p:sp>
-        <p:nvSpPr>
-          <p:cNvPr id="11" name="note card"/>
-          <p:cNvSpPr/>
-          <p:nvPr/>
-        </p:nvSpPr>
-        <p:spPr>
-          <a:xfrm>
-            <a:off x="5212080" y="2880360"/>
-            <a:ext cx="3474720" cy="1234440"/>
-          </a:xfrm>
-          <a:prstGeom prst="roundRect">
-            <a:avLst>
-              <a:gd name="adj" fmla="val 5926"/>
-            </a:avLst>
-          </a:prstGeom>
-          <a:solidFill>
-            <a:srgbClr val="EAF7EE"/>
-          </a:solidFill>
-          <a:ln w="12700">
-            <a:solidFill>
-              <a:srgbClr val="EAF7EE"/>
-            </a:solidFill>
-            <a:prstDash val="solid"/>
-          </a:ln>
-        </p:spPr>
-      </p:sp>
-      <p:sp>
-        <p:nvSpPr>
-          <p:cNvPr id="12" name="Text 4"/>
-          <p:cNvSpPr txBox="1"/>
-          <p:nvPr/>
-        </p:nvSpPr>
-        <p:spPr>
-          <a:xfrm>
-            <a:off x="5394960" y="2880360"/>
-            <a:ext cx="3108960" cy="1234440"/>
-          </a:xfrm>
-          <a:prstGeom prst="rect">
-            <a:avLst/>
-          </a:prstGeom>
-          <a:noFill/>
-          <a:ln/>
-        </p:spPr>
-        <p:txBody>
-          <a:bodyPr wrap="square" lIns="0" tIns="0" rIns="0" bIns="0" rtlCol="0" anchor="ctr"/>
-          <a:lstStyle/>
-          <a:p>
-            <a:pPr indent="0" marL="0">
-              <a:buNone/>
-            </a:pPr>
-            <a:r>
-              <a:rPr lang="en-US" sz="1300" dirty="0">
-                <a:solidFill>
-                  <a:srgbClr val="16211C"/>
-                </a:solidFill>
-                <a:latin typeface="Pretendard" pitchFamily="34" charset="0"/>
-                <a:ea typeface="Pretendard" pitchFamily="34" charset="-122"/>
-                <a:cs typeface="Pretendard" pitchFamily="34" charset="-120"/>
-              </a:rPr>
-              <a:t>바람에 날리는 느낌을 아주 조금만 더했습니다.</a:t>
-            </a:r>
-            <a:endParaRPr lang="en-US" sz="1300" dirty="0"/>
-          </a:p>
-        </p:txBody>
-      </p:sp>
-    </p:spTree>
-  </p:cSld>
-  <p:clrMapOvr>
-    <a:masterClrMapping/>
-  </p:clrMapOvr>
-</p:sld>
-</file>
-
-<file path=ppt/slides/slide9.xml><?xml version="1.0" encoding="utf-8"?>
-<p:sld xmlns:a="http://schemas.openxmlformats.org/drawingml/2006/main" xmlns:r="http://schemas.openxmlformats.org/officeDocument/2006/relationships" xmlns:p="http://schemas.openxmlformats.org/presentationml/2006/main">
-  <p:cSld name="Slide 9">
     <p:bg>
       <p:bgPr>
         <a:solidFill>

</xml_diff>

<commit_message>
BI symbol variations: organic mountain, two mountains, fingerprint arches
Co-Authored-By: Claude Sonnet 5.5 <noreply@anthropic.com>
Claude-Session: https://claude.ai/code/session_01XSVwnKProgLsAGnFXzc9nT
</commit_message>
<xml_diff>
--- a/bi/zambia-variations-v3/plant-zambia-bi-variations-v3.pptx
+++ b/bi/zambia-variations-v3/plant-zambia-bi-variations-v3.pptx
@@ -1500,7 +1500,7 @@
       </p:grpSpPr>
       <p:pic>
         <p:nvPicPr>
-          <p:cNvPr id="2" name="cover symbol" descr="/tmp/claude-0/-home-user-otterlee/54e04198-701a-58c9-b487-eea2ac6d4846/scratchpad/out4/1_monowhite.png">    </p:cNvPr>
+          <p:cNvPr id="2" name="cover symbol" descr="/tmp/claude-0/-home-user-otterlee/54e04198-701a-58c9-b487-eea2ac6d4846/scratchpad/out5/1_monowhite.png">    </p:cNvPr>
           <p:cNvPicPr>
             <a:picLocks noChangeAspect="1"/>
           </p:cNvPicPr>
@@ -2305,7 +2305,7 @@
       </p:sp>
       <p:pic>
         <p:nvPicPr>
-          <p:cNvPr id="4" name="overview 1" descr="/tmp/claude-0/-home-user-otterlee/54e04198-701a-58c9-b487-eea2ac6d4846/scratchpad/out4/1_green.png">    </p:cNvPr>
+          <p:cNvPr id="4" name="overview 1" descr="/tmp/claude-0/-home-user-otterlee/54e04198-701a-58c9-b487-eea2ac6d4846/scratchpad/out5/1_green.png">    </p:cNvPr>
           <p:cNvPicPr>
             <a:picLocks noChangeAspect="1"/>
           </p:cNvPicPr>
@@ -2368,7 +2368,7 @@
       </p:sp>
       <p:pic>
         <p:nvPicPr>
-          <p:cNvPr id="6" name="overview 2" descr="/tmp/claude-0/-home-user-otterlee/54e04198-701a-58c9-b487-eea2ac6d4846/scratchpad/out4/2_green.png">    </p:cNvPr>
+          <p:cNvPr id="6" name="overview 2" descr="/tmp/claude-0/-home-user-otterlee/54e04198-701a-58c9-b487-eea2ac6d4846/scratchpad/out5/2_green.png">    </p:cNvPr>
           <p:cNvPicPr>
             <a:picLocks noChangeAspect="1"/>
           </p:cNvPicPr>
@@ -2423,7 +2423,7 @@
                 <a:ea typeface="Pretendard" pitchFamily="34" charset="-122"/>
                 <a:cs typeface="Pretendard" pitchFamily="34" charset="-120"/>
               </a:rPr>
-              <a:t>2안  숲(삼각형)</a:t>
+              <a:t>2안  숲(산)</a:t>
             </a:r>
             <a:endParaRPr lang="en-US" sz="1200" dirty="0"/>
           </a:p>
@@ -2431,7 +2431,7 @@
       </p:sp>
       <p:pic>
         <p:nvPicPr>
-          <p:cNvPr id="8" name="overview 3" descr="/tmp/claude-0/-home-user-otterlee/54e04198-701a-58c9-b487-eea2ac6d4846/scratchpad/out4/3_green.png">    </p:cNvPr>
+          <p:cNvPr id="8" name="overview 3" descr="/tmp/claude-0/-home-user-otterlee/54e04198-701a-58c9-b487-eea2ac6d4846/scratchpad/out5/3_green.png">    </p:cNvPr>
           <p:cNvPicPr>
             <a:picLocks noChangeAspect="1"/>
           </p:cNvPicPr>
@@ -2494,7 +2494,7 @@
       </p:sp>
       <p:pic>
         <p:nvPicPr>
-          <p:cNvPr id="10" name="overview 4" descr="/tmp/claude-0/-home-user-otterlee/54e04198-701a-58c9-b487-eea2ac6d4846/scratchpad/out4/4_green.png">    </p:cNvPr>
+          <p:cNvPr id="10" name="overview 4" descr="/tmp/claude-0/-home-user-otterlee/54e04198-701a-58c9-b487-eea2ac6d4846/scratchpad/out5/4_green.png">    </p:cNvPr>
           <p:cNvPicPr>
             <a:picLocks noChangeAspect="1"/>
           </p:cNvPicPr>
@@ -2698,7 +2698,7 @@
                 <a:ea typeface="Pretendard" pitchFamily="34" charset="-122"/>
                 <a:cs typeface="Pretendard" pitchFamily="34" charset="-120"/>
               </a:rPr>
-              <a:t>앞서 좋다고 하신 1안 그대로입니다. v2의 나무 모양에 점의 위치와 크기만 조금 풀었습니다.</a:t>
+              <a:t>앞서 좋다고 하신 1안 그대로입니다.</a:t>
             </a:r>
             <a:endParaRPr lang="en-US" sz="1200" dirty="0"/>
           </a:p>
@@ -2706,7 +2706,7 @@
       </p:sp>
       <p:pic>
         <p:nvPicPr>
-          <p:cNvPr id="4" name="1 green" descr="/tmp/claude-0/-home-user-otterlee/54e04198-701a-58c9-b487-eea2ac6d4846/scratchpad/out4/1_green.png">    </p:cNvPr>
+          <p:cNvPr id="4" name="1 green" descr="/tmp/claude-0/-home-user-otterlee/54e04198-701a-58c9-b487-eea2ac6d4846/scratchpad/out5/1_green.png">    </p:cNvPr>
           <p:cNvPicPr>
             <a:picLocks noChangeAspect="1"/>
           </p:cNvPicPr>
@@ -2730,7 +2730,7 @@
       </p:pic>
       <p:pic>
         <p:nvPicPr>
-          <p:cNvPr id="5" name="1 white" descr="/tmp/claude-0/-home-user-otterlee/54e04198-701a-58c9-b487-eea2ac6d4846/scratchpad/out4/1_white.png">    </p:cNvPr>
+          <p:cNvPr id="5" name="1 white" descr="/tmp/claude-0/-home-user-otterlee/54e04198-701a-58c9-b487-eea2ac6d4846/scratchpad/out5/1_white.png">    </p:cNvPr>
           <p:cNvPicPr>
             <a:picLocks noChangeAspect="1"/>
           </p:cNvPicPr>
@@ -2754,7 +2754,7 @@
       </p:pic>
       <p:pic>
         <p:nvPicPr>
-          <p:cNvPr id="6" name="1 lockup" descr="/tmp/claude-0/-home-user-otterlee/54e04198-701a-58c9-b487-eea2ac6d4846/scratchpad/out4/1_lockup.png">    </p:cNvPr>
+          <p:cNvPr id="6" name="1 lockup" descr="/tmp/claude-0/-home-user-otterlee/54e04198-701a-58c9-b487-eea2ac6d4846/scratchpad/out5/1_lockup.png">    </p:cNvPr>
           <p:cNvPicPr>
             <a:picLocks noChangeAspect="1"/>
           </p:cNvPicPr>
@@ -2778,7 +2778,7 @@
       </p:pic>
       <p:pic>
         <p:nvPicPr>
-          <p:cNvPr id="7" name="1 size0" descr="/tmp/claude-0/-home-user-otterlee/54e04198-701a-58c9-b487-eea2ac6d4846/scratchpad/out4/1_white.png">    </p:cNvPr>
+          <p:cNvPr id="7" name="1 size0" descr="/tmp/claude-0/-home-user-otterlee/54e04198-701a-58c9-b487-eea2ac6d4846/scratchpad/out5/1_white.png">    </p:cNvPr>
           <p:cNvPicPr>
             <a:picLocks noChangeAspect="1"/>
           </p:cNvPicPr>
@@ -2802,7 +2802,7 @@
       </p:pic>
       <p:pic>
         <p:nvPicPr>
-          <p:cNvPr id="8" name="1 size1" descr="/tmp/claude-0/-home-user-otterlee/54e04198-701a-58c9-b487-eea2ac6d4846/scratchpad/out4/1_white.png">    </p:cNvPr>
+          <p:cNvPr id="8" name="1 size1" descr="/tmp/claude-0/-home-user-otterlee/54e04198-701a-58c9-b487-eea2ac6d4846/scratchpad/out5/1_white.png">    </p:cNvPr>
           <p:cNvPicPr>
             <a:picLocks noChangeAspect="1"/>
           </p:cNvPicPr>
@@ -2826,7 +2826,7 @@
       </p:pic>
       <p:pic>
         <p:nvPicPr>
-          <p:cNvPr id="9" name="1 size2" descr="/tmp/claude-0/-home-user-otterlee/54e04198-701a-58c9-b487-eea2ac6d4846/scratchpad/out4/1_white.png">    </p:cNvPr>
+          <p:cNvPr id="9" name="1 size2" descr="/tmp/claude-0/-home-user-otterlee/54e04198-701a-58c9-b487-eea2ac6d4846/scratchpad/out5/1_white.png">    </p:cNvPr>
           <p:cNvPicPr>
             <a:picLocks noChangeAspect="1"/>
           </p:cNvPicPr>
@@ -2947,7 +2947,7 @@
                 <a:ea typeface="Pretendard" pitchFamily="34" charset="-122"/>
                 <a:cs typeface="Pretendard" pitchFamily="34" charset="-120"/>
               </a:rPr>
-              <a:t>기준이 되는 안. 나무 한 그루를 점으로 그립니다.</a:t>
+              <a:t>기준이 되는 안. 점 25개로 나무 한 그루를 그립니다.</a:t>
             </a:r>
             <a:endParaRPr lang="en-US" sz="1300" dirty="0"/>
           </a:p>
@@ -3018,7 +3018,7 @@
                 <a:ea typeface="Pretendard" pitchFamily="34" charset="-122"/>
                 <a:cs typeface="Pretendard" pitchFamily="34" charset="-120"/>
               </a:rPr>
-              <a:t>2안  숲(삼각형)</a:t>
+              <a:t>2안  숲(산)</a:t>
             </a:r>
             <a:endParaRPr lang="en-US" sz="2000" dirty="0"/>
           </a:p>
@@ -3057,7 +3057,7 @@
                 <a:ea typeface="Pretendard" pitchFamily="34" charset="-122"/>
                 <a:cs typeface="Pretendard" pitchFamily="34" charset="-120"/>
               </a:rPr>
-              <a:t>점이 삼각형으로 모여 숲이자 산의 모양이 됩니다.</a:t>
+              <a:t>능선이 살짝 비뚤어진 산 하나. 점은 아래가 크고 위로 갈수록 작아져 흩어집니다.</a:t>
             </a:r>
             <a:endParaRPr lang="en-US" sz="1200" dirty="0"/>
           </a:p>
@@ -3065,7 +3065,7 @@
       </p:sp>
       <p:pic>
         <p:nvPicPr>
-          <p:cNvPr id="4" name="2 green" descr="/tmp/claude-0/-home-user-otterlee/54e04198-701a-58c9-b487-eea2ac6d4846/scratchpad/out4/2_green.png">    </p:cNvPr>
+          <p:cNvPr id="4" name="2 green" descr="/tmp/claude-0/-home-user-otterlee/54e04198-701a-58c9-b487-eea2ac6d4846/scratchpad/out5/2_green.png">    </p:cNvPr>
           <p:cNvPicPr>
             <a:picLocks noChangeAspect="1"/>
           </p:cNvPicPr>
@@ -3089,7 +3089,7 @@
       </p:pic>
       <p:pic>
         <p:nvPicPr>
-          <p:cNvPr id="5" name="2 white" descr="/tmp/claude-0/-home-user-otterlee/54e04198-701a-58c9-b487-eea2ac6d4846/scratchpad/out4/2_white.png">    </p:cNvPr>
+          <p:cNvPr id="5" name="2 white" descr="/tmp/claude-0/-home-user-otterlee/54e04198-701a-58c9-b487-eea2ac6d4846/scratchpad/out5/2_white.png">    </p:cNvPr>
           <p:cNvPicPr>
             <a:picLocks noChangeAspect="1"/>
           </p:cNvPicPr>
@@ -3113,7 +3113,7 @@
       </p:pic>
       <p:pic>
         <p:nvPicPr>
-          <p:cNvPr id="6" name="2 lockup" descr="/tmp/claude-0/-home-user-otterlee/54e04198-701a-58c9-b487-eea2ac6d4846/scratchpad/out4/2_lockup.png">    </p:cNvPr>
+          <p:cNvPr id="6" name="2 lockup" descr="/tmp/claude-0/-home-user-otterlee/54e04198-701a-58c9-b487-eea2ac6d4846/scratchpad/out5/2_lockup.png">    </p:cNvPr>
           <p:cNvPicPr>
             <a:picLocks noChangeAspect="1"/>
           </p:cNvPicPr>
@@ -3137,7 +3137,7 @@
       </p:pic>
       <p:pic>
         <p:nvPicPr>
-          <p:cNvPr id="7" name="2 size0" descr="/tmp/claude-0/-home-user-otterlee/54e04198-701a-58c9-b487-eea2ac6d4846/scratchpad/out4/2_white.png">    </p:cNvPr>
+          <p:cNvPr id="7" name="2 size0" descr="/tmp/claude-0/-home-user-otterlee/54e04198-701a-58c9-b487-eea2ac6d4846/scratchpad/out5/2_white.png">    </p:cNvPr>
           <p:cNvPicPr>
             <a:picLocks noChangeAspect="1"/>
           </p:cNvPicPr>
@@ -3161,7 +3161,7 @@
       </p:pic>
       <p:pic>
         <p:nvPicPr>
-          <p:cNvPr id="8" name="2 size1" descr="/tmp/claude-0/-home-user-otterlee/54e04198-701a-58c9-b487-eea2ac6d4846/scratchpad/out4/2_white.png">    </p:cNvPr>
+          <p:cNvPr id="8" name="2 size1" descr="/tmp/claude-0/-home-user-otterlee/54e04198-701a-58c9-b487-eea2ac6d4846/scratchpad/out5/2_white.png">    </p:cNvPr>
           <p:cNvPicPr>
             <a:picLocks noChangeAspect="1"/>
           </p:cNvPicPr>
@@ -3185,7 +3185,7 @@
       </p:pic>
       <p:pic>
         <p:nvPicPr>
-          <p:cNvPr id="9" name="2 size2" descr="/tmp/claude-0/-home-user-otterlee/54e04198-701a-58c9-b487-eea2ac6d4846/scratchpad/out4/2_white.png">    </p:cNvPr>
+          <p:cNvPr id="9" name="2 size2" descr="/tmp/claude-0/-home-user-otterlee/54e04198-701a-58c9-b487-eea2ac6d4846/scratchpad/out5/2_white.png">    </p:cNvPr>
           <p:cNvPicPr>
             <a:picLocks noChangeAspect="1"/>
           </p:cNvPicPr>
@@ -3306,7 +3306,7 @@
                 <a:ea typeface="Pretendard" pitchFamily="34" charset="-122"/>
                 <a:cs typeface="Pretendard" pitchFamily="34" charset="-120"/>
               </a:rPr>
-              <a:t>가장 단순한 형태. 점이 모여 숲을 이룬다는 이야기가 바로 읽힙니다. 삼각형이라 표지판처럼 보이지 않는지 확인이 필요합니다.</a:t>
+              <a:t>반듯한 삼각형 대신 능선을 자연스럽게 풀었습니다. 점이 77개로 많아 작게 쓸 때 확인이 필요합니다.</a:t>
             </a:r>
             <a:endParaRPr lang="en-US" sz="1300" dirty="0"/>
           </a:p>
@@ -3416,7 +3416,7 @@
                 <a:ea typeface="Pretendard" pitchFamily="34" charset="-122"/>
                 <a:cs typeface="Pretendard" pitchFamily="34" charset="-120"/>
               </a:rPr>
-              <a:t>큰 산과 작은 산, 두 개의 삼각형이 이어집니다.</a:t>
+              <a:t>높이가 다른 산 두 개가 이어지고, 점은 제각각의 크기로 모여 있습니다.</a:t>
             </a:r>
             <a:endParaRPr lang="en-US" sz="1200" dirty="0"/>
           </a:p>
@@ -3424,7 +3424,7 @@
       </p:sp>
       <p:pic>
         <p:nvPicPr>
-          <p:cNvPr id="4" name="3 green" descr="/tmp/claude-0/-home-user-otterlee/54e04198-701a-58c9-b487-eea2ac6d4846/scratchpad/out4/3_green.png">    </p:cNvPr>
+          <p:cNvPr id="4" name="3 green" descr="/tmp/claude-0/-home-user-otterlee/54e04198-701a-58c9-b487-eea2ac6d4846/scratchpad/out5/3_green.png">    </p:cNvPr>
           <p:cNvPicPr>
             <a:picLocks noChangeAspect="1"/>
           </p:cNvPicPr>
@@ -3448,7 +3448,7 @@
       </p:pic>
       <p:pic>
         <p:nvPicPr>
-          <p:cNvPr id="5" name="3 white" descr="/tmp/claude-0/-home-user-otterlee/54e04198-701a-58c9-b487-eea2ac6d4846/scratchpad/out4/3_white.png">    </p:cNvPr>
+          <p:cNvPr id="5" name="3 white" descr="/tmp/claude-0/-home-user-otterlee/54e04198-701a-58c9-b487-eea2ac6d4846/scratchpad/out5/3_white.png">    </p:cNvPr>
           <p:cNvPicPr>
             <a:picLocks noChangeAspect="1"/>
           </p:cNvPicPr>
@@ -3472,7 +3472,7 @@
       </p:pic>
       <p:pic>
         <p:nvPicPr>
-          <p:cNvPr id="6" name="3 lockup" descr="/tmp/claude-0/-home-user-otterlee/54e04198-701a-58c9-b487-eea2ac6d4846/scratchpad/out4/3_lockup.png">    </p:cNvPr>
+          <p:cNvPr id="6" name="3 lockup" descr="/tmp/claude-0/-home-user-otterlee/54e04198-701a-58c9-b487-eea2ac6d4846/scratchpad/out5/3_lockup.png">    </p:cNvPr>
           <p:cNvPicPr>
             <a:picLocks noChangeAspect="1"/>
           </p:cNvPicPr>
@@ -3496,7 +3496,7 @@
       </p:pic>
       <p:pic>
         <p:nvPicPr>
-          <p:cNvPr id="7" name="3 size0" descr="/tmp/claude-0/-home-user-otterlee/54e04198-701a-58c9-b487-eea2ac6d4846/scratchpad/out4/3_white.png">    </p:cNvPr>
+          <p:cNvPr id="7" name="3 size0" descr="/tmp/claude-0/-home-user-otterlee/54e04198-701a-58c9-b487-eea2ac6d4846/scratchpad/out5/3_white.png">    </p:cNvPr>
           <p:cNvPicPr>
             <a:picLocks noChangeAspect="1"/>
           </p:cNvPicPr>
@@ -3520,7 +3520,7 @@
       </p:pic>
       <p:pic>
         <p:nvPicPr>
-          <p:cNvPr id="8" name="3 size1" descr="/tmp/claude-0/-home-user-otterlee/54e04198-701a-58c9-b487-eea2ac6d4846/scratchpad/out4/3_white.png">    </p:cNvPr>
+          <p:cNvPr id="8" name="3 size1" descr="/tmp/claude-0/-home-user-otterlee/54e04198-701a-58c9-b487-eea2ac6d4846/scratchpad/out5/3_white.png">    </p:cNvPr>
           <p:cNvPicPr>
             <a:picLocks noChangeAspect="1"/>
           </p:cNvPicPr>
@@ -3544,7 +3544,7 @@
       </p:pic>
       <p:pic>
         <p:nvPicPr>
-          <p:cNvPr id="9" name="3 size2" descr="/tmp/claude-0/-home-user-otterlee/54e04198-701a-58c9-b487-eea2ac6d4846/scratchpad/out4/3_white.png">    </p:cNvPr>
+          <p:cNvPr id="9" name="3 size2" descr="/tmp/claude-0/-home-user-otterlee/54e04198-701a-58c9-b487-eea2ac6d4846/scratchpad/out5/3_white.png">    </p:cNvPr>
           <p:cNvPicPr>
             <a:picLocks noChangeAspect="1"/>
           </p:cNvPicPr>
@@ -3665,7 +3665,7 @@
                 <a:ea typeface="Pretendard" pitchFamily="34" charset="-122"/>
                 <a:cs typeface="Pretendard" pitchFamily="34" charset="-120"/>
               </a:rPr>
-              <a:t>두 개가 이어져 한국과 잠비아, 나와 이웃의 모습으로 이야기할 수 있습니다.</a:t>
+              <a:t>능선이 겹치는 골짜기가 생깁니다. 점이 93개로 가장 많아 작게 쓸 때 확인이 필요합니다.</a:t>
             </a:r>
             <a:endParaRPr lang="en-US" sz="1300" dirty="0"/>
           </a:p>
@@ -3775,7 +3775,7 @@
                 <a:ea typeface="Pretendard" pitchFamily="34" charset="-122"/>
                 <a:cs typeface="Pretendard" pitchFamily="34" charset="-120"/>
               </a:rPr>
-              <a:t>1안의 나무 모양 안에서 점이 지문처럼 휘감겨 돕니다. 바깥 끝이 줄기로 이어집니다.</a:t>
+              <a:t>겹겹이 쌓인 아치가 지문 무늬를 이루고, 가운데에서 줄기가 내려옵니다.</a:t>
             </a:r>
             <a:endParaRPr lang="en-US" sz="1200" dirty="0"/>
           </a:p>
@@ -3783,7 +3783,7 @@
       </p:sp>
       <p:pic>
         <p:nvPicPr>
-          <p:cNvPr id="4" name="4 green" descr="/tmp/claude-0/-home-user-otterlee/54e04198-701a-58c9-b487-eea2ac6d4846/scratchpad/out4/4_green.png">    </p:cNvPr>
+          <p:cNvPr id="4" name="4 green" descr="/tmp/claude-0/-home-user-otterlee/54e04198-701a-58c9-b487-eea2ac6d4846/scratchpad/out5/4_green.png">    </p:cNvPr>
           <p:cNvPicPr>
             <a:picLocks noChangeAspect="1"/>
           </p:cNvPicPr>
@@ -3807,7 +3807,7 @@
       </p:pic>
       <p:pic>
         <p:nvPicPr>
-          <p:cNvPr id="5" name="4 white" descr="/tmp/claude-0/-home-user-otterlee/54e04198-701a-58c9-b487-eea2ac6d4846/scratchpad/out4/4_white.png">    </p:cNvPr>
+          <p:cNvPr id="5" name="4 white" descr="/tmp/claude-0/-home-user-otterlee/54e04198-701a-58c9-b487-eea2ac6d4846/scratchpad/out5/4_white.png">    </p:cNvPr>
           <p:cNvPicPr>
             <a:picLocks noChangeAspect="1"/>
           </p:cNvPicPr>
@@ -3831,7 +3831,7 @@
       </p:pic>
       <p:pic>
         <p:nvPicPr>
-          <p:cNvPr id="6" name="4 lockup" descr="/tmp/claude-0/-home-user-otterlee/54e04198-701a-58c9-b487-eea2ac6d4846/scratchpad/out4/4_lockup.png">    </p:cNvPr>
+          <p:cNvPr id="6" name="4 lockup" descr="/tmp/claude-0/-home-user-otterlee/54e04198-701a-58c9-b487-eea2ac6d4846/scratchpad/out5/4_lockup.png">    </p:cNvPr>
           <p:cNvPicPr>
             <a:picLocks noChangeAspect="1"/>
           </p:cNvPicPr>
@@ -3855,7 +3855,7 @@
       </p:pic>
       <p:pic>
         <p:nvPicPr>
-          <p:cNvPr id="7" name="4 size0" descr="/tmp/claude-0/-home-user-otterlee/54e04198-701a-58c9-b487-eea2ac6d4846/scratchpad/out4/4_white.png">    </p:cNvPr>
+          <p:cNvPr id="7" name="4 size0" descr="/tmp/claude-0/-home-user-otterlee/54e04198-701a-58c9-b487-eea2ac6d4846/scratchpad/out5/4_white.png">    </p:cNvPr>
           <p:cNvPicPr>
             <a:picLocks noChangeAspect="1"/>
           </p:cNvPicPr>
@@ -3879,7 +3879,7 @@
       </p:pic>
       <p:pic>
         <p:nvPicPr>
-          <p:cNvPr id="8" name="4 size1" descr="/tmp/claude-0/-home-user-otterlee/54e04198-701a-58c9-b487-eea2ac6d4846/scratchpad/out4/4_white.png">    </p:cNvPr>
+          <p:cNvPr id="8" name="4 size1" descr="/tmp/claude-0/-home-user-otterlee/54e04198-701a-58c9-b487-eea2ac6d4846/scratchpad/out5/4_white.png">    </p:cNvPr>
           <p:cNvPicPr>
             <a:picLocks noChangeAspect="1"/>
           </p:cNvPicPr>
@@ -3903,7 +3903,7 @@
       </p:pic>
       <p:pic>
         <p:nvPicPr>
-          <p:cNvPr id="9" name="4 size2" descr="/tmp/claude-0/-home-user-otterlee/54e04198-701a-58c9-b487-eea2ac6d4846/scratchpad/out4/4_white.png">    </p:cNvPr>
+          <p:cNvPr id="9" name="4 size2" descr="/tmp/claude-0/-home-user-otterlee/54e04198-701a-58c9-b487-eea2ac6d4846/scratchpad/out5/4_white.png">    </p:cNvPr>
           <p:cNvPicPr>
             <a:picLocks noChangeAspect="1"/>
           </p:cNvPicPr>
@@ -4024,7 +4024,7 @@
                 <a:ea typeface="Pretendard" pitchFamily="34" charset="-122"/>
                 <a:cs typeface="Pretendard" pitchFamily="34" charset="-120"/>
               </a:rPr>
-              <a:t>점 하나가 사람 한 명, 지문은 그 사람의 흔적입니다. 점이 64개로 가장 많아 작게 쓸 때 확인이 필요합니다.</a:t>
+              <a:t>지문이자 나무로 읽힙니다. 점 52개. 점마다 크기가 조금씩 다릅니다.</a:t>
             </a:r>
             <a:endParaRPr lang="en-US" sz="1300" dirty="0"/>
           </a:p>

</xml_diff>

<commit_message>
BI symbol options reorganized to 3: original, loosened dots, fingerprint lines
Co-Authored-By: Claude Sonnet 5.5 <noreply@anthropic.com>
Claude-Session: https://claude.ai/code/session_01XSVwnKProgLsAGnFXzc9nT
</commit_message>
<xml_diff>
--- a/bi/zambia-variations-v3/plant-zambia-bi-variations-v3.pptx
+++ b/bi/zambia-variations-v3/plant-zambia-bi-variations-v3.pptx
@@ -12,10 +12,9 @@
     <p:sldId id="260" r:id="rId6"/>
     <p:sldId id="261" r:id="rId7"/>
     <p:sldId id="262" r:id="rId8"/>
-    <p:sldId id="263" r:id="rId9"/>
   </p:sldIdLst>
   <p:notesMasterIdLst>
-    <p:notesMasterId r:id="rId10"/>
+    <p:notesMasterId r:id="rId9"/>
   </p:notesMasterIdLst>
   <p:sldSz cx="9144000" cy="5143500"/>
   <p:notesSz cx="5143500" cy="9144000"/>
@@ -1061,94 +1060,6 @@
             <a:fld id="{F7021451-1387-4CA6-816F-3879F97B5CBC}" type="slidenum">
               <a:rPr lang="en-US"/>
               <a:t>7</a:t>
-            </a:fld>
-            <a:endParaRPr lang="en-US"/>
-          </a:p>
-        </p:txBody>
-      </p:sp>
-    </p:spTree>
-    <p:extLst>
-      <p:ext uri="{BB962C8B-B14F-4D97-AF65-F5344CB8AC3E}">
-        <p14:creationId xmlns:p14="http://schemas.microsoft.com/office/powerpoint/2010/main" val="1024086991"/>
-      </p:ext>
-    </p:extLst>
-  </p:cSld>
-  <p:clrMapOvr>
-    <a:masterClrMapping/>
-  </p:clrMapOvr>
-</p:notes>
-</file>
-
-<file path=ppt/notesSlides/notesSlide8.xml><?xml version="1.0" encoding="utf-8"?>
-<p:notes xmlns:a="http://schemas.openxmlformats.org/drawingml/2006/main" xmlns:r="http://schemas.openxmlformats.org/officeDocument/2006/relationships" xmlns:p="http://schemas.openxmlformats.org/presentationml/2006/main">
-  <p:cSld>
-    <p:spTree>
-      <p:nvGrpSpPr>
-        <p:cNvPr id="1" name=""/>
-        <p:cNvGrpSpPr/>
-        <p:nvPr/>
-      </p:nvGrpSpPr>
-      <p:grpSpPr>
-        <a:xfrm>
-          <a:off x="0" y="0"/>
-          <a:ext cx="0" cy="0"/>
-          <a:chOff x="0" y="0"/>
-          <a:chExt cx="0" cy="0"/>
-        </a:xfrm>
-      </p:grpSpPr>
-      <p:sp>
-        <p:nvSpPr>
-          <p:cNvPr id="2" name="Slide Image Placeholder 1"/>
-          <p:cNvSpPr>
-            <a:spLocks noGrp="1" noRot="1" noChangeAspect="1"/>
-          </p:cNvSpPr>
-          <p:nvPr>
-            <p:ph type="sldImg"/>
-          </p:nvPr>
-        </p:nvSpPr>
-        <p:spPr/>
-      </p:sp>
-      <p:sp>
-        <p:nvSpPr>
-          <p:cNvPr id="3" name="Notes Placeholder 2"/>
-          <p:cNvSpPr>
-            <a:spLocks noGrp="1"/>
-          </p:cNvSpPr>
-          <p:nvPr>
-            <p:ph type="body" idx="1"/>
-          </p:nvPr>
-        </p:nvSpPr>
-        <p:spPr/>
-        <p:txBody>
-          <a:bodyPr/>
-          <a:lstStyle/>
-          <a:p>
-            <a:r>
-              <a:rPr lang="en-US" dirty="0"/>
-              <a:t/>
-            </a:r>
-            <a:endParaRPr lang="en-US" dirty="0"/>
-          </a:p>
-        </p:txBody>
-      </p:sp>
-      <p:sp>
-        <p:nvSpPr>
-          <p:cNvPr id="4" name="Slide Number Placeholder 3"/>
-          <p:cNvSpPr>
-            <a:spLocks noGrp="1"/>
-          </p:cNvSpPr>
-          <p:nvPr>
-            <p:ph type="sldNum" sz="quarter" idx="10"/>
-          </p:nvPr>
-        </p:nvSpPr>
-        <p:spPr/>
-        <p:txBody>
-          <a:bodyPr/>
-          <a:lstStyle/>
-          <a:p>
-            <a:fld id="{F7021451-1387-4CA6-816F-3879F97B5CBC}" type="slidenum">
-              <a:rPr lang="en-US"/>
-              <a:t>8</a:t>
             </a:fld>
             <a:endParaRPr lang="en-US"/>
           </a:p>
@@ -1500,7 +1411,7 @@
       </p:grpSpPr>
       <p:pic>
         <p:nvPicPr>
-          <p:cNvPr id="2" name="cover symbol" descr="/tmp/claude-0/-home-user-otterlee/54e04198-701a-58c9-b487-eea2ac6d4846/scratchpad/out5/1_monowhite.png">    </p:cNvPr>
+          <p:cNvPr id="2" name="cover symbol" descr="/tmp/claude-0/-home-user-otterlee/54e04198-701a-58c9-b487-eea2ac6d4846/scratchpad/out6/2_monowhite.png">    </p:cNvPr>
           <p:cNvPicPr>
             <a:picLocks noChangeAspect="1"/>
           </p:cNvPicPr>
@@ -1633,7 +1544,7 @@
                 <a:ea typeface="Pretendard" pitchFamily="34" charset="-122"/>
                 <a:cs typeface="Pretendard" pitchFamily="34" charset="-120"/>
               </a:rPr>
-              <a:t>(사)산과자연의친구 · 2026. 10 · v3 (피드백 반영 4안)</a:t>
+              <a:t>(사)산과자연의친구 · 2026. 10 · v3 (피드백 반영 3안)</a:t>
             </a:r>
             <a:endParaRPr lang="en-US" sz="1100" dirty="0"/>
           </a:p>
@@ -2187,7 +2098,7 @@
                 <a:ea typeface="Pretendard" pitchFamily="34" charset="-122"/>
                 <a:cs typeface="Pretendard" pitchFamily="34" charset="-120"/>
               </a:rPr>
-              <a:t>4가지 변형을 만들어 나중에 택일</a:t>
+              <a:t>3가지 안을 만들어 나중에 택일</a:t>
             </a:r>
             <a:endParaRPr lang="en-US" sz="1300" dirty="0"/>
           </a:p>
@@ -2305,7 +2216,7 @@
       </p:sp>
       <p:pic>
         <p:nvPicPr>
-          <p:cNvPr id="4" name="overview 1" descr="/tmp/claude-0/-home-user-otterlee/54e04198-701a-58c9-b487-eea2ac6d4846/scratchpad/out5/1_green.png">    </p:cNvPr>
+          <p:cNvPr id="4" name="overview 1" descr="/tmp/claude-0/-home-user-otterlee/54e04198-701a-58c9-b487-eea2ac6d4846/scratchpad/out6/1_green.png">    </p:cNvPr>
           <p:cNvPicPr>
             <a:picLocks noChangeAspect="1"/>
           </p:cNvPicPr>
@@ -2319,8 +2230,8 @@
         </p:blipFill>
         <p:spPr>
           <a:xfrm>
-            <a:off x="457200" y="1371600"/>
-            <a:ext cx="1828800" cy="1828800"/>
+            <a:off x="457200" y="1188720"/>
+            <a:ext cx="2560320" cy="2560320"/>
           </a:xfrm>
           <a:prstGeom prst="rect">
             <a:avLst/>
@@ -2335,8 +2246,8 @@
         </p:nvSpPr>
         <p:spPr>
           <a:xfrm>
-            <a:off x="457200" y="3337560"/>
-            <a:ext cx="1828800" cy="365760"/>
+            <a:off x="457200" y="3840480"/>
+            <a:ext cx="2560320" cy="320040"/>
           </a:xfrm>
           <a:prstGeom prst="rect">
             <a:avLst/>
@@ -2360,7 +2271,7 @@
                 <a:ea typeface="Pretendard" pitchFamily="34" charset="-122"/>
                 <a:cs typeface="Pretendard" pitchFamily="34" charset="-120"/>
               </a:rPr>
-              <a:t>1안  나무</a:t>
+              <a:t>1안  최초안</a:t>
             </a:r>
             <a:endParaRPr lang="en-US" sz="1200" dirty="0"/>
           </a:p>
@@ -2368,7 +2279,7 @@
       </p:sp>
       <p:pic>
         <p:nvPicPr>
-          <p:cNvPr id="6" name="overview 2" descr="/tmp/claude-0/-home-user-otterlee/54e04198-701a-58c9-b487-eea2ac6d4846/scratchpad/out5/2_green.png">    </p:cNvPr>
+          <p:cNvPr id="6" name="overview 2" descr="/tmp/claude-0/-home-user-otterlee/54e04198-701a-58c9-b487-eea2ac6d4846/scratchpad/out6/2_green.png">    </p:cNvPr>
           <p:cNvPicPr>
             <a:picLocks noChangeAspect="1"/>
           </p:cNvPicPr>
@@ -2382,8 +2293,8 @@
         </p:blipFill>
         <p:spPr>
           <a:xfrm>
-            <a:off x="2560320" y="1371600"/>
-            <a:ext cx="1828800" cy="1828800"/>
+            <a:off x="3291840" y="1188720"/>
+            <a:ext cx="2560320" cy="2560320"/>
           </a:xfrm>
           <a:prstGeom prst="rect">
             <a:avLst/>
@@ -2398,8 +2309,8 @@
         </p:nvSpPr>
         <p:spPr>
           <a:xfrm>
-            <a:off x="2560320" y="3337560"/>
-            <a:ext cx="1828800" cy="365760"/>
+            <a:off x="3291840" y="3840480"/>
+            <a:ext cx="2560320" cy="320040"/>
           </a:xfrm>
           <a:prstGeom prst="rect">
             <a:avLst/>
@@ -2423,7 +2334,7 @@
                 <a:ea typeface="Pretendard" pitchFamily="34" charset="-122"/>
                 <a:cs typeface="Pretendard" pitchFamily="34" charset="-120"/>
               </a:rPr>
-              <a:t>2안  숲(산)</a:t>
+              <a:t>2안  점을 살짝 풀기</a:t>
             </a:r>
             <a:endParaRPr lang="en-US" sz="1200" dirty="0"/>
           </a:p>
@@ -2431,7 +2342,7 @@
       </p:sp>
       <p:pic>
         <p:nvPicPr>
-          <p:cNvPr id="8" name="overview 3" descr="/tmp/claude-0/-home-user-otterlee/54e04198-701a-58c9-b487-eea2ac6d4846/scratchpad/out5/3_green.png">    </p:cNvPr>
+          <p:cNvPr id="8" name="overview 3" descr="/tmp/claude-0/-home-user-otterlee/54e04198-701a-58c9-b487-eea2ac6d4846/scratchpad/out6/3_green.png">    </p:cNvPr>
           <p:cNvPicPr>
             <a:picLocks noChangeAspect="1"/>
           </p:cNvPicPr>
@@ -2445,8 +2356,8 @@
         </p:blipFill>
         <p:spPr>
           <a:xfrm>
-            <a:off x="4663440" y="1371600"/>
-            <a:ext cx="1828800" cy="1828800"/>
+            <a:off x="6126480" y="1188720"/>
+            <a:ext cx="2560320" cy="2560320"/>
           </a:xfrm>
           <a:prstGeom prst="rect">
             <a:avLst/>
@@ -2461,8 +2372,8 @@
         </p:nvSpPr>
         <p:spPr>
           <a:xfrm>
-            <a:off x="4663440" y="3337560"/>
-            <a:ext cx="1828800" cy="365760"/>
+            <a:off x="6126480" y="3840480"/>
+            <a:ext cx="2560320" cy="320040"/>
           </a:xfrm>
           <a:prstGeom prst="rect">
             <a:avLst/>
@@ -2486,84 +2397,21 @@
                 <a:ea typeface="Pretendard" pitchFamily="34" charset="-122"/>
                 <a:cs typeface="Pretendard" pitchFamily="34" charset="-120"/>
               </a:rPr>
-              <a:t>3안  산 두 개</a:t>
+              <a:t>3안  지문</a:t>
             </a:r>
             <a:endParaRPr lang="en-US" sz="1200" dirty="0"/>
           </a:p>
         </p:txBody>
       </p:sp>
-      <p:pic>
-        <p:nvPicPr>
-          <p:cNvPr id="10" name="overview 4" descr="/tmp/claude-0/-home-user-otterlee/54e04198-701a-58c9-b487-eea2ac6d4846/scratchpad/out5/4_green.png">    </p:cNvPr>
-          <p:cNvPicPr>
-            <a:picLocks noChangeAspect="1"/>
-          </p:cNvPicPr>
-          <p:nvPr/>
-        </p:nvPicPr>
-        <p:blipFill>
-          <a:blip r:embed="rId4"/>
-          <a:stretch>
-            <a:fillRect/>
-          </a:stretch>
-        </p:blipFill>
-        <p:spPr>
-          <a:xfrm>
-            <a:off x="6766560" y="1371600"/>
-            <a:ext cx="1828800" cy="1828800"/>
-          </a:xfrm>
-          <a:prstGeom prst="rect">
-            <a:avLst/>
-          </a:prstGeom>
-        </p:spPr>
-      </p:pic>
-      <p:sp>
-        <p:nvSpPr>
-          <p:cNvPr id="11" name="Text 5"/>
+      <p:sp>
+        <p:nvSpPr>
+          <p:cNvPr id="10" name="Text 5"/>
           <p:cNvSpPr txBox="1"/>
           <p:nvPr/>
         </p:nvSpPr>
         <p:spPr>
           <a:xfrm>
-            <a:off x="6766560" y="3337560"/>
-            <a:ext cx="1828800" cy="365760"/>
-          </a:xfrm>
-          <a:prstGeom prst="rect">
-            <a:avLst/>
-          </a:prstGeom>
-          <a:noFill/>
-          <a:ln/>
-        </p:spPr>
-        <p:txBody>
-          <a:bodyPr wrap="square" lIns="0" tIns="0" rIns="0" bIns="0" rtlCol="0" anchor="ctr"/>
-          <a:lstStyle/>
-          <a:p>
-            <a:pPr indent="0" marL="0">
-              <a:buNone/>
-            </a:pPr>
-            <a:r>
-              <a:rPr lang="en-US" sz="1200" b="1" dirty="0">
-                <a:solidFill>
-                  <a:srgbClr val="16211C"/>
-                </a:solidFill>
-                <a:latin typeface="Pretendard" pitchFamily="34" charset="0"/>
-                <a:ea typeface="Pretendard" pitchFamily="34" charset="-122"/>
-                <a:cs typeface="Pretendard" pitchFamily="34" charset="-120"/>
-              </a:rPr>
-              <a:t>4안  지문</a:t>
-            </a:r>
-            <a:endParaRPr lang="en-US" sz="1200" dirty="0"/>
-          </a:p>
-        </p:txBody>
-      </p:sp>
-      <p:sp>
-        <p:nvSpPr>
-          <p:cNvPr id="12" name="Text 6"/>
-          <p:cNvSpPr txBox="1"/>
-          <p:nvPr/>
-        </p:nvSpPr>
-        <p:spPr>
-          <a:xfrm>
-            <a:off x="457200" y="4114800"/>
+            <a:off x="457200" y="4389120"/>
             <a:ext cx="8229600" cy="274320"/>
           </a:xfrm>
           <a:prstGeom prst="rect">
@@ -2588,7 +2436,7 @@
                 <a:ea typeface="Pretendard" pitchFamily="34" charset="-122"/>
                 <a:cs typeface="Pretendard" pitchFamily="34" charset="-120"/>
               </a:rPr>
-              <a:t>1안은 그대로 두고, 2~4안은 형태를 달리했습니다.</a:t>
+              <a:t>1안은 최초안, 2안은 점을 풀어낸 안, 3안은 지문으로 바꾼 안입니다.</a:t>
             </a:r>
             <a:endParaRPr lang="en-US" sz="1200" dirty="0"/>
           </a:p>
@@ -2659,7 +2507,7 @@
                 <a:ea typeface="Pretendard" pitchFamily="34" charset="-122"/>
                 <a:cs typeface="Pretendard" pitchFamily="34" charset="-120"/>
               </a:rPr>
-              <a:t>1안  나무</a:t>
+              <a:t>1안  최초안</a:t>
             </a:r>
             <a:endParaRPr lang="en-US" sz="2000" dirty="0"/>
           </a:p>
@@ -2698,7 +2546,7 @@
                 <a:ea typeface="Pretendard" pitchFamily="34" charset="-122"/>
                 <a:cs typeface="Pretendard" pitchFamily="34" charset="-120"/>
               </a:rPr>
-              <a:t>앞서 좋다고 하신 1안 그대로입니다.</a:t>
+              <a:t>v2에서 제안드린 기존 심볼입니다. 점을 같은 크기로 가지런히 배열했습니다.</a:t>
             </a:r>
             <a:endParaRPr lang="en-US" sz="1200" dirty="0"/>
           </a:p>
@@ -2706,7 +2554,7 @@
       </p:sp>
       <p:pic>
         <p:nvPicPr>
-          <p:cNvPr id="4" name="1 green" descr="/tmp/claude-0/-home-user-otterlee/54e04198-701a-58c9-b487-eea2ac6d4846/scratchpad/out5/1_green.png">    </p:cNvPr>
+          <p:cNvPr id="4" name="1 green" descr="/tmp/claude-0/-home-user-otterlee/54e04198-701a-58c9-b487-eea2ac6d4846/scratchpad/out6/1_green.png">    </p:cNvPr>
           <p:cNvPicPr>
             <a:picLocks noChangeAspect="1"/>
           </p:cNvPicPr>
@@ -2730,7 +2578,7 @@
       </p:pic>
       <p:pic>
         <p:nvPicPr>
-          <p:cNvPr id="5" name="1 white" descr="/tmp/claude-0/-home-user-otterlee/54e04198-701a-58c9-b487-eea2ac6d4846/scratchpad/out5/1_white.png">    </p:cNvPr>
+          <p:cNvPr id="5" name="1 white" descr="/tmp/claude-0/-home-user-otterlee/54e04198-701a-58c9-b487-eea2ac6d4846/scratchpad/out6/1_white.png">    </p:cNvPr>
           <p:cNvPicPr>
             <a:picLocks noChangeAspect="1"/>
           </p:cNvPicPr>
@@ -2754,7 +2602,7 @@
       </p:pic>
       <p:pic>
         <p:nvPicPr>
-          <p:cNvPr id="6" name="1 lockup" descr="/tmp/claude-0/-home-user-otterlee/54e04198-701a-58c9-b487-eea2ac6d4846/scratchpad/out5/1_lockup.png">    </p:cNvPr>
+          <p:cNvPr id="6" name="1 lockup" descr="/tmp/claude-0/-home-user-otterlee/54e04198-701a-58c9-b487-eea2ac6d4846/scratchpad/out6/1_lockup.png">    </p:cNvPr>
           <p:cNvPicPr>
             <a:picLocks noChangeAspect="1"/>
           </p:cNvPicPr>
@@ -2778,7 +2626,7 @@
       </p:pic>
       <p:pic>
         <p:nvPicPr>
-          <p:cNvPr id="7" name="1 size0" descr="/tmp/claude-0/-home-user-otterlee/54e04198-701a-58c9-b487-eea2ac6d4846/scratchpad/out5/1_white.png">    </p:cNvPr>
+          <p:cNvPr id="7" name="1 size0" descr="/tmp/claude-0/-home-user-otterlee/54e04198-701a-58c9-b487-eea2ac6d4846/scratchpad/out6/1_white.png">    </p:cNvPr>
           <p:cNvPicPr>
             <a:picLocks noChangeAspect="1"/>
           </p:cNvPicPr>
@@ -2802,7 +2650,7 @@
       </p:pic>
       <p:pic>
         <p:nvPicPr>
-          <p:cNvPr id="8" name="1 size1" descr="/tmp/claude-0/-home-user-otterlee/54e04198-701a-58c9-b487-eea2ac6d4846/scratchpad/out5/1_white.png">    </p:cNvPr>
+          <p:cNvPr id="8" name="1 size1" descr="/tmp/claude-0/-home-user-otterlee/54e04198-701a-58c9-b487-eea2ac6d4846/scratchpad/out6/1_white.png">    </p:cNvPr>
           <p:cNvPicPr>
             <a:picLocks noChangeAspect="1"/>
           </p:cNvPicPr>
@@ -2826,7 +2674,7 @@
       </p:pic>
       <p:pic>
         <p:nvPicPr>
-          <p:cNvPr id="9" name="1 size2" descr="/tmp/claude-0/-home-user-otterlee/54e04198-701a-58c9-b487-eea2ac6d4846/scratchpad/out5/1_white.png">    </p:cNvPr>
+          <p:cNvPr id="9" name="1 size2" descr="/tmp/claude-0/-home-user-otterlee/54e04198-701a-58c9-b487-eea2ac6d4846/scratchpad/out6/1_white.png">    </p:cNvPr>
           <p:cNvPicPr>
             <a:picLocks noChangeAspect="1"/>
           </p:cNvPicPr>
@@ -2947,7 +2795,7 @@
                 <a:ea typeface="Pretendard" pitchFamily="34" charset="-122"/>
                 <a:cs typeface="Pretendard" pitchFamily="34" charset="-120"/>
               </a:rPr>
-              <a:t>기준이 되는 안. 점 25개로 나무 한 그루를 그립니다.</a:t>
+              <a:t>비교의 기준입니다. 점이 반듯해서 도식적이라는 의견이 있었습니다.</a:t>
             </a:r>
             <a:endParaRPr lang="en-US" sz="1300" dirty="0"/>
           </a:p>
@@ -3018,7 +2866,7 @@
                 <a:ea typeface="Pretendard" pitchFamily="34" charset="-122"/>
                 <a:cs typeface="Pretendard" pitchFamily="34" charset="-120"/>
               </a:rPr>
-              <a:t>2안  숲(산)</a:t>
+              <a:t>2안  점을 살짝 풀기</a:t>
             </a:r>
             <a:endParaRPr lang="en-US" sz="2000" dirty="0"/>
           </a:p>
@@ -3057,7 +2905,7 @@
                 <a:ea typeface="Pretendard" pitchFamily="34" charset="-122"/>
                 <a:cs typeface="Pretendard" pitchFamily="34" charset="-120"/>
               </a:rPr>
-              <a:t>능선이 살짝 비뚤어진 산 하나. 점은 아래가 크고 위로 갈수록 작아져 흩어집니다.</a:t>
+              <a:t>나무 모양은 그대로 두고, 점의 위치와 크기만 조금씩 흩트렸습니다.</a:t>
             </a:r>
             <a:endParaRPr lang="en-US" sz="1200" dirty="0"/>
           </a:p>
@@ -3065,7 +2913,7 @@
       </p:sp>
       <p:pic>
         <p:nvPicPr>
-          <p:cNvPr id="4" name="2 green" descr="/tmp/claude-0/-home-user-otterlee/54e04198-701a-58c9-b487-eea2ac6d4846/scratchpad/out5/2_green.png">    </p:cNvPr>
+          <p:cNvPr id="4" name="2 green" descr="/tmp/claude-0/-home-user-otterlee/54e04198-701a-58c9-b487-eea2ac6d4846/scratchpad/out6/2_green.png">    </p:cNvPr>
           <p:cNvPicPr>
             <a:picLocks noChangeAspect="1"/>
           </p:cNvPicPr>
@@ -3089,7 +2937,7 @@
       </p:pic>
       <p:pic>
         <p:nvPicPr>
-          <p:cNvPr id="5" name="2 white" descr="/tmp/claude-0/-home-user-otterlee/54e04198-701a-58c9-b487-eea2ac6d4846/scratchpad/out5/2_white.png">    </p:cNvPr>
+          <p:cNvPr id="5" name="2 white" descr="/tmp/claude-0/-home-user-otterlee/54e04198-701a-58c9-b487-eea2ac6d4846/scratchpad/out6/2_white.png">    </p:cNvPr>
           <p:cNvPicPr>
             <a:picLocks noChangeAspect="1"/>
           </p:cNvPicPr>
@@ -3113,7 +2961,7 @@
       </p:pic>
       <p:pic>
         <p:nvPicPr>
-          <p:cNvPr id="6" name="2 lockup" descr="/tmp/claude-0/-home-user-otterlee/54e04198-701a-58c9-b487-eea2ac6d4846/scratchpad/out5/2_lockup.png">    </p:cNvPr>
+          <p:cNvPr id="6" name="2 lockup" descr="/tmp/claude-0/-home-user-otterlee/54e04198-701a-58c9-b487-eea2ac6d4846/scratchpad/out6/2_lockup.png">    </p:cNvPr>
           <p:cNvPicPr>
             <a:picLocks noChangeAspect="1"/>
           </p:cNvPicPr>
@@ -3137,7 +2985,7 @@
       </p:pic>
       <p:pic>
         <p:nvPicPr>
-          <p:cNvPr id="7" name="2 size0" descr="/tmp/claude-0/-home-user-otterlee/54e04198-701a-58c9-b487-eea2ac6d4846/scratchpad/out5/2_white.png">    </p:cNvPr>
+          <p:cNvPr id="7" name="2 size0" descr="/tmp/claude-0/-home-user-otterlee/54e04198-701a-58c9-b487-eea2ac6d4846/scratchpad/out6/2_white.png">    </p:cNvPr>
           <p:cNvPicPr>
             <a:picLocks noChangeAspect="1"/>
           </p:cNvPicPr>
@@ -3161,7 +3009,7 @@
       </p:pic>
       <p:pic>
         <p:nvPicPr>
-          <p:cNvPr id="8" name="2 size1" descr="/tmp/claude-0/-home-user-otterlee/54e04198-701a-58c9-b487-eea2ac6d4846/scratchpad/out5/2_white.png">    </p:cNvPr>
+          <p:cNvPr id="8" name="2 size1" descr="/tmp/claude-0/-home-user-otterlee/54e04198-701a-58c9-b487-eea2ac6d4846/scratchpad/out6/2_white.png">    </p:cNvPr>
           <p:cNvPicPr>
             <a:picLocks noChangeAspect="1"/>
           </p:cNvPicPr>
@@ -3185,7 +3033,7 @@
       </p:pic>
       <p:pic>
         <p:nvPicPr>
-          <p:cNvPr id="9" name="2 size2" descr="/tmp/claude-0/-home-user-otterlee/54e04198-701a-58c9-b487-eea2ac6d4846/scratchpad/out5/2_white.png">    </p:cNvPr>
+          <p:cNvPr id="9" name="2 size2" descr="/tmp/claude-0/-home-user-otterlee/54e04198-701a-58c9-b487-eea2ac6d4846/scratchpad/out6/2_white.png">    </p:cNvPr>
           <p:cNvPicPr>
             <a:picLocks noChangeAspect="1"/>
           </p:cNvPicPr>
@@ -3306,7 +3154,7 @@
                 <a:ea typeface="Pretendard" pitchFamily="34" charset="-122"/>
                 <a:cs typeface="Pretendard" pitchFamily="34" charset="-120"/>
               </a:rPr>
-              <a:t>반듯한 삼각형 대신 능선을 자연스럽게 풀었습니다. 점이 77개로 많아 작게 쓸 때 확인이 필요합니다.</a:t>
+              <a:t>기존 인상을 이어가면서 도식적인 느낌을 줄였습니다. 점 25개.</a:t>
             </a:r>
             <a:endParaRPr lang="en-US" sz="1300" dirty="0"/>
           </a:p>
@@ -3377,7 +3225,7 @@
                 <a:ea typeface="Pretendard" pitchFamily="34" charset="-122"/>
                 <a:cs typeface="Pretendard" pitchFamily="34" charset="-120"/>
               </a:rPr>
-              <a:t>3안  산 두 개</a:t>
+              <a:t>3안  지문</a:t>
             </a:r>
             <a:endParaRPr lang="en-US" sz="2000" dirty="0"/>
           </a:p>
@@ -3416,7 +3264,7 @@
                 <a:ea typeface="Pretendard" pitchFamily="34" charset="-122"/>
                 <a:cs typeface="Pretendard" pitchFamily="34" charset="-120"/>
               </a:rPr>
-              <a:t>높이가 다른 산 두 개가 이어지고, 점은 제각각의 크기로 모여 있습니다.</a:t>
+              <a:t>동그란 점 대신, 지문의 융선처럼 끊어진 선이 겹겹이 쌓여 나무를 이룹니다.</a:t>
             </a:r>
             <a:endParaRPr lang="en-US" sz="1200" dirty="0"/>
           </a:p>
@@ -3424,7 +3272,7 @@
       </p:sp>
       <p:pic>
         <p:nvPicPr>
-          <p:cNvPr id="4" name="3 green" descr="/tmp/claude-0/-home-user-otterlee/54e04198-701a-58c9-b487-eea2ac6d4846/scratchpad/out5/3_green.png">    </p:cNvPr>
+          <p:cNvPr id="4" name="3 green" descr="/tmp/claude-0/-home-user-otterlee/54e04198-701a-58c9-b487-eea2ac6d4846/scratchpad/out6/3_green.png">    </p:cNvPr>
           <p:cNvPicPr>
             <a:picLocks noChangeAspect="1"/>
           </p:cNvPicPr>
@@ -3448,7 +3296,7 @@
       </p:pic>
       <p:pic>
         <p:nvPicPr>
-          <p:cNvPr id="5" name="3 white" descr="/tmp/claude-0/-home-user-otterlee/54e04198-701a-58c9-b487-eea2ac6d4846/scratchpad/out5/3_white.png">    </p:cNvPr>
+          <p:cNvPr id="5" name="3 white" descr="/tmp/claude-0/-home-user-otterlee/54e04198-701a-58c9-b487-eea2ac6d4846/scratchpad/out6/3_white.png">    </p:cNvPr>
           <p:cNvPicPr>
             <a:picLocks noChangeAspect="1"/>
           </p:cNvPicPr>
@@ -3472,7 +3320,7 @@
       </p:pic>
       <p:pic>
         <p:nvPicPr>
-          <p:cNvPr id="6" name="3 lockup" descr="/tmp/claude-0/-home-user-otterlee/54e04198-701a-58c9-b487-eea2ac6d4846/scratchpad/out5/3_lockup.png">    </p:cNvPr>
+          <p:cNvPr id="6" name="3 lockup" descr="/tmp/claude-0/-home-user-otterlee/54e04198-701a-58c9-b487-eea2ac6d4846/scratchpad/out6/3_lockup.png">    </p:cNvPr>
           <p:cNvPicPr>
             <a:picLocks noChangeAspect="1"/>
           </p:cNvPicPr>
@@ -3496,7 +3344,7 @@
       </p:pic>
       <p:pic>
         <p:nvPicPr>
-          <p:cNvPr id="7" name="3 size0" descr="/tmp/claude-0/-home-user-otterlee/54e04198-701a-58c9-b487-eea2ac6d4846/scratchpad/out5/3_white.png">    </p:cNvPr>
+          <p:cNvPr id="7" name="3 size0" descr="/tmp/claude-0/-home-user-otterlee/54e04198-701a-58c9-b487-eea2ac6d4846/scratchpad/out6/3_white.png">    </p:cNvPr>
           <p:cNvPicPr>
             <a:picLocks noChangeAspect="1"/>
           </p:cNvPicPr>
@@ -3520,7 +3368,7 @@
       </p:pic>
       <p:pic>
         <p:nvPicPr>
-          <p:cNvPr id="8" name="3 size1" descr="/tmp/claude-0/-home-user-otterlee/54e04198-701a-58c9-b487-eea2ac6d4846/scratchpad/out5/3_white.png">    </p:cNvPr>
+          <p:cNvPr id="8" name="3 size1" descr="/tmp/claude-0/-home-user-otterlee/54e04198-701a-58c9-b487-eea2ac6d4846/scratchpad/out6/3_white.png">    </p:cNvPr>
           <p:cNvPicPr>
             <a:picLocks noChangeAspect="1"/>
           </p:cNvPicPr>
@@ -3544,7 +3392,7 @@
       </p:pic>
       <p:pic>
         <p:nvPicPr>
-          <p:cNvPr id="9" name="3 size2" descr="/tmp/claude-0/-home-user-otterlee/54e04198-701a-58c9-b487-eea2ac6d4846/scratchpad/out5/3_white.png">    </p:cNvPr>
+          <p:cNvPr id="9" name="3 size2" descr="/tmp/claude-0/-home-user-otterlee/54e04198-701a-58c9-b487-eea2ac6d4846/scratchpad/out6/3_white.png">    </p:cNvPr>
           <p:cNvPicPr>
             <a:picLocks noChangeAspect="1"/>
           </p:cNvPicPr>
@@ -3665,7 +3513,7 @@
                 <a:ea typeface="Pretendard" pitchFamily="34" charset="-122"/>
                 <a:cs typeface="Pretendard" pitchFamily="34" charset="-120"/>
               </a:rPr>
-              <a:t>능선이 겹치는 골짜기가 생깁니다. 점이 93개로 가장 많아 작게 쓸 때 확인이 필요합니다.</a:t>
+              <a:t>선 하나가 사람 한 명, 지문은 그 사람의 흔적입니다. 점이 아닌 선이라 컨셉 설명이 달라집니다.</a:t>
             </a:r>
             <a:endParaRPr lang="en-US" sz="1300" dirty="0"/>
           </a:p>
@@ -3682,365 +3530,6 @@
 <file path=ppt/slides/slide7.xml><?xml version="1.0" encoding="utf-8"?>
 <p:sld xmlns:a="http://schemas.openxmlformats.org/drawingml/2006/main" xmlns:r="http://schemas.openxmlformats.org/officeDocument/2006/relationships" xmlns:p="http://schemas.openxmlformats.org/presentationml/2006/main">
   <p:cSld name="Slide 7">
-    <p:bg>
-      <p:bgPr>
-        <a:solidFill>
-          <a:srgbClr val="FFFFFF"/>
-        </a:solidFill>
-      </p:bgPr>
-    </p:bg>
-    <p:spTree>
-      <p:nvGrpSpPr>
-        <p:cNvPr id="1" name=""/>
-        <p:cNvGrpSpPr/>
-        <p:nvPr/>
-      </p:nvGrpSpPr>
-      <p:grpSpPr>
-        <a:xfrm>
-          <a:off x="0" y="0"/>
-          <a:ext cx="0" cy="0"/>
-          <a:chOff x="0" y="0"/>
-          <a:chExt cx="0" cy="0"/>
-        </a:xfrm>
-      </p:grpSpPr>
-      <p:sp>
-        <p:nvSpPr>
-          <p:cNvPr id="2" name="Text 0"/>
-          <p:cNvSpPr txBox="1"/>
-          <p:nvPr/>
-        </p:nvSpPr>
-        <p:spPr>
-          <a:xfrm>
-            <a:off x="457200" y="292608"/>
-            <a:ext cx="8229600" cy="457200"/>
-          </a:xfrm>
-          <a:prstGeom prst="rect">
-            <a:avLst/>
-          </a:prstGeom>
-          <a:noFill/>
-          <a:ln/>
-        </p:spPr>
-        <p:txBody>
-          <a:bodyPr wrap="square" lIns="0" tIns="0" rIns="0" bIns="0" rtlCol="0" anchor="ctr"/>
-          <a:lstStyle/>
-          <a:p>
-            <a:pPr indent="0" marL="0">
-              <a:buNone/>
-            </a:pPr>
-            <a:r>
-              <a:rPr lang="en-US" sz="2000" b="1" dirty="0">
-                <a:solidFill>
-                  <a:srgbClr val="16211C"/>
-                </a:solidFill>
-                <a:latin typeface="Pretendard" pitchFamily="34" charset="0"/>
-                <a:ea typeface="Pretendard" pitchFamily="34" charset="-122"/>
-                <a:cs typeface="Pretendard" pitchFamily="34" charset="-120"/>
-              </a:rPr>
-              <a:t>4안  지문</a:t>
-            </a:r>
-            <a:endParaRPr lang="en-US" sz="2000" dirty="0"/>
-          </a:p>
-        </p:txBody>
-      </p:sp>
-      <p:sp>
-        <p:nvSpPr>
-          <p:cNvPr id="3" name="Text 1"/>
-          <p:cNvSpPr txBox="1"/>
-          <p:nvPr/>
-        </p:nvSpPr>
-        <p:spPr>
-          <a:xfrm>
-            <a:off x="457200" y="731520"/>
-            <a:ext cx="8229600" cy="274320"/>
-          </a:xfrm>
-          <a:prstGeom prst="rect">
-            <a:avLst/>
-          </a:prstGeom>
-          <a:noFill/>
-          <a:ln/>
-        </p:spPr>
-        <p:txBody>
-          <a:bodyPr wrap="square" lIns="0" tIns="0" rIns="0" bIns="0" rtlCol="0" anchor="ctr"/>
-          <a:lstStyle/>
-          <a:p>
-            <a:pPr indent="0" marL="0">
-              <a:buNone/>
-            </a:pPr>
-            <a:r>
-              <a:rPr lang="en-US" sz="1200" dirty="0">
-                <a:solidFill>
-                  <a:srgbClr val="6B7A72"/>
-                </a:solidFill>
-                <a:latin typeface="Pretendard" pitchFamily="34" charset="0"/>
-                <a:ea typeface="Pretendard" pitchFamily="34" charset="-122"/>
-                <a:cs typeface="Pretendard" pitchFamily="34" charset="-120"/>
-              </a:rPr>
-              <a:t>겹겹이 쌓인 아치가 지문 무늬를 이루고, 가운데에서 줄기가 내려옵니다.</a:t>
-            </a:r>
-            <a:endParaRPr lang="en-US" sz="1200" dirty="0"/>
-          </a:p>
-        </p:txBody>
-      </p:sp>
-      <p:pic>
-        <p:nvPicPr>
-          <p:cNvPr id="4" name="4 green" descr="/tmp/claude-0/-home-user-otterlee/54e04198-701a-58c9-b487-eea2ac6d4846/scratchpad/out5/4_green.png">    </p:cNvPr>
-          <p:cNvPicPr>
-            <a:picLocks noChangeAspect="1"/>
-          </p:cNvPicPr>
-          <p:nvPr/>
-        </p:nvPicPr>
-        <p:blipFill>
-          <a:blip r:embed="rId1"/>
-          <a:stretch>
-            <a:fillRect/>
-          </a:stretch>
-        </p:blipFill>
-        <p:spPr>
-          <a:xfrm>
-            <a:off x="457200" y="1188720"/>
-            <a:ext cx="2926080" cy="2926080"/>
-          </a:xfrm>
-          <a:prstGeom prst="rect">
-            <a:avLst/>
-          </a:prstGeom>
-        </p:spPr>
-      </p:pic>
-      <p:pic>
-        <p:nvPicPr>
-          <p:cNvPr id="5" name="4 white" descr="/tmp/claude-0/-home-user-otterlee/54e04198-701a-58c9-b487-eea2ac6d4846/scratchpad/out5/4_white.png">    </p:cNvPr>
-          <p:cNvPicPr>
-            <a:picLocks noChangeAspect="1"/>
-          </p:cNvPicPr>
-          <p:nvPr/>
-        </p:nvPicPr>
-        <p:blipFill>
-          <a:blip r:embed="rId2"/>
-          <a:stretch>
-            <a:fillRect/>
-          </a:stretch>
-        </p:blipFill>
-        <p:spPr>
-          <a:xfrm>
-            <a:off x="3566160" y="1188720"/>
-            <a:ext cx="1463040" cy="1463040"/>
-          </a:xfrm>
-          <a:prstGeom prst="rect">
-            <a:avLst/>
-          </a:prstGeom>
-        </p:spPr>
-      </p:pic>
-      <p:pic>
-        <p:nvPicPr>
-          <p:cNvPr id="6" name="4 lockup" descr="/tmp/claude-0/-home-user-otterlee/54e04198-701a-58c9-b487-eea2ac6d4846/scratchpad/out5/4_lockup.png">    </p:cNvPr>
-          <p:cNvPicPr>
-            <a:picLocks noChangeAspect="1"/>
-          </p:cNvPicPr>
-          <p:nvPr/>
-        </p:nvPicPr>
-        <p:blipFill>
-          <a:blip r:embed="rId3"/>
-          <a:stretch>
-            <a:fillRect/>
-          </a:stretch>
-        </p:blipFill>
-        <p:spPr>
-          <a:xfrm>
-            <a:off x="5212080" y="1188720"/>
-            <a:ext cx="3474720" cy="1411834"/>
-          </a:xfrm>
-          <a:prstGeom prst="rect">
-            <a:avLst/>
-          </a:prstGeom>
-        </p:spPr>
-      </p:pic>
-      <p:pic>
-        <p:nvPicPr>
-          <p:cNvPr id="7" name="4 size0" descr="/tmp/claude-0/-home-user-otterlee/54e04198-701a-58c9-b487-eea2ac6d4846/scratchpad/out5/4_white.png">    </p:cNvPr>
-          <p:cNvPicPr>
-            <a:picLocks noChangeAspect="1"/>
-          </p:cNvPicPr>
-          <p:nvPr/>
-        </p:nvPicPr>
-        <p:blipFill>
-          <a:blip r:embed="rId4"/>
-          <a:stretch>
-            <a:fillRect/>
-          </a:stretch>
-        </p:blipFill>
-        <p:spPr>
-          <a:xfrm>
-            <a:off x="3566160" y="3063240"/>
-            <a:ext cx="274320" cy="274320"/>
-          </a:xfrm>
-          <a:prstGeom prst="rect">
-            <a:avLst/>
-          </a:prstGeom>
-        </p:spPr>
-      </p:pic>
-      <p:pic>
-        <p:nvPicPr>
-          <p:cNvPr id="8" name="4 size1" descr="/tmp/claude-0/-home-user-otterlee/54e04198-701a-58c9-b487-eea2ac6d4846/scratchpad/out5/4_white.png">    </p:cNvPr>
-          <p:cNvPicPr>
-            <a:picLocks noChangeAspect="1"/>
-          </p:cNvPicPr>
-          <p:nvPr/>
-        </p:nvPicPr>
-        <p:blipFill>
-          <a:blip r:embed="rId5"/>
-          <a:stretch>
-            <a:fillRect/>
-          </a:stretch>
-        </p:blipFill>
-        <p:spPr>
-          <a:xfrm>
-            <a:off x="3977640" y="2994660"/>
-            <a:ext cx="411480" cy="411480"/>
-          </a:xfrm>
-          <a:prstGeom prst="rect">
-            <a:avLst/>
-          </a:prstGeom>
-        </p:spPr>
-      </p:pic>
-      <p:pic>
-        <p:nvPicPr>
-          <p:cNvPr id="9" name="4 size2" descr="/tmp/claude-0/-home-user-otterlee/54e04198-701a-58c9-b487-eea2ac6d4846/scratchpad/out5/4_white.png">    </p:cNvPr>
-          <p:cNvPicPr>
-            <a:picLocks noChangeAspect="1"/>
-          </p:cNvPicPr>
-          <p:nvPr/>
-        </p:nvPicPr>
-        <p:blipFill>
-          <a:blip r:embed="rId6"/>
-          <a:stretch>
-            <a:fillRect/>
-          </a:stretch>
-        </p:blipFill>
-        <p:spPr>
-          <a:xfrm>
-            <a:off x="4480560" y="2880360"/>
-            <a:ext cx="640080" cy="640080"/>
-          </a:xfrm>
-          <a:prstGeom prst="rect">
-            <a:avLst/>
-          </a:prstGeom>
-        </p:spPr>
-      </p:pic>
-      <p:sp>
-        <p:nvSpPr>
-          <p:cNvPr id="10" name="Text 2"/>
-          <p:cNvSpPr txBox="1"/>
-          <p:nvPr/>
-        </p:nvSpPr>
-        <p:spPr>
-          <a:xfrm>
-            <a:off x="3566160" y="3840480"/>
-            <a:ext cx="1645920" cy="228600"/>
-          </a:xfrm>
-          <a:prstGeom prst="rect">
-            <a:avLst/>
-          </a:prstGeom>
-          <a:noFill/>
-          <a:ln/>
-        </p:spPr>
-        <p:txBody>
-          <a:bodyPr wrap="square" lIns="0" tIns="0" rIns="0" bIns="0" rtlCol="0" anchor="ctr"/>
-          <a:lstStyle/>
-          <a:p>
-            <a:pPr indent="0" marL="0">
-              <a:buNone/>
-            </a:pPr>
-            <a:r>
-              <a:rPr lang="en-US" sz="1000" dirty="0">
-                <a:solidFill>
-                  <a:srgbClr val="6B7A72"/>
-                </a:solidFill>
-                <a:latin typeface="Pretendard" pitchFamily="34" charset="0"/>
-                <a:ea typeface="Pretendard" pitchFamily="34" charset="-122"/>
-                <a:cs typeface="Pretendard" pitchFamily="34" charset="-120"/>
-              </a:rPr>
-              <a:t>축소 확인</a:t>
-            </a:r>
-            <a:endParaRPr lang="en-US" sz="1000" dirty="0"/>
-          </a:p>
-        </p:txBody>
-      </p:sp>
-      <p:sp>
-        <p:nvSpPr>
-          <p:cNvPr id="11" name="note card"/>
-          <p:cNvSpPr/>
-          <p:nvPr/>
-        </p:nvSpPr>
-        <p:spPr>
-          <a:xfrm>
-            <a:off x="5212080" y="2880360"/>
-            <a:ext cx="3474720" cy="1234440"/>
-          </a:xfrm>
-          <a:prstGeom prst="roundRect">
-            <a:avLst>
-              <a:gd name="adj" fmla="val 5926"/>
-            </a:avLst>
-          </a:prstGeom>
-          <a:solidFill>
-            <a:srgbClr val="EAF7EE"/>
-          </a:solidFill>
-          <a:ln w="12700">
-            <a:solidFill>
-              <a:srgbClr val="EAF7EE"/>
-            </a:solidFill>
-            <a:prstDash val="solid"/>
-          </a:ln>
-        </p:spPr>
-      </p:sp>
-      <p:sp>
-        <p:nvSpPr>
-          <p:cNvPr id="12" name="Text 4"/>
-          <p:cNvSpPr txBox="1"/>
-          <p:nvPr/>
-        </p:nvSpPr>
-        <p:spPr>
-          <a:xfrm>
-            <a:off x="5394960" y="2880360"/>
-            <a:ext cx="3108960" cy="1234440"/>
-          </a:xfrm>
-          <a:prstGeom prst="rect">
-            <a:avLst/>
-          </a:prstGeom>
-          <a:noFill/>
-          <a:ln/>
-        </p:spPr>
-        <p:txBody>
-          <a:bodyPr wrap="square" lIns="0" tIns="0" rIns="0" bIns="0" rtlCol="0" anchor="ctr"/>
-          <a:lstStyle/>
-          <a:p>
-            <a:pPr indent="0" marL="0">
-              <a:buNone/>
-            </a:pPr>
-            <a:r>
-              <a:rPr lang="en-US" sz="1300" dirty="0">
-                <a:solidFill>
-                  <a:srgbClr val="16211C"/>
-                </a:solidFill>
-                <a:latin typeface="Pretendard" pitchFamily="34" charset="0"/>
-                <a:ea typeface="Pretendard" pitchFamily="34" charset="-122"/>
-                <a:cs typeface="Pretendard" pitchFamily="34" charset="-120"/>
-              </a:rPr>
-              <a:t>지문이자 나무로 읽힙니다. 점 52개. 점마다 크기가 조금씩 다릅니다.</a:t>
-            </a:r>
-            <a:endParaRPr lang="en-US" sz="1300" dirty="0"/>
-          </a:p>
-        </p:txBody>
-      </p:sp>
-    </p:spTree>
-  </p:cSld>
-  <p:clrMapOvr>
-    <a:masterClrMapping/>
-  </p:clrMapOvr>
-</p:sld>
-</file>
-
-<file path=ppt/slides/slide8.xml><?xml version="1.0" encoding="utf-8"?>
-<p:sld xmlns:a="http://schemas.openxmlformats.org/drawingml/2006/main" xmlns:r="http://schemas.openxmlformats.org/officeDocument/2006/relationships" xmlns:p="http://schemas.openxmlformats.org/presentationml/2006/main">
-  <p:cSld name="Slide 8">
     <p:bg>
       <p:bgPr>
         <a:solidFill>

</xml_diff>

<commit_message>
BI symbol option 3: round fingerprint whorl of dots
Co-Authored-By: Claude Sonnet 5.5 <noreply@anthropic.com>
Claude-Session: https://claude.ai/code/session_01XSVwnKProgLsAGnFXzc9nT
</commit_message>
<xml_diff>
--- a/bi/zambia-variations-v3/plant-zambia-bi-variations-v3.pptx
+++ b/bi/zambia-variations-v3/plant-zambia-bi-variations-v3.pptx
@@ -1411,7 +1411,7 @@
       </p:grpSpPr>
       <p:pic>
         <p:nvPicPr>
-          <p:cNvPr id="2" name="cover symbol" descr="/tmp/claude-0/-home-user-otterlee/54e04198-701a-58c9-b487-eea2ac6d4846/scratchpad/out6/2_monowhite.png">    </p:cNvPr>
+          <p:cNvPr id="2" name="cover symbol" descr="/tmp/claude-0/-home-user-otterlee/54e04198-701a-58c9-b487-eea2ac6d4846/scratchpad/out7/2_monowhite.png">    </p:cNvPr>
           <p:cNvPicPr>
             <a:picLocks noChangeAspect="1"/>
           </p:cNvPicPr>
@@ -2216,7 +2216,7 @@
       </p:sp>
       <p:pic>
         <p:nvPicPr>
-          <p:cNvPr id="4" name="overview 1" descr="/tmp/claude-0/-home-user-otterlee/54e04198-701a-58c9-b487-eea2ac6d4846/scratchpad/out6/1_green.png">    </p:cNvPr>
+          <p:cNvPr id="4" name="overview 1" descr="/tmp/claude-0/-home-user-otterlee/54e04198-701a-58c9-b487-eea2ac6d4846/scratchpad/out7/1_green.png">    </p:cNvPr>
           <p:cNvPicPr>
             <a:picLocks noChangeAspect="1"/>
           </p:cNvPicPr>
@@ -2279,7 +2279,7 @@
       </p:sp>
       <p:pic>
         <p:nvPicPr>
-          <p:cNvPr id="6" name="overview 2" descr="/tmp/claude-0/-home-user-otterlee/54e04198-701a-58c9-b487-eea2ac6d4846/scratchpad/out6/2_green.png">    </p:cNvPr>
+          <p:cNvPr id="6" name="overview 2" descr="/tmp/claude-0/-home-user-otterlee/54e04198-701a-58c9-b487-eea2ac6d4846/scratchpad/out7/2_green.png">    </p:cNvPr>
           <p:cNvPicPr>
             <a:picLocks noChangeAspect="1"/>
           </p:cNvPicPr>
@@ -2342,7 +2342,7 @@
       </p:sp>
       <p:pic>
         <p:nvPicPr>
-          <p:cNvPr id="8" name="overview 3" descr="/tmp/claude-0/-home-user-otterlee/54e04198-701a-58c9-b487-eea2ac6d4846/scratchpad/out6/3_green.png">    </p:cNvPr>
+          <p:cNvPr id="8" name="overview 3" descr="/tmp/claude-0/-home-user-otterlee/54e04198-701a-58c9-b487-eea2ac6d4846/scratchpad/out7/3_green.png">    </p:cNvPr>
           <p:cNvPicPr>
             <a:picLocks noChangeAspect="1"/>
           </p:cNvPicPr>
@@ -2436,7 +2436,7 @@
                 <a:ea typeface="Pretendard" pitchFamily="34" charset="-122"/>
                 <a:cs typeface="Pretendard" pitchFamily="34" charset="-120"/>
               </a:rPr>
-              <a:t>1안은 최초안, 2안은 점을 풀어낸 안, 3안은 지문으로 바꾼 안입니다.</a:t>
+              <a:t>1안은 최초안, 2안은 점을 풀어낸 안, 3안은 둥근 지문 무늬로 바꾼 안입니다.</a:t>
             </a:r>
             <a:endParaRPr lang="en-US" sz="1200" dirty="0"/>
           </a:p>
@@ -2554,7 +2554,7 @@
       </p:sp>
       <p:pic>
         <p:nvPicPr>
-          <p:cNvPr id="4" name="1 green" descr="/tmp/claude-0/-home-user-otterlee/54e04198-701a-58c9-b487-eea2ac6d4846/scratchpad/out6/1_green.png">    </p:cNvPr>
+          <p:cNvPr id="4" name="1 green" descr="/tmp/claude-0/-home-user-otterlee/54e04198-701a-58c9-b487-eea2ac6d4846/scratchpad/out7/1_green.png">    </p:cNvPr>
           <p:cNvPicPr>
             <a:picLocks noChangeAspect="1"/>
           </p:cNvPicPr>
@@ -2578,7 +2578,7 @@
       </p:pic>
       <p:pic>
         <p:nvPicPr>
-          <p:cNvPr id="5" name="1 white" descr="/tmp/claude-0/-home-user-otterlee/54e04198-701a-58c9-b487-eea2ac6d4846/scratchpad/out6/1_white.png">    </p:cNvPr>
+          <p:cNvPr id="5" name="1 white" descr="/tmp/claude-0/-home-user-otterlee/54e04198-701a-58c9-b487-eea2ac6d4846/scratchpad/out7/1_white.png">    </p:cNvPr>
           <p:cNvPicPr>
             <a:picLocks noChangeAspect="1"/>
           </p:cNvPicPr>
@@ -2602,7 +2602,7 @@
       </p:pic>
       <p:pic>
         <p:nvPicPr>
-          <p:cNvPr id="6" name="1 lockup" descr="/tmp/claude-0/-home-user-otterlee/54e04198-701a-58c9-b487-eea2ac6d4846/scratchpad/out6/1_lockup.png">    </p:cNvPr>
+          <p:cNvPr id="6" name="1 lockup" descr="/tmp/claude-0/-home-user-otterlee/54e04198-701a-58c9-b487-eea2ac6d4846/scratchpad/out7/1_lockup.png">    </p:cNvPr>
           <p:cNvPicPr>
             <a:picLocks noChangeAspect="1"/>
           </p:cNvPicPr>
@@ -2626,7 +2626,7 @@
       </p:pic>
       <p:pic>
         <p:nvPicPr>
-          <p:cNvPr id="7" name="1 size0" descr="/tmp/claude-0/-home-user-otterlee/54e04198-701a-58c9-b487-eea2ac6d4846/scratchpad/out6/1_white.png">    </p:cNvPr>
+          <p:cNvPr id="7" name="1 size0" descr="/tmp/claude-0/-home-user-otterlee/54e04198-701a-58c9-b487-eea2ac6d4846/scratchpad/out7/1_white.png">    </p:cNvPr>
           <p:cNvPicPr>
             <a:picLocks noChangeAspect="1"/>
           </p:cNvPicPr>
@@ -2650,7 +2650,7 @@
       </p:pic>
       <p:pic>
         <p:nvPicPr>
-          <p:cNvPr id="8" name="1 size1" descr="/tmp/claude-0/-home-user-otterlee/54e04198-701a-58c9-b487-eea2ac6d4846/scratchpad/out6/1_white.png">    </p:cNvPr>
+          <p:cNvPr id="8" name="1 size1" descr="/tmp/claude-0/-home-user-otterlee/54e04198-701a-58c9-b487-eea2ac6d4846/scratchpad/out7/1_white.png">    </p:cNvPr>
           <p:cNvPicPr>
             <a:picLocks noChangeAspect="1"/>
           </p:cNvPicPr>
@@ -2674,7 +2674,7 @@
       </p:pic>
       <p:pic>
         <p:nvPicPr>
-          <p:cNvPr id="9" name="1 size2" descr="/tmp/claude-0/-home-user-otterlee/54e04198-701a-58c9-b487-eea2ac6d4846/scratchpad/out6/1_white.png">    </p:cNvPr>
+          <p:cNvPr id="9" name="1 size2" descr="/tmp/claude-0/-home-user-otterlee/54e04198-701a-58c9-b487-eea2ac6d4846/scratchpad/out7/1_white.png">    </p:cNvPr>
           <p:cNvPicPr>
             <a:picLocks noChangeAspect="1"/>
           </p:cNvPicPr>
@@ -2913,7 +2913,7 @@
       </p:sp>
       <p:pic>
         <p:nvPicPr>
-          <p:cNvPr id="4" name="2 green" descr="/tmp/claude-0/-home-user-otterlee/54e04198-701a-58c9-b487-eea2ac6d4846/scratchpad/out6/2_green.png">    </p:cNvPr>
+          <p:cNvPr id="4" name="2 green" descr="/tmp/claude-0/-home-user-otterlee/54e04198-701a-58c9-b487-eea2ac6d4846/scratchpad/out7/2_green.png">    </p:cNvPr>
           <p:cNvPicPr>
             <a:picLocks noChangeAspect="1"/>
           </p:cNvPicPr>
@@ -2937,7 +2937,7 @@
       </p:pic>
       <p:pic>
         <p:nvPicPr>
-          <p:cNvPr id="5" name="2 white" descr="/tmp/claude-0/-home-user-otterlee/54e04198-701a-58c9-b487-eea2ac6d4846/scratchpad/out6/2_white.png">    </p:cNvPr>
+          <p:cNvPr id="5" name="2 white" descr="/tmp/claude-0/-home-user-otterlee/54e04198-701a-58c9-b487-eea2ac6d4846/scratchpad/out7/2_white.png">    </p:cNvPr>
           <p:cNvPicPr>
             <a:picLocks noChangeAspect="1"/>
           </p:cNvPicPr>
@@ -2961,7 +2961,7 @@
       </p:pic>
       <p:pic>
         <p:nvPicPr>
-          <p:cNvPr id="6" name="2 lockup" descr="/tmp/claude-0/-home-user-otterlee/54e04198-701a-58c9-b487-eea2ac6d4846/scratchpad/out6/2_lockup.png">    </p:cNvPr>
+          <p:cNvPr id="6" name="2 lockup" descr="/tmp/claude-0/-home-user-otterlee/54e04198-701a-58c9-b487-eea2ac6d4846/scratchpad/out7/2_lockup.png">    </p:cNvPr>
           <p:cNvPicPr>
             <a:picLocks noChangeAspect="1"/>
           </p:cNvPicPr>
@@ -2985,7 +2985,7 @@
       </p:pic>
       <p:pic>
         <p:nvPicPr>
-          <p:cNvPr id="7" name="2 size0" descr="/tmp/claude-0/-home-user-otterlee/54e04198-701a-58c9-b487-eea2ac6d4846/scratchpad/out6/2_white.png">    </p:cNvPr>
+          <p:cNvPr id="7" name="2 size0" descr="/tmp/claude-0/-home-user-otterlee/54e04198-701a-58c9-b487-eea2ac6d4846/scratchpad/out7/2_white.png">    </p:cNvPr>
           <p:cNvPicPr>
             <a:picLocks noChangeAspect="1"/>
           </p:cNvPicPr>
@@ -3009,7 +3009,7 @@
       </p:pic>
       <p:pic>
         <p:nvPicPr>
-          <p:cNvPr id="8" name="2 size1" descr="/tmp/claude-0/-home-user-otterlee/54e04198-701a-58c9-b487-eea2ac6d4846/scratchpad/out6/2_white.png">    </p:cNvPr>
+          <p:cNvPr id="8" name="2 size1" descr="/tmp/claude-0/-home-user-otterlee/54e04198-701a-58c9-b487-eea2ac6d4846/scratchpad/out7/2_white.png">    </p:cNvPr>
           <p:cNvPicPr>
             <a:picLocks noChangeAspect="1"/>
           </p:cNvPicPr>
@@ -3033,7 +3033,7 @@
       </p:pic>
       <p:pic>
         <p:nvPicPr>
-          <p:cNvPr id="9" name="2 size2" descr="/tmp/claude-0/-home-user-otterlee/54e04198-701a-58c9-b487-eea2ac6d4846/scratchpad/out6/2_white.png">    </p:cNvPr>
+          <p:cNvPr id="9" name="2 size2" descr="/tmp/claude-0/-home-user-otterlee/54e04198-701a-58c9-b487-eea2ac6d4846/scratchpad/out7/2_white.png">    </p:cNvPr>
           <p:cNvPicPr>
             <a:picLocks noChangeAspect="1"/>
           </p:cNvPicPr>
@@ -3264,7 +3264,7 @@
                 <a:ea typeface="Pretendard" pitchFamily="34" charset="-122"/>
                 <a:cs typeface="Pretendard" pitchFamily="34" charset="-120"/>
               </a:rPr>
-              <a:t>동그란 점 대신, 지문의 융선처럼 끊어진 선이 겹겹이 쌓여 나무를 이룹니다.</a:t>
+              <a:t>엄지 지문처럼 동글동글한 소용돌이 무늬. 점이 동심원으로 돌고, 아래로 줄기가 내려옵니다.</a:t>
             </a:r>
             <a:endParaRPr lang="en-US" sz="1200" dirty="0"/>
           </a:p>
@@ -3272,7 +3272,7 @@
       </p:sp>
       <p:pic>
         <p:nvPicPr>
-          <p:cNvPr id="4" name="3 green" descr="/tmp/claude-0/-home-user-otterlee/54e04198-701a-58c9-b487-eea2ac6d4846/scratchpad/out6/3_green.png">    </p:cNvPr>
+          <p:cNvPr id="4" name="3 green" descr="/tmp/claude-0/-home-user-otterlee/54e04198-701a-58c9-b487-eea2ac6d4846/scratchpad/out7/3_green.png">    </p:cNvPr>
           <p:cNvPicPr>
             <a:picLocks noChangeAspect="1"/>
           </p:cNvPicPr>
@@ -3296,7 +3296,7 @@
       </p:pic>
       <p:pic>
         <p:nvPicPr>
-          <p:cNvPr id="5" name="3 white" descr="/tmp/claude-0/-home-user-otterlee/54e04198-701a-58c9-b487-eea2ac6d4846/scratchpad/out6/3_white.png">    </p:cNvPr>
+          <p:cNvPr id="5" name="3 white" descr="/tmp/claude-0/-home-user-otterlee/54e04198-701a-58c9-b487-eea2ac6d4846/scratchpad/out7/3_white.png">    </p:cNvPr>
           <p:cNvPicPr>
             <a:picLocks noChangeAspect="1"/>
           </p:cNvPicPr>
@@ -3320,7 +3320,7 @@
       </p:pic>
       <p:pic>
         <p:nvPicPr>
-          <p:cNvPr id="6" name="3 lockup" descr="/tmp/claude-0/-home-user-otterlee/54e04198-701a-58c9-b487-eea2ac6d4846/scratchpad/out6/3_lockup.png">    </p:cNvPr>
+          <p:cNvPr id="6" name="3 lockup" descr="/tmp/claude-0/-home-user-otterlee/54e04198-701a-58c9-b487-eea2ac6d4846/scratchpad/out7/3_lockup.png">    </p:cNvPr>
           <p:cNvPicPr>
             <a:picLocks noChangeAspect="1"/>
           </p:cNvPicPr>
@@ -3344,7 +3344,7 @@
       </p:pic>
       <p:pic>
         <p:nvPicPr>
-          <p:cNvPr id="7" name="3 size0" descr="/tmp/claude-0/-home-user-otterlee/54e04198-701a-58c9-b487-eea2ac6d4846/scratchpad/out6/3_white.png">    </p:cNvPr>
+          <p:cNvPr id="7" name="3 size0" descr="/tmp/claude-0/-home-user-otterlee/54e04198-701a-58c9-b487-eea2ac6d4846/scratchpad/out7/3_white.png">    </p:cNvPr>
           <p:cNvPicPr>
             <a:picLocks noChangeAspect="1"/>
           </p:cNvPicPr>
@@ -3368,7 +3368,7 @@
       </p:pic>
       <p:pic>
         <p:nvPicPr>
-          <p:cNvPr id="8" name="3 size1" descr="/tmp/claude-0/-home-user-otterlee/54e04198-701a-58c9-b487-eea2ac6d4846/scratchpad/out6/3_white.png">    </p:cNvPr>
+          <p:cNvPr id="8" name="3 size1" descr="/tmp/claude-0/-home-user-otterlee/54e04198-701a-58c9-b487-eea2ac6d4846/scratchpad/out7/3_white.png">    </p:cNvPr>
           <p:cNvPicPr>
             <a:picLocks noChangeAspect="1"/>
           </p:cNvPicPr>
@@ -3392,7 +3392,7 @@
       </p:pic>
       <p:pic>
         <p:nvPicPr>
-          <p:cNvPr id="9" name="3 size2" descr="/tmp/claude-0/-home-user-otterlee/54e04198-701a-58c9-b487-eea2ac6d4846/scratchpad/out6/3_white.png">    </p:cNvPr>
+          <p:cNvPr id="9" name="3 size2" descr="/tmp/claude-0/-home-user-otterlee/54e04198-701a-58c9-b487-eea2ac6d4846/scratchpad/out7/3_white.png">    </p:cNvPr>
           <p:cNvPicPr>
             <a:picLocks noChangeAspect="1"/>
           </p:cNvPicPr>
@@ -3513,7 +3513,7 @@
                 <a:ea typeface="Pretendard" pitchFamily="34" charset="-122"/>
                 <a:cs typeface="Pretendard" pitchFamily="34" charset="-120"/>
               </a:rPr>
-              <a:t>선 하나가 사람 한 명, 지문은 그 사람의 흔적입니다. 점이 아닌 선이라 컨셉 설명이 달라집니다.</a:t>
+              <a:t>점 하나가 사람 한 명, 지문은 그 사람의 흔적입니다. 점 70개 안팎이라 작게 쓸 때 확인이 필요합니다.</a:t>
             </a:r>
             <a:endParaRPr lang="en-US" sz="1300" dirty="0"/>
           </a:p>

</xml_diff>

<commit_message>
BI symbol options: keep only original (1) and loosened dots (2)
Co-Authored-By: Claude Sonnet 5.5 <noreply@anthropic.com>
Claude-Session: https://claude.ai/code/session_01XSVwnKProgLsAGnFXzc9nT
</commit_message>
<xml_diff>
--- a/bi/zambia-variations-v3/plant-zambia-bi-variations-v3.pptx
+++ b/bi/zambia-variations-v3/plant-zambia-bi-variations-v3.pptx
@@ -11,10 +11,9 @@
     <p:sldId id="259" r:id="rId5"/>
     <p:sldId id="260" r:id="rId6"/>
     <p:sldId id="261" r:id="rId7"/>
-    <p:sldId id="262" r:id="rId8"/>
   </p:sldIdLst>
   <p:notesMasterIdLst>
-    <p:notesMasterId r:id="rId9"/>
+    <p:notesMasterId r:id="rId8"/>
   </p:notesMasterIdLst>
   <p:sldSz cx="9144000" cy="5143500"/>
   <p:notesSz cx="5143500" cy="9144000"/>
@@ -972,94 +971,6 @@
             <a:fld id="{F7021451-1387-4CA6-816F-3879F97B5CBC}" type="slidenum">
               <a:rPr lang="en-US"/>
               <a:t>6</a:t>
-            </a:fld>
-            <a:endParaRPr lang="en-US"/>
-          </a:p>
-        </p:txBody>
-      </p:sp>
-    </p:spTree>
-    <p:extLst>
-      <p:ext uri="{BB962C8B-B14F-4D97-AF65-F5344CB8AC3E}">
-        <p14:creationId xmlns:p14="http://schemas.microsoft.com/office/powerpoint/2010/main" val="1024086991"/>
-      </p:ext>
-    </p:extLst>
-  </p:cSld>
-  <p:clrMapOvr>
-    <a:masterClrMapping/>
-  </p:clrMapOvr>
-</p:notes>
-</file>
-
-<file path=ppt/notesSlides/notesSlide7.xml><?xml version="1.0" encoding="utf-8"?>
-<p:notes xmlns:a="http://schemas.openxmlformats.org/drawingml/2006/main" xmlns:r="http://schemas.openxmlformats.org/officeDocument/2006/relationships" xmlns:p="http://schemas.openxmlformats.org/presentationml/2006/main">
-  <p:cSld>
-    <p:spTree>
-      <p:nvGrpSpPr>
-        <p:cNvPr id="1" name=""/>
-        <p:cNvGrpSpPr/>
-        <p:nvPr/>
-      </p:nvGrpSpPr>
-      <p:grpSpPr>
-        <a:xfrm>
-          <a:off x="0" y="0"/>
-          <a:ext cx="0" cy="0"/>
-          <a:chOff x="0" y="0"/>
-          <a:chExt cx="0" cy="0"/>
-        </a:xfrm>
-      </p:grpSpPr>
-      <p:sp>
-        <p:nvSpPr>
-          <p:cNvPr id="2" name="Slide Image Placeholder 1"/>
-          <p:cNvSpPr>
-            <a:spLocks noGrp="1" noRot="1" noChangeAspect="1"/>
-          </p:cNvSpPr>
-          <p:nvPr>
-            <p:ph type="sldImg"/>
-          </p:nvPr>
-        </p:nvSpPr>
-        <p:spPr/>
-      </p:sp>
-      <p:sp>
-        <p:nvSpPr>
-          <p:cNvPr id="3" name="Notes Placeholder 2"/>
-          <p:cNvSpPr>
-            <a:spLocks noGrp="1"/>
-          </p:cNvSpPr>
-          <p:nvPr>
-            <p:ph type="body" idx="1"/>
-          </p:nvPr>
-        </p:nvSpPr>
-        <p:spPr/>
-        <p:txBody>
-          <a:bodyPr/>
-          <a:lstStyle/>
-          <a:p>
-            <a:r>
-              <a:rPr lang="en-US" dirty="0"/>
-              <a:t/>
-            </a:r>
-            <a:endParaRPr lang="en-US" dirty="0"/>
-          </a:p>
-        </p:txBody>
-      </p:sp>
-      <p:sp>
-        <p:nvSpPr>
-          <p:cNvPr id="4" name="Slide Number Placeholder 3"/>
-          <p:cNvSpPr>
-            <a:spLocks noGrp="1"/>
-          </p:cNvSpPr>
-          <p:nvPr>
-            <p:ph type="sldNum" sz="quarter" idx="10"/>
-          </p:nvPr>
-        </p:nvSpPr>
-        <p:spPr/>
-        <p:txBody>
-          <a:bodyPr/>
-          <a:lstStyle/>
-          <a:p>
-            <a:fld id="{F7021451-1387-4CA6-816F-3879F97B5CBC}" type="slidenum">
-              <a:rPr lang="en-US"/>
-              <a:t>7</a:t>
             </a:fld>
             <a:endParaRPr lang="en-US"/>
           </a:p>
@@ -1544,7 +1455,7 @@
                 <a:ea typeface="Pretendard" pitchFamily="34" charset="-122"/>
                 <a:cs typeface="Pretendard" pitchFamily="34" charset="-120"/>
               </a:rPr>
-              <a:t>(사)산과자연의친구 · 2026. 10 · v3 (피드백 반영 3안)</a:t>
+              <a:t>(사)산과자연의친구 · 2026. 10 · v3 (피드백 반영 2안)</a:t>
             </a:r>
             <a:endParaRPr lang="en-US" sz="1100" dirty="0"/>
           </a:p>
@@ -2098,7 +2009,7 @@
                 <a:ea typeface="Pretendard" pitchFamily="34" charset="-122"/>
                 <a:cs typeface="Pretendard" pitchFamily="34" charset="-120"/>
               </a:rPr>
-              <a:t>3가지 안을 만들어 나중에 택일</a:t>
+              <a:t>2가지 안을 만들어 나중에 택일</a:t>
             </a:r>
             <a:endParaRPr lang="en-US" sz="1300" dirty="0"/>
           </a:p>
@@ -2230,8 +2141,8 @@
         </p:blipFill>
         <p:spPr>
           <a:xfrm>
-            <a:off x="457200" y="1188720"/>
-            <a:ext cx="2560320" cy="2560320"/>
+            <a:off x="1188720" y="1097280"/>
+            <a:ext cx="2743200" cy="2743200"/>
           </a:xfrm>
           <a:prstGeom prst="rect">
             <a:avLst/>
@@ -2246,8 +2157,8 @@
         </p:nvSpPr>
         <p:spPr>
           <a:xfrm>
-            <a:off x="457200" y="3840480"/>
-            <a:ext cx="2560320" cy="320040"/>
+            <a:off x="1188720" y="3977640"/>
+            <a:ext cx="2743200" cy="320040"/>
           </a:xfrm>
           <a:prstGeom prst="rect">
             <a:avLst/>
@@ -2293,8 +2204,8 @@
         </p:blipFill>
         <p:spPr>
           <a:xfrm>
-            <a:off x="3291840" y="1188720"/>
-            <a:ext cx="2560320" cy="2560320"/>
+            <a:off x="5029200" y="1097280"/>
+            <a:ext cx="2743200" cy="2743200"/>
           </a:xfrm>
           <a:prstGeom prst="rect">
             <a:avLst/>
@@ -2309,8 +2220,8 @@
         </p:nvSpPr>
         <p:spPr>
           <a:xfrm>
-            <a:off x="3291840" y="3840480"/>
-            <a:ext cx="2560320" cy="320040"/>
+            <a:off x="5029200" y="3977640"/>
+            <a:ext cx="2743200" cy="320040"/>
           </a:xfrm>
           <a:prstGeom prst="rect">
             <a:avLst/>
@@ -2340,78 +2251,15 @@
           </a:p>
         </p:txBody>
       </p:sp>
-      <p:pic>
-        <p:nvPicPr>
-          <p:cNvPr id="8" name="overview 3" descr="/tmp/claude-0/-home-user-otterlee/54e04198-701a-58c9-b487-eea2ac6d4846/scratchpad/out7/3_green.png">    </p:cNvPr>
-          <p:cNvPicPr>
-            <a:picLocks noChangeAspect="1"/>
-          </p:cNvPicPr>
-          <p:nvPr/>
-        </p:nvPicPr>
-        <p:blipFill>
-          <a:blip r:embed="rId3"/>
-          <a:stretch>
-            <a:fillRect/>
-          </a:stretch>
-        </p:blipFill>
-        <p:spPr>
-          <a:xfrm>
-            <a:off x="6126480" y="1188720"/>
-            <a:ext cx="2560320" cy="2560320"/>
-          </a:xfrm>
-          <a:prstGeom prst="rect">
-            <a:avLst/>
-          </a:prstGeom>
-        </p:spPr>
-      </p:pic>
-      <p:sp>
-        <p:nvSpPr>
-          <p:cNvPr id="9" name="Text 4"/>
+      <p:sp>
+        <p:nvSpPr>
+          <p:cNvPr id="8" name="Text 4"/>
           <p:cNvSpPr txBox="1"/>
           <p:nvPr/>
         </p:nvSpPr>
         <p:spPr>
           <a:xfrm>
-            <a:off x="6126480" y="3840480"/>
-            <a:ext cx="2560320" cy="320040"/>
-          </a:xfrm>
-          <a:prstGeom prst="rect">
-            <a:avLst/>
-          </a:prstGeom>
-          <a:noFill/>
-          <a:ln/>
-        </p:spPr>
-        <p:txBody>
-          <a:bodyPr wrap="square" lIns="0" tIns="0" rIns="0" bIns="0" rtlCol="0" anchor="ctr"/>
-          <a:lstStyle/>
-          <a:p>
-            <a:pPr indent="0" marL="0">
-              <a:buNone/>
-            </a:pPr>
-            <a:r>
-              <a:rPr lang="en-US" sz="1200" b="1" dirty="0">
-                <a:solidFill>
-                  <a:srgbClr val="16211C"/>
-                </a:solidFill>
-                <a:latin typeface="Pretendard" pitchFamily="34" charset="0"/>
-                <a:ea typeface="Pretendard" pitchFamily="34" charset="-122"/>
-                <a:cs typeface="Pretendard" pitchFamily="34" charset="-120"/>
-              </a:rPr>
-              <a:t>3안  지문</a:t>
-            </a:r>
-            <a:endParaRPr lang="en-US" sz="1200" dirty="0"/>
-          </a:p>
-        </p:txBody>
-      </p:sp>
-      <p:sp>
-        <p:nvSpPr>
-          <p:cNvPr id="10" name="Text 5"/>
-          <p:cNvSpPr txBox="1"/>
-          <p:nvPr/>
-        </p:nvSpPr>
-        <p:spPr>
-          <a:xfrm>
-            <a:off x="457200" y="4389120"/>
+            <a:off x="457200" y="4480560"/>
             <a:ext cx="8229600" cy="274320"/>
           </a:xfrm>
           <a:prstGeom prst="rect">
@@ -2436,7 +2284,7 @@
                 <a:ea typeface="Pretendard" pitchFamily="34" charset="-122"/>
                 <a:cs typeface="Pretendard" pitchFamily="34" charset="-120"/>
               </a:rPr>
-              <a:t>1안은 최초안, 2안은 점을 풀어낸 안, 3안은 둥근 지문 무늬로 바꾼 안입니다.</a:t>
+              <a:t>1안은 최초안, 2안은 점을 풀어낸 안입니다.</a:t>
             </a:r>
             <a:endParaRPr lang="en-US" sz="1200" dirty="0"/>
           </a:p>
@@ -3171,365 +3019,6 @@
 <file path=ppt/slides/slide6.xml><?xml version="1.0" encoding="utf-8"?>
 <p:sld xmlns:a="http://schemas.openxmlformats.org/drawingml/2006/main" xmlns:r="http://schemas.openxmlformats.org/officeDocument/2006/relationships" xmlns:p="http://schemas.openxmlformats.org/presentationml/2006/main">
   <p:cSld name="Slide 6">
-    <p:bg>
-      <p:bgPr>
-        <a:solidFill>
-          <a:srgbClr val="FFFFFF"/>
-        </a:solidFill>
-      </p:bgPr>
-    </p:bg>
-    <p:spTree>
-      <p:nvGrpSpPr>
-        <p:cNvPr id="1" name=""/>
-        <p:cNvGrpSpPr/>
-        <p:nvPr/>
-      </p:nvGrpSpPr>
-      <p:grpSpPr>
-        <a:xfrm>
-          <a:off x="0" y="0"/>
-          <a:ext cx="0" cy="0"/>
-          <a:chOff x="0" y="0"/>
-          <a:chExt cx="0" cy="0"/>
-        </a:xfrm>
-      </p:grpSpPr>
-      <p:sp>
-        <p:nvSpPr>
-          <p:cNvPr id="2" name="Text 0"/>
-          <p:cNvSpPr txBox="1"/>
-          <p:nvPr/>
-        </p:nvSpPr>
-        <p:spPr>
-          <a:xfrm>
-            <a:off x="457200" y="292608"/>
-            <a:ext cx="8229600" cy="457200"/>
-          </a:xfrm>
-          <a:prstGeom prst="rect">
-            <a:avLst/>
-          </a:prstGeom>
-          <a:noFill/>
-          <a:ln/>
-        </p:spPr>
-        <p:txBody>
-          <a:bodyPr wrap="square" lIns="0" tIns="0" rIns="0" bIns="0" rtlCol="0" anchor="ctr"/>
-          <a:lstStyle/>
-          <a:p>
-            <a:pPr indent="0" marL="0">
-              <a:buNone/>
-            </a:pPr>
-            <a:r>
-              <a:rPr lang="en-US" sz="2000" b="1" dirty="0">
-                <a:solidFill>
-                  <a:srgbClr val="16211C"/>
-                </a:solidFill>
-                <a:latin typeface="Pretendard" pitchFamily="34" charset="0"/>
-                <a:ea typeface="Pretendard" pitchFamily="34" charset="-122"/>
-                <a:cs typeface="Pretendard" pitchFamily="34" charset="-120"/>
-              </a:rPr>
-              <a:t>3안  지문</a:t>
-            </a:r>
-            <a:endParaRPr lang="en-US" sz="2000" dirty="0"/>
-          </a:p>
-        </p:txBody>
-      </p:sp>
-      <p:sp>
-        <p:nvSpPr>
-          <p:cNvPr id="3" name="Text 1"/>
-          <p:cNvSpPr txBox="1"/>
-          <p:nvPr/>
-        </p:nvSpPr>
-        <p:spPr>
-          <a:xfrm>
-            <a:off x="457200" y="731520"/>
-            <a:ext cx="8229600" cy="274320"/>
-          </a:xfrm>
-          <a:prstGeom prst="rect">
-            <a:avLst/>
-          </a:prstGeom>
-          <a:noFill/>
-          <a:ln/>
-        </p:spPr>
-        <p:txBody>
-          <a:bodyPr wrap="square" lIns="0" tIns="0" rIns="0" bIns="0" rtlCol="0" anchor="ctr"/>
-          <a:lstStyle/>
-          <a:p>
-            <a:pPr indent="0" marL="0">
-              <a:buNone/>
-            </a:pPr>
-            <a:r>
-              <a:rPr lang="en-US" sz="1200" dirty="0">
-                <a:solidFill>
-                  <a:srgbClr val="6B7A72"/>
-                </a:solidFill>
-                <a:latin typeface="Pretendard" pitchFamily="34" charset="0"/>
-                <a:ea typeface="Pretendard" pitchFamily="34" charset="-122"/>
-                <a:cs typeface="Pretendard" pitchFamily="34" charset="-120"/>
-              </a:rPr>
-              <a:t>엄지 지문처럼 동글동글한 소용돌이 무늬. 점이 동심원으로 돌고, 아래로 줄기가 내려옵니다.</a:t>
-            </a:r>
-            <a:endParaRPr lang="en-US" sz="1200" dirty="0"/>
-          </a:p>
-        </p:txBody>
-      </p:sp>
-      <p:pic>
-        <p:nvPicPr>
-          <p:cNvPr id="4" name="3 green" descr="/tmp/claude-0/-home-user-otterlee/54e04198-701a-58c9-b487-eea2ac6d4846/scratchpad/out7/3_green.png">    </p:cNvPr>
-          <p:cNvPicPr>
-            <a:picLocks noChangeAspect="1"/>
-          </p:cNvPicPr>
-          <p:nvPr/>
-        </p:nvPicPr>
-        <p:blipFill>
-          <a:blip r:embed="rId1"/>
-          <a:stretch>
-            <a:fillRect/>
-          </a:stretch>
-        </p:blipFill>
-        <p:spPr>
-          <a:xfrm>
-            <a:off x="457200" y="1188720"/>
-            <a:ext cx="2926080" cy="2926080"/>
-          </a:xfrm>
-          <a:prstGeom prst="rect">
-            <a:avLst/>
-          </a:prstGeom>
-        </p:spPr>
-      </p:pic>
-      <p:pic>
-        <p:nvPicPr>
-          <p:cNvPr id="5" name="3 white" descr="/tmp/claude-0/-home-user-otterlee/54e04198-701a-58c9-b487-eea2ac6d4846/scratchpad/out7/3_white.png">    </p:cNvPr>
-          <p:cNvPicPr>
-            <a:picLocks noChangeAspect="1"/>
-          </p:cNvPicPr>
-          <p:nvPr/>
-        </p:nvPicPr>
-        <p:blipFill>
-          <a:blip r:embed="rId2"/>
-          <a:stretch>
-            <a:fillRect/>
-          </a:stretch>
-        </p:blipFill>
-        <p:spPr>
-          <a:xfrm>
-            <a:off x="3566160" y="1188720"/>
-            <a:ext cx="1463040" cy="1463040"/>
-          </a:xfrm>
-          <a:prstGeom prst="rect">
-            <a:avLst/>
-          </a:prstGeom>
-        </p:spPr>
-      </p:pic>
-      <p:pic>
-        <p:nvPicPr>
-          <p:cNvPr id="6" name="3 lockup" descr="/tmp/claude-0/-home-user-otterlee/54e04198-701a-58c9-b487-eea2ac6d4846/scratchpad/out7/3_lockup.png">    </p:cNvPr>
-          <p:cNvPicPr>
-            <a:picLocks noChangeAspect="1"/>
-          </p:cNvPicPr>
-          <p:nvPr/>
-        </p:nvPicPr>
-        <p:blipFill>
-          <a:blip r:embed="rId3"/>
-          <a:stretch>
-            <a:fillRect/>
-          </a:stretch>
-        </p:blipFill>
-        <p:spPr>
-          <a:xfrm>
-            <a:off x="5212080" y="1188720"/>
-            <a:ext cx="3474720" cy="1411834"/>
-          </a:xfrm>
-          <a:prstGeom prst="rect">
-            <a:avLst/>
-          </a:prstGeom>
-        </p:spPr>
-      </p:pic>
-      <p:pic>
-        <p:nvPicPr>
-          <p:cNvPr id="7" name="3 size0" descr="/tmp/claude-0/-home-user-otterlee/54e04198-701a-58c9-b487-eea2ac6d4846/scratchpad/out7/3_white.png">    </p:cNvPr>
-          <p:cNvPicPr>
-            <a:picLocks noChangeAspect="1"/>
-          </p:cNvPicPr>
-          <p:nvPr/>
-        </p:nvPicPr>
-        <p:blipFill>
-          <a:blip r:embed="rId4"/>
-          <a:stretch>
-            <a:fillRect/>
-          </a:stretch>
-        </p:blipFill>
-        <p:spPr>
-          <a:xfrm>
-            <a:off x="3566160" y="3063240"/>
-            <a:ext cx="274320" cy="274320"/>
-          </a:xfrm>
-          <a:prstGeom prst="rect">
-            <a:avLst/>
-          </a:prstGeom>
-        </p:spPr>
-      </p:pic>
-      <p:pic>
-        <p:nvPicPr>
-          <p:cNvPr id="8" name="3 size1" descr="/tmp/claude-0/-home-user-otterlee/54e04198-701a-58c9-b487-eea2ac6d4846/scratchpad/out7/3_white.png">    </p:cNvPr>
-          <p:cNvPicPr>
-            <a:picLocks noChangeAspect="1"/>
-          </p:cNvPicPr>
-          <p:nvPr/>
-        </p:nvPicPr>
-        <p:blipFill>
-          <a:blip r:embed="rId5"/>
-          <a:stretch>
-            <a:fillRect/>
-          </a:stretch>
-        </p:blipFill>
-        <p:spPr>
-          <a:xfrm>
-            <a:off x="3977640" y="2994660"/>
-            <a:ext cx="411480" cy="411480"/>
-          </a:xfrm>
-          <a:prstGeom prst="rect">
-            <a:avLst/>
-          </a:prstGeom>
-        </p:spPr>
-      </p:pic>
-      <p:pic>
-        <p:nvPicPr>
-          <p:cNvPr id="9" name="3 size2" descr="/tmp/claude-0/-home-user-otterlee/54e04198-701a-58c9-b487-eea2ac6d4846/scratchpad/out7/3_white.png">    </p:cNvPr>
-          <p:cNvPicPr>
-            <a:picLocks noChangeAspect="1"/>
-          </p:cNvPicPr>
-          <p:nvPr/>
-        </p:nvPicPr>
-        <p:blipFill>
-          <a:blip r:embed="rId6"/>
-          <a:stretch>
-            <a:fillRect/>
-          </a:stretch>
-        </p:blipFill>
-        <p:spPr>
-          <a:xfrm>
-            <a:off x="4480560" y="2880360"/>
-            <a:ext cx="640080" cy="640080"/>
-          </a:xfrm>
-          <a:prstGeom prst="rect">
-            <a:avLst/>
-          </a:prstGeom>
-        </p:spPr>
-      </p:pic>
-      <p:sp>
-        <p:nvSpPr>
-          <p:cNvPr id="10" name="Text 2"/>
-          <p:cNvSpPr txBox="1"/>
-          <p:nvPr/>
-        </p:nvSpPr>
-        <p:spPr>
-          <a:xfrm>
-            <a:off x="3566160" y="3840480"/>
-            <a:ext cx="1645920" cy="228600"/>
-          </a:xfrm>
-          <a:prstGeom prst="rect">
-            <a:avLst/>
-          </a:prstGeom>
-          <a:noFill/>
-          <a:ln/>
-        </p:spPr>
-        <p:txBody>
-          <a:bodyPr wrap="square" lIns="0" tIns="0" rIns="0" bIns="0" rtlCol="0" anchor="ctr"/>
-          <a:lstStyle/>
-          <a:p>
-            <a:pPr indent="0" marL="0">
-              <a:buNone/>
-            </a:pPr>
-            <a:r>
-              <a:rPr lang="en-US" sz="1000" dirty="0">
-                <a:solidFill>
-                  <a:srgbClr val="6B7A72"/>
-                </a:solidFill>
-                <a:latin typeface="Pretendard" pitchFamily="34" charset="0"/>
-                <a:ea typeface="Pretendard" pitchFamily="34" charset="-122"/>
-                <a:cs typeface="Pretendard" pitchFamily="34" charset="-120"/>
-              </a:rPr>
-              <a:t>축소 확인</a:t>
-            </a:r>
-            <a:endParaRPr lang="en-US" sz="1000" dirty="0"/>
-          </a:p>
-        </p:txBody>
-      </p:sp>
-      <p:sp>
-        <p:nvSpPr>
-          <p:cNvPr id="11" name="note card"/>
-          <p:cNvSpPr/>
-          <p:nvPr/>
-        </p:nvSpPr>
-        <p:spPr>
-          <a:xfrm>
-            <a:off x="5212080" y="2880360"/>
-            <a:ext cx="3474720" cy="1234440"/>
-          </a:xfrm>
-          <a:prstGeom prst="roundRect">
-            <a:avLst>
-              <a:gd name="adj" fmla="val 5926"/>
-            </a:avLst>
-          </a:prstGeom>
-          <a:solidFill>
-            <a:srgbClr val="EAF7EE"/>
-          </a:solidFill>
-          <a:ln w="12700">
-            <a:solidFill>
-              <a:srgbClr val="EAF7EE"/>
-            </a:solidFill>
-            <a:prstDash val="solid"/>
-          </a:ln>
-        </p:spPr>
-      </p:sp>
-      <p:sp>
-        <p:nvSpPr>
-          <p:cNvPr id="12" name="Text 4"/>
-          <p:cNvSpPr txBox="1"/>
-          <p:nvPr/>
-        </p:nvSpPr>
-        <p:spPr>
-          <a:xfrm>
-            <a:off x="5394960" y="2880360"/>
-            <a:ext cx="3108960" cy="1234440"/>
-          </a:xfrm>
-          <a:prstGeom prst="rect">
-            <a:avLst/>
-          </a:prstGeom>
-          <a:noFill/>
-          <a:ln/>
-        </p:spPr>
-        <p:txBody>
-          <a:bodyPr wrap="square" lIns="0" tIns="0" rIns="0" bIns="0" rtlCol="0" anchor="ctr"/>
-          <a:lstStyle/>
-          <a:p>
-            <a:pPr indent="0" marL="0">
-              <a:buNone/>
-            </a:pPr>
-            <a:r>
-              <a:rPr lang="en-US" sz="1300" dirty="0">
-                <a:solidFill>
-                  <a:srgbClr val="16211C"/>
-                </a:solidFill>
-                <a:latin typeface="Pretendard" pitchFamily="34" charset="0"/>
-                <a:ea typeface="Pretendard" pitchFamily="34" charset="-122"/>
-                <a:cs typeface="Pretendard" pitchFamily="34" charset="-120"/>
-              </a:rPr>
-              <a:t>점 하나가 사람 한 명, 지문은 그 사람의 흔적입니다. 점 70개 안팎이라 작게 쓸 때 확인이 필요합니다.</a:t>
-            </a:r>
-            <a:endParaRPr lang="en-US" sz="1300" dirty="0"/>
-          </a:p>
-        </p:txBody>
-      </p:sp>
-    </p:spTree>
-  </p:cSld>
-  <p:clrMapOvr>
-    <a:masterClrMapping/>
-  </p:clrMapOvr>
-</p:sld>
-</file>
-
-<file path=ppt/slides/slide7.xml><?xml version="1.0" encoding="utf-8"?>
-<p:sld xmlns:a="http://schemas.openxmlformats.org/drawingml/2006/main" xmlns:r="http://schemas.openxmlformats.org/officeDocument/2006/relationships" xmlns:p="http://schemas.openxmlformats.org/presentationml/2006/main">
-  <p:cSld name="Slide 7">
     <p:bg>
       <p:bgPr>
         <a:solidFill>

</xml_diff>